<commit_message>
Updated days 1 to 5
</commit_message>
<xml_diff>
--- a/slides/day 1/D1C1_LR_NNs.pptx
+++ b/slides/day 1/D1C1_LR_NNs.pptx
@@ -5,42 +5,46 @@
     <p:sldMasterId id="2147483648" r:id="rId1"/>
   </p:sldMasterIdLst>
   <p:notesMasterIdLst>
-    <p:notesMasterId r:id="rId35"/>
+    <p:notesMasterId r:id="rId39"/>
   </p:notesMasterIdLst>
   <p:sldIdLst>
     <p:sldId id="256" r:id="rId2"/>
     <p:sldId id="258" r:id="rId3"/>
-    <p:sldId id="288" r:id="rId4"/>
-    <p:sldId id="317" r:id="rId5"/>
-    <p:sldId id="289" r:id="rId6"/>
-    <p:sldId id="259" r:id="rId7"/>
-    <p:sldId id="260" r:id="rId8"/>
-    <p:sldId id="314" r:id="rId9"/>
-    <p:sldId id="315" r:id="rId10"/>
-    <p:sldId id="266" r:id="rId11"/>
-    <p:sldId id="261" r:id="rId12"/>
-    <p:sldId id="292" r:id="rId13"/>
-    <p:sldId id="262" r:id="rId14"/>
-    <p:sldId id="294" r:id="rId15"/>
-    <p:sldId id="295" r:id="rId16"/>
-    <p:sldId id="296" r:id="rId17"/>
-    <p:sldId id="297" r:id="rId18"/>
-    <p:sldId id="298" r:id="rId19"/>
-    <p:sldId id="299" r:id="rId20"/>
-    <p:sldId id="300" r:id="rId21"/>
-    <p:sldId id="301" r:id="rId22"/>
-    <p:sldId id="302" r:id="rId23"/>
-    <p:sldId id="303" r:id="rId24"/>
-    <p:sldId id="304" r:id="rId25"/>
-    <p:sldId id="318" r:id="rId26"/>
-    <p:sldId id="305" r:id="rId27"/>
-    <p:sldId id="306" r:id="rId28"/>
-    <p:sldId id="308" r:id="rId29"/>
-    <p:sldId id="309" r:id="rId30"/>
-    <p:sldId id="310" r:id="rId31"/>
-    <p:sldId id="311" r:id="rId32"/>
-    <p:sldId id="312" r:id="rId33"/>
-    <p:sldId id="285" r:id="rId34"/>
+    <p:sldId id="319" r:id="rId4"/>
+    <p:sldId id="320" r:id="rId5"/>
+    <p:sldId id="288" r:id="rId6"/>
+    <p:sldId id="317" r:id="rId7"/>
+    <p:sldId id="289" r:id="rId8"/>
+    <p:sldId id="259" r:id="rId9"/>
+    <p:sldId id="260" r:id="rId10"/>
+    <p:sldId id="314" r:id="rId11"/>
+    <p:sldId id="315" r:id="rId12"/>
+    <p:sldId id="266" r:id="rId13"/>
+    <p:sldId id="261" r:id="rId14"/>
+    <p:sldId id="292" r:id="rId15"/>
+    <p:sldId id="262" r:id="rId16"/>
+    <p:sldId id="294" r:id="rId17"/>
+    <p:sldId id="295" r:id="rId18"/>
+    <p:sldId id="296" r:id="rId19"/>
+    <p:sldId id="297" r:id="rId20"/>
+    <p:sldId id="298" r:id="rId21"/>
+    <p:sldId id="299" r:id="rId22"/>
+    <p:sldId id="300" r:id="rId23"/>
+    <p:sldId id="301" r:id="rId24"/>
+    <p:sldId id="302" r:id="rId25"/>
+    <p:sldId id="303" r:id="rId26"/>
+    <p:sldId id="321" r:id="rId27"/>
+    <p:sldId id="322" r:id="rId28"/>
+    <p:sldId id="304" r:id="rId29"/>
+    <p:sldId id="318" r:id="rId30"/>
+    <p:sldId id="305" r:id="rId31"/>
+    <p:sldId id="306" r:id="rId32"/>
+    <p:sldId id="308" r:id="rId33"/>
+    <p:sldId id="309" r:id="rId34"/>
+    <p:sldId id="310" r:id="rId35"/>
+    <p:sldId id="311" r:id="rId36"/>
+    <p:sldId id="312" r:id="rId37"/>
+    <p:sldId id="285" r:id="rId38"/>
   </p:sldIdLst>
   <p:sldSz cx="12192000" cy="6858000"/>
   <p:notesSz cx="6858000" cy="9144000"/>
@@ -3522,7 +3526,7 @@
           <a:p>
             <a:fld id="{FF5685EE-3D40-0A4E-BB88-46887330FC0A}" type="datetimeFigureOut">
               <a:rPr lang="en-US" smtClean="0"/>
-              <a:t>2/8/26</a:t>
+              <a:t>2/15/26</a:t>
             </a:fld>
             <a:endParaRPr lang="en-US"/>
           </a:p>
@@ -3834,7 +3838,18 @@
           <a:bodyPr/>
           <a:lstStyle/>
           <a:p>
-            <a:endParaRPr lang="en-US"/>
+            <a:r>
+              <a:rPr lang="en-US"/>
+              <a:t>Do not modify the notes in this section to avoid tampering with the Poll Everywhere activity.
+More info at polleverywhere.com/support
+How would you rate your Python skills?</a:t>
+            </a:r>
+          </a:p>
+          <a:p>
+            <a:r>
+              <a:rPr lang="en-US"/>
+              <a:t>https://www.polleverywhere.com/multiple_choice_polls/ke0F7V1qXKkGTR3kaJFc2?state=opened&amp;flow=Default&amp;onscreen=persist</a:t>
+            </a:r>
           </a:p>
         </p:txBody>
       </p:sp>
@@ -3853,9 +3868,188 @@
           <a:bodyPr/>
           <a:lstStyle/>
           <a:p>
+            <a:fld id="{30752F2A-FA59-1746-ABA5-28C394E5ED08}" type="slidenum">
+              <a:rPr lang="en-US" smtClean="0"/>
+              <a:t>3</a:t>
+            </a:fld>
+            <a:endParaRPr lang="en-US"/>
+          </a:p>
+        </p:txBody>
+      </p:sp>
+    </p:spTree>
+    <p:extLst>
+      <p:ext uri="{BB962C8B-B14F-4D97-AF65-F5344CB8AC3E}">
+        <p14:creationId xmlns:p14="http://schemas.microsoft.com/office/powerpoint/2010/main" val="914578412"/>
+      </p:ext>
+    </p:extLst>
+  </p:cSld>
+  <p:clrMapOvr>
+    <a:masterClrMapping/>
+  </p:clrMapOvr>
+</p:notes>
+</file>
+
+<file path=ppt/notesSlides/notesSlide2.xml><?xml version="1.0" encoding="utf-8"?>
+<p:notes xmlns:a="http://schemas.openxmlformats.org/drawingml/2006/main" xmlns:r="http://schemas.openxmlformats.org/officeDocument/2006/relationships" xmlns:p="http://schemas.openxmlformats.org/presentationml/2006/main">
+  <p:cSld>
+    <p:spTree>
+      <p:nvGrpSpPr>
+        <p:cNvPr id="1" name=""/>
+        <p:cNvGrpSpPr/>
+        <p:nvPr/>
+      </p:nvGrpSpPr>
+      <p:grpSpPr>
+        <a:xfrm>
+          <a:off x="0" y="0"/>
+          <a:ext cx="0" cy="0"/>
+          <a:chOff x="0" y="0"/>
+          <a:chExt cx="0" cy="0"/>
+        </a:xfrm>
+      </p:grpSpPr>
+      <p:sp>
+        <p:nvSpPr>
+          <p:cNvPr id="2" name="Slide Image Placeholder 1"/>
+          <p:cNvSpPr>
+            <a:spLocks noGrp="1" noRot="1" noChangeAspect="1"/>
+          </p:cNvSpPr>
+          <p:nvPr>
+            <p:ph type="sldImg"/>
+          </p:nvPr>
+        </p:nvSpPr>
+        <p:spPr/>
+      </p:sp>
+      <p:sp>
+        <p:nvSpPr>
+          <p:cNvPr id="3" name="Notes Placeholder 2"/>
+          <p:cNvSpPr>
+            <a:spLocks noGrp="1"/>
+          </p:cNvSpPr>
+          <p:nvPr>
+            <p:ph type="body" idx="1"/>
+          </p:nvPr>
+        </p:nvSpPr>
+        <p:spPr/>
+        <p:txBody>
+          <a:bodyPr/>
+          <a:lstStyle/>
+          <a:p>
+            <a:r>
+              <a:rPr lang="en-US"/>
+              <a:t>Do not modify the notes in this section to avoid tampering with the Poll Everywhere activity.
+More info at polleverywhere.com/support
+How would you rate your Machine Learning / AI skills?</a:t>
+            </a:r>
+          </a:p>
+          <a:p>
+            <a:r>
+              <a:rPr lang="en-US"/>
+              <a:t>https://www.polleverywhere.com/multiple_choice_polls/hWsbco8TWVs02D6zeGQK2?state=opened&amp;flow=Default&amp;onscreen=persist</a:t>
+            </a:r>
+          </a:p>
+        </p:txBody>
+      </p:sp>
+      <p:sp>
+        <p:nvSpPr>
+          <p:cNvPr id="4" name="Slide Number Placeholder 3"/>
+          <p:cNvSpPr>
+            <a:spLocks noGrp="1"/>
+          </p:cNvSpPr>
+          <p:nvPr>
+            <p:ph type="sldNum" sz="quarter" idx="5"/>
+          </p:nvPr>
+        </p:nvSpPr>
+        <p:spPr/>
+        <p:txBody>
+          <a:bodyPr/>
+          <a:lstStyle/>
+          <a:p>
+            <a:fld id="{30752F2A-FA59-1746-ABA5-28C394E5ED08}" type="slidenum">
+              <a:rPr lang="en-US" smtClean="0"/>
+              <a:t>4</a:t>
+            </a:fld>
+            <a:endParaRPr lang="en-US"/>
+          </a:p>
+        </p:txBody>
+      </p:sp>
+    </p:spTree>
+    <p:extLst>
+      <p:ext uri="{BB962C8B-B14F-4D97-AF65-F5344CB8AC3E}">
+        <p14:creationId xmlns:p14="http://schemas.microsoft.com/office/powerpoint/2010/main" val="1842467295"/>
+      </p:ext>
+    </p:extLst>
+  </p:cSld>
+  <p:clrMapOvr>
+    <a:masterClrMapping/>
+  </p:clrMapOvr>
+</p:notes>
+</file>
+
+<file path=ppt/notesSlides/notesSlide3.xml><?xml version="1.0" encoding="utf-8"?>
+<p:notes xmlns:a="http://schemas.openxmlformats.org/drawingml/2006/main" xmlns:r="http://schemas.openxmlformats.org/officeDocument/2006/relationships" xmlns:p="http://schemas.openxmlformats.org/presentationml/2006/main">
+  <p:cSld>
+    <p:spTree>
+      <p:nvGrpSpPr>
+        <p:cNvPr id="1" name=""/>
+        <p:cNvGrpSpPr/>
+        <p:nvPr/>
+      </p:nvGrpSpPr>
+      <p:grpSpPr>
+        <a:xfrm>
+          <a:off x="0" y="0"/>
+          <a:ext cx="0" cy="0"/>
+          <a:chOff x="0" y="0"/>
+          <a:chExt cx="0" cy="0"/>
+        </a:xfrm>
+      </p:grpSpPr>
+      <p:sp>
+        <p:nvSpPr>
+          <p:cNvPr id="2" name="Slide Image Placeholder 1"/>
+          <p:cNvSpPr>
+            <a:spLocks noGrp="1" noRot="1" noChangeAspect="1"/>
+          </p:cNvSpPr>
+          <p:nvPr>
+            <p:ph type="sldImg"/>
+          </p:nvPr>
+        </p:nvSpPr>
+        <p:spPr/>
+      </p:sp>
+      <p:sp>
+        <p:nvSpPr>
+          <p:cNvPr id="3" name="Notes Placeholder 2"/>
+          <p:cNvSpPr>
+            <a:spLocks noGrp="1"/>
+          </p:cNvSpPr>
+          <p:nvPr>
+            <p:ph type="body" idx="1"/>
+          </p:nvPr>
+        </p:nvSpPr>
+        <p:spPr/>
+        <p:txBody>
+          <a:bodyPr/>
+          <a:lstStyle/>
+          <a:p>
+            <a:endParaRPr lang="en-US"/>
+          </a:p>
+        </p:txBody>
+      </p:sp>
+      <p:sp>
+        <p:nvSpPr>
+          <p:cNvPr id="4" name="Slide Number Placeholder 3"/>
+          <p:cNvSpPr>
+            <a:spLocks noGrp="1"/>
+          </p:cNvSpPr>
+          <p:nvPr>
+            <p:ph type="sldNum" sz="quarter" idx="5"/>
+          </p:nvPr>
+        </p:nvSpPr>
+        <p:spPr/>
+        <p:txBody>
+          <a:bodyPr/>
+          <a:lstStyle/>
+          <a:p>
             <a:fld id="{D516AF13-2809-9544-9651-1E9FCBB11C9A}" type="slidenum">
               <a:rPr lang="en-US" smtClean="0"/>
-              <a:t>7</a:t>
+              <a:t>9</a:t>
             </a:fld>
             <a:endParaRPr lang="en-US"/>
           </a:p>
@@ -3865,6 +4059,448 @@
     <p:extLst>
       <p:ext uri="{BB962C8B-B14F-4D97-AF65-F5344CB8AC3E}">
         <p14:creationId xmlns:p14="http://schemas.microsoft.com/office/powerpoint/2010/main" val="2254202341"/>
+      </p:ext>
+    </p:extLst>
+  </p:cSld>
+  <p:clrMapOvr>
+    <a:masterClrMapping/>
+  </p:clrMapOvr>
+</p:notes>
+</file>
+
+<file path=ppt/notesSlides/notesSlide4.xml><?xml version="1.0" encoding="utf-8"?>
+<p:notes xmlns:a="http://schemas.openxmlformats.org/drawingml/2006/main" xmlns:r="http://schemas.openxmlformats.org/officeDocument/2006/relationships" xmlns:p="http://schemas.openxmlformats.org/presentationml/2006/main">
+  <p:cSld>
+    <p:spTree>
+      <p:nvGrpSpPr>
+        <p:cNvPr id="1" name=""/>
+        <p:cNvGrpSpPr/>
+        <p:nvPr/>
+      </p:nvGrpSpPr>
+      <p:grpSpPr>
+        <a:xfrm>
+          <a:off x="0" y="0"/>
+          <a:ext cx="0" cy="0"/>
+          <a:chOff x="0" y="0"/>
+          <a:chExt cx="0" cy="0"/>
+        </a:xfrm>
+      </p:grpSpPr>
+      <p:sp>
+        <p:nvSpPr>
+          <p:cNvPr id="2" name="Slide Image Placeholder 1"/>
+          <p:cNvSpPr>
+            <a:spLocks noGrp="1" noRot="1" noChangeAspect="1"/>
+          </p:cNvSpPr>
+          <p:nvPr>
+            <p:ph type="sldImg"/>
+          </p:nvPr>
+        </p:nvSpPr>
+        <p:spPr/>
+      </p:sp>
+      <p:sp>
+        <p:nvSpPr>
+          <p:cNvPr id="3" name="Notes Placeholder 2"/>
+          <p:cNvSpPr>
+            <a:spLocks noGrp="1"/>
+          </p:cNvSpPr>
+          <p:nvPr>
+            <p:ph type="body" idx="1"/>
+          </p:nvPr>
+        </p:nvSpPr>
+        <p:spPr/>
+        <p:txBody>
+          <a:bodyPr/>
+          <a:lstStyle/>
+          <a:p>
+            <a:endParaRPr lang="en-US"/>
+          </a:p>
+        </p:txBody>
+      </p:sp>
+      <p:sp>
+        <p:nvSpPr>
+          <p:cNvPr id="4" name="Slide Number Placeholder 3"/>
+          <p:cNvSpPr>
+            <a:spLocks noGrp="1"/>
+          </p:cNvSpPr>
+          <p:nvPr>
+            <p:ph type="sldNum" sz="quarter" idx="5"/>
+          </p:nvPr>
+        </p:nvSpPr>
+        <p:spPr/>
+        <p:txBody>
+          <a:bodyPr/>
+          <a:lstStyle/>
+          <a:p>
+            <a:fld id="{30752F2A-FA59-1746-ABA5-28C394E5ED08}" type="slidenum">
+              <a:rPr lang="en-US" smtClean="0"/>
+              <a:t>25</a:t>
+            </a:fld>
+            <a:endParaRPr lang="en-US"/>
+          </a:p>
+        </p:txBody>
+      </p:sp>
+    </p:spTree>
+    <p:extLst>
+      <p:ext uri="{BB962C8B-B14F-4D97-AF65-F5344CB8AC3E}">
+        <p14:creationId xmlns:p14="http://schemas.microsoft.com/office/powerpoint/2010/main" val="19367326"/>
+      </p:ext>
+    </p:extLst>
+  </p:cSld>
+  <p:clrMapOvr>
+    <a:masterClrMapping/>
+  </p:clrMapOvr>
+</p:notes>
+</file>
+
+<file path=ppt/notesSlides/notesSlide5.xml><?xml version="1.0" encoding="utf-8"?>
+<p:notes xmlns:a="http://schemas.openxmlformats.org/drawingml/2006/main" xmlns:r="http://schemas.openxmlformats.org/officeDocument/2006/relationships" xmlns:p="http://schemas.openxmlformats.org/presentationml/2006/main">
+  <p:cSld>
+    <p:spTree>
+      <p:nvGrpSpPr>
+        <p:cNvPr id="1" name=""/>
+        <p:cNvGrpSpPr/>
+        <p:nvPr/>
+      </p:nvGrpSpPr>
+      <p:grpSpPr>
+        <a:xfrm>
+          <a:off x="0" y="0"/>
+          <a:ext cx="0" cy="0"/>
+          <a:chOff x="0" y="0"/>
+          <a:chExt cx="0" cy="0"/>
+        </a:xfrm>
+      </p:grpSpPr>
+      <p:sp>
+        <p:nvSpPr>
+          <p:cNvPr id="2" name="Slide Image Placeholder 1"/>
+          <p:cNvSpPr>
+            <a:spLocks noGrp="1" noRot="1" noChangeAspect="1"/>
+          </p:cNvSpPr>
+          <p:nvPr>
+            <p:ph type="sldImg"/>
+          </p:nvPr>
+        </p:nvSpPr>
+        <p:spPr/>
+      </p:sp>
+      <p:sp>
+        <p:nvSpPr>
+          <p:cNvPr id="3" name="Notes Placeholder 2"/>
+          <p:cNvSpPr>
+            <a:spLocks noGrp="1"/>
+          </p:cNvSpPr>
+          <p:nvPr>
+            <p:ph type="body" idx="1"/>
+          </p:nvPr>
+        </p:nvSpPr>
+        <p:spPr/>
+        <p:txBody>
+          <a:bodyPr/>
+          <a:lstStyle/>
+          <a:p>
+            <a:r>
+              <a:rPr lang="en-US"/>
+              <a:t>Do not modify the notes in this section to avoid tampering with the Poll Everywhere activity.
+More info at polleverywhere.com/support
+Imagine a 2D contour plot of the Loss Surface with weight (w) and bias (b) as axes. If the current parameters are on a very steep part of the surface, what does this tell us about the gradients?</a:t>
+            </a:r>
+          </a:p>
+          <a:p>
+            <a:r>
+              <a:rPr lang="en-US"/>
+              <a:t>https://www.polleverywhere.com/multiple_choice_polls/Nl64SB8F6W7j9Limp1MDf?state=opened&amp;flow=Default&amp;onscreen=persist</a:t>
+            </a:r>
+          </a:p>
+        </p:txBody>
+      </p:sp>
+      <p:sp>
+        <p:nvSpPr>
+          <p:cNvPr id="4" name="Slide Number Placeholder 3"/>
+          <p:cNvSpPr>
+            <a:spLocks noGrp="1"/>
+          </p:cNvSpPr>
+          <p:nvPr>
+            <p:ph type="sldNum" sz="quarter" idx="5"/>
+          </p:nvPr>
+        </p:nvSpPr>
+        <p:spPr/>
+        <p:txBody>
+          <a:bodyPr/>
+          <a:lstStyle/>
+          <a:p>
+            <a:fld id="{30752F2A-FA59-1746-ABA5-28C394E5ED08}" type="slidenum">
+              <a:rPr lang="en-US" smtClean="0"/>
+              <a:t>26</a:t>
+            </a:fld>
+            <a:endParaRPr lang="en-US"/>
+          </a:p>
+        </p:txBody>
+      </p:sp>
+    </p:spTree>
+    <p:extLst>
+      <p:ext uri="{BB962C8B-B14F-4D97-AF65-F5344CB8AC3E}">
+        <p14:creationId xmlns:p14="http://schemas.microsoft.com/office/powerpoint/2010/main" val="3727355394"/>
+      </p:ext>
+    </p:extLst>
+  </p:cSld>
+  <p:clrMapOvr>
+    <a:masterClrMapping/>
+  </p:clrMapOvr>
+</p:notes>
+</file>
+
+<file path=ppt/notesSlides/notesSlide6.xml><?xml version="1.0" encoding="utf-8"?>
+<p:notes xmlns:a="http://schemas.openxmlformats.org/drawingml/2006/main" xmlns:r="http://schemas.openxmlformats.org/officeDocument/2006/relationships" xmlns:p="http://schemas.openxmlformats.org/presentationml/2006/main">
+  <p:cSld>
+    <p:spTree>
+      <p:nvGrpSpPr>
+        <p:cNvPr id="1" name=""/>
+        <p:cNvGrpSpPr/>
+        <p:nvPr/>
+      </p:nvGrpSpPr>
+      <p:grpSpPr>
+        <a:xfrm>
+          <a:off x="0" y="0"/>
+          <a:ext cx="0" cy="0"/>
+          <a:chOff x="0" y="0"/>
+          <a:chExt cx="0" cy="0"/>
+        </a:xfrm>
+      </p:grpSpPr>
+      <p:sp>
+        <p:nvSpPr>
+          <p:cNvPr id="2" name="Slide Image Placeholder 1"/>
+          <p:cNvSpPr>
+            <a:spLocks noGrp="1" noRot="1" noChangeAspect="1"/>
+          </p:cNvSpPr>
+          <p:nvPr>
+            <p:ph type="sldImg"/>
+          </p:nvPr>
+        </p:nvSpPr>
+        <p:spPr/>
+      </p:sp>
+      <p:sp>
+        <p:nvSpPr>
+          <p:cNvPr id="3" name="Notes Placeholder 2"/>
+          <p:cNvSpPr>
+            <a:spLocks noGrp="1"/>
+          </p:cNvSpPr>
+          <p:nvPr>
+            <p:ph type="body" idx="1"/>
+          </p:nvPr>
+        </p:nvSpPr>
+        <p:spPr/>
+        <p:txBody>
+          <a:bodyPr/>
+          <a:lstStyle/>
+          <a:p>
+            <a:r>
+              <a:rPr lang="en-US" dirty="0"/>
+              <a:t>Do not modify the notes in this section to avoid tampering with the Poll Everywhere activity.
+More info at </a:t>
+            </a:r>
+            <a:r>
+              <a:rPr lang="en-US" dirty="0" err="1"/>
+              <a:t>polleverywhere.com</a:t>
+            </a:r>
+            <a:r>
+              <a:rPr lang="en-US" dirty="0"/>
+              <a:t>/support
+Current weight w = 2.0 and bias b = 4.0. The gradients are dL/</a:t>
+            </a:r>
+            <a:r>
+              <a:rPr lang="en-US" dirty="0" err="1"/>
+              <a:t>dw</a:t>
+            </a:r>
+            <a:r>
+              <a:rPr lang="en-US" dirty="0"/>
+              <a:t> = 0.5 and dL/</a:t>
+            </a:r>
+            <a:r>
+              <a:rPr lang="en-US" dirty="0" err="1"/>
+              <a:t>db</a:t>
+            </a:r>
+            <a:r>
+              <a:rPr lang="en-US" dirty="0"/>
+              <a:t> = -1.0. If the learning rate is 0.1, what are the new values for w and b after one gradient descent step?</a:t>
+            </a:r>
+          </a:p>
+          <a:p>
+            <a:r>
+              <a:rPr lang="en-US" dirty="0"/>
+              <a:t>https://</a:t>
+            </a:r>
+            <a:r>
+              <a:rPr lang="en-US" dirty="0" err="1"/>
+              <a:t>www.polleverywhere.com</a:t>
+            </a:r>
+            <a:r>
+              <a:rPr lang="en-US" dirty="0"/>
+              <a:t>/</a:t>
+            </a:r>
+            <a:r>
+              <a:rPr lang="en-US" dirty="0" err="1"/>
+              <a:t>multiple_choice_polls</a:t>
+            </a:r>
+            <a:r>
+              <a:rPr lang="en-US" dirty="0"/>
+              <a:t>/OrixocTkLIB9GXI5DFJxH?state=</a:t>
+            </a:r>
+            <a:r>
+              <a:rPr lang="en-US" dirty="0" err="1"/>
+              <a:t>opened&amp;flow</a:t>
+            </a:r>
+            <a:r>
+              <a:rPr lang="en-US" dirty="0"/>
+              <a:t>=</a:t>
+            </a:r>
+            <a:r>
+              <a:rPr lang="en-US" dirty="0" err="1"/>
+              <a:t>Default&amp;onscreen</a:t>
+            </a:r>
+            <a:r>
+              <a:rPr lang="en-US" dirty="0"/>
+              <a:t>=persist</a:t>
+            </a:r>
+          </a:p>
+        </p:txBody>
+      </p:sp>
+      <p:sp>
+        <p:nvSpPr>
+          <p:cNvPr id="4" name="Slide Number Placeholder 3"/>
+          <p:cNvSpPr>
+            <a:spLocks noGrp="1"/>
+          </p:cNvSpPr>
+          <p:nvPr>
+            <p:ph type="sldNum" sz="quarter" idx="5"/>
+          </p:nvPr>
+        </p:nvSpPr>
+        <p:spPr/>
+        <p:txBody>
+          <a:bodyPr/>
+          <a:lstStyle/>
+          <a:p>
+            <a:fld id="{30752F2A-FA59-1746-ABA5-28C394E5ED08}" type="slidenum">
+              <a:rPr lang="en-US" smtClean="0"/>
+              <a:t>27</a:t>
+            </a:fld>
+            <a:endParaRPr lang="en-US"/>
+          </a:p>
+        </p:txBody>
+      </p:sp>
+    </p:spTree>
+    <p:extLst>
+      <p:ext uri="{BB962C8B-B14F-4D97-AF65-F5344CB8AC3E}">
+        <p14:creationId xmlns:p14="http://schemas.microsoft.com/office/powerpoint/2010/main" val="3995923508"/>
+      </p:ext>
+    </p:extLst>
+  </p:cSld>
+  <p:clrMapOvr>
+    <a:masterClrMapping/>
+  </p:clrMapOvr>
+</p:notes>
+</file>
+
+<file path=ppt/notesSlides/notesSlide7.xml><?xml version="1.0" encoding="utf-8"?>
+<p:notes xmlns:a="http://schemas.openxmlformats.org/drawingml/2006/main" xmlns:r="http://schemas.openxmlformats.org/officeDocument/2006/relationships" xmlns:p="http://schemas.openxmlformats.org/presentationml/2006/main">
+  <p:cSld>
+    <p:spTree>
+      <p:nvGrpSpPr>
+        <p:cNvPr id="1" name=""/>
+        <p:cNvGrpSpPr/>
+        <p:nvPr/>
+      </p:nvGrpSpPr>
+      <p:grpSpPr>
+        <a:xfrm>
+          <a:off x="0" y="0"/>
+          <a:ext cx="0" cy="0"/>
+          <a:chOff x="0" y="0"/>
+          <a:chExt cx="0" cy="0"/>
+        </a:xfrm>
+      </p:grpSpPr>
+      <p:sp>
+        <p:nvSpPr>
+          <p:cNvPr id="2" name="Slide Image Placeholder 1"/>
+          <p:cNvSpPr>
+            <a:spLocks noGrp="1" noRot="1" noChangeAspect="1"/>
+          </p:cNvSpPr>
+          <p:nvPr>
+            <p:ph type="sldImg"/>
+          </p:nvPr>
+        </p:nvSpPr>
+        <p:spPr/>
+      </p:sp>
+      <p:sp>
+        <p:nvSpPr>
+          <p:cNvPr id="3" name="Notes Placeholder 2"/>
+          <p:cNvSpPr>
+            <a:spLocks noGrp="1"/>
+          </p:cNvSpPr>
+          <p:nvPr>
+            <p:ph type="body" idx="1"/>
+          </p:nvPr>
+        </p:nvSpPr>
+        <p:spPr/>
+        <p:txBody>
+          <a:bodyPr/>
+          <a:lstStyle/>
+          <a:p>
+            <a:r>
+              <a:rPr lang="en-IE" sz="1200" kern="1200" dirty="0">
+                <a:solidFill>
+                  <a:schemeClr val="tx1"/>
+                </a:solidFill>
+                <a:effectLst/>
+                <a:latin typeface="+mn-lt"/>
+                <a:ea typeface="+mn-ea"/>
+                <a:cs typeface="+mn-cs"/>
+              </a:rPr>
+              <a:t>$w_{new} = 2.0 - (0.1 \times 0.5) = 1.95$</a:t>
+            </a:r>
+          </a:p>
+          <a:p>
+            <a:r>
+              <a:rPr lang="en-IE" sz="1200" kern="1200" dirty="0">
+                <a:solidFill>
+                  <a:schemeClr val="tx1"/>
+                </a:solidFill>
+                <a:effectLst/>
+                <a:latin typeface="+mn-lt"/>
+                <a:ea typeface="+mn-ea"/>
+                <a:cs typeface="+mn-cs"/>
+              </a:rPr>
+              <a:t>$b_{new} = 4.0 - (0.1 \times -1.0) = 4.1$</a:t>
+            </a:r>
+          </a:p>
+          <a:p>
+            <a:endParaRPr lang="en-US" dirty="0"/>
+          </a:p>
+        </p:txBody>
+      </p:sp>
+      <p:sp>
+        <p:nvSpPr>
+          <p:cNvPr id="4" name="Slide Number Placeholder 3"/>
+          <p:cNvSpPr>
+            <a:spLocks noGrp="1"/>
+          </p:cNvSpPr>
+          <p:nvPr>
+            <p:ph type="sldNum" sz="quarter" idx="5"/>
+          </p:nvPr>
+        </p:nvSpPr>
+        <p:spPr/>
+        <p:txBody>
+          <a:bodyPr/>
+          <a:lstStyle/>
+          <a:p>
+            <a:fld id="{30752F2A-FA59-1746-ABA5-28C394E5ED08}" type="slidenum">
+              <a:rPr lang="en-US" smtClean="0"/>
+              <a:t>28</a:t>
+            </a:fld>
+            <a:endParaRPr lang="en-US"/>
+          </a:p>
+        </p:txBody>
+      </p:sp>
+    </p:spTree>
+    <p:extLst>
+      <p:ext uri="{BB962C8B-B14F-4D97-AF65-F5344CB8AC3E}">
+        <p14:creationId xmlns:p14="http://schemas.microsoft.com/office/powerpoint/2010/main" val="3218316299"/>
       </p:ext>
     </p:extLst>
   </p:cSld>
@@ -4067,7 +4703,7 @@
             <a:fld id="{16F2FB5F-D553-C945-B874-A642CC0C851F}" type="datetime3">
               <a:rPr lang="en-IE" smtClean="0"/>
               <a:pPr/>
-              <a:t>8 February 2026</a:t>
+              <a:t>15 February 2026</a:t>
             </a:fld>
             <a:endParaRPr lang="en-US" dirty="0"/>
           </a:p>
@@ -5384,7 +6020,7 @@
           <a:p>
             <a:fld id="{D724839B-90DF-FA46-9D52-D10060A86ADB}" type="datetime3">
               <a:rPr lang="en-IE" smtClean="0"/>
-              <a:t>8 February 2026</a:t>
+              <a:t>15 February 2026</a:t>
             </a:fld>
             <a:endParaRPr lang="en-US"/>
           </a:p>
@@ -5673,7 +6309,7 @@
           <a:p>
             <a:fld id="{D3F12174-D4B7-E74D-A582-5C71C550CABE}" type="datetime3">
               <a:rPr lang="en-IE" smtClean="0"/>
-              <a:t>8 February 2026</a:t>
+              <a:t>15 February 2026</a:t>
             </a:fld>
             <a:endParaRPr lang="en-US"/>
           </a:p>
@@ -6128,7 +6764,7 @@
             <a:fld id="{16F2FB5F-D553-C945-B874-A642CC0C851F}" type="datetime3">
               <a:rPr lang="en-IE" smtClean="0"/>
               <a:pPr/>
-              <a:t>8 February 2026</a:t>
+              <a:t>15 February 2026</a:t>
             </a:fld>
             <a:endParaRPr lang="en-US" dirty="0"/>
           </a:p>
@@ -6340,7 +6976,7 @@
             <a:fld id="{16F2FB5F-D553-C945-B874-A642CC0C851F}" type="datetime3">
               <a:rPr lang="en-IE" smtClean="0"/>
               <a:pPr/>
-              <a:t>8 February 2026</a:t>
+              <a:t>15 February 2026</a:t>
             </a:fld>
             <a:endParaRPr lang="en-US" dirty="0"/>
           </a:p>
@@ -6737,7 +7373,7 @@
           <a:p>
             <a:fld id="{07196900-CA2A-2D43-9641-C5C0DD2D22D3}" type="datetime3">
               <a:rPr lang="en-IE" smtClean="0"/>
-              <a:t>8 February 2026</a:t>
+              <a:t>15 February 2026</a:t>
             </a:fld>
             <a:endParaRPr lang="en-US"/>
           </a:p>
@@ -7005,7 +7641,7 @@
           <a:p>
             <a:fld id="{8AB1A910-F8E0-D541-83F2-2CFD6E718762}" type="datetime3">
               <a:rPr lang="en-IE" smtClean="0"/>
-              <a:t>8 February 2026</a:t>
+              <a:t>15 February 2026</a:t>
             </a:fld>
             <a:endParaRPr lang="en-US"/>
           </a:p>
@@ -7147,7 +7783,7 @@
           <a:p>
             <a:fld id="{7E245B59-D3F3-5B43-BDD1-6C7B7CFD2AA6}" type="datetime3">
               <a:rPr lang="en-IE" smtClean="0"/>
-              <a:t>8 February 2026</a:t>
+              <a:t>15 February 2026</a:t>
             </a:fld>
             <a:endParaRPr lang="en-US"/>
           </a:p>
@@ -7260,7 +7896,7 @@
           <a:p>
             <a:fld id="{AD77DDCF-3644-8C44-AE36-2C59F897E125}" type="datetime3">
               <a:rPr lang="en-IE" smtClean="0"/>
-              <a:t>8 February 2026</a:t>
+              <a:t>15 February 2026</a:t>
             </a:fld>
             <a:endParaRPr lang="en-US"/>
           </a:p>
@@ -8331,7 +8967,7 @@
           <a:p>
             <a:fld id="{C1B28D5F-B017-3B47-9775-DA319F6143FF}" type="datetime3">
               <a:rPr lang="en-IE" smtClean="0"/>
-              <a:t>8 February 2026</a:t>
+              <a:t>15 February 2026</a:t>
             </a:fld>
             <a:endParaRPr lang="en-US" dirty="0"/>
           </a:p>
@@ -8854,6 +9490,333 @@
           <p:cNvPr id="2" name="Title 1">
             <a:extLst>
               <a:ext uri="{FF2B5EF4-FFF2-40B4-BE49-F238E27FC236}">
+                <a16:creationId xmlns:a16="http://schemas.microsoft.com/office/drawing/2014/main" id="{5F404B0A-99AF-1B23-9CEF-CC62D701AE52}"/>
+              </a:ext>
+            </a:extLst>
+          </p:cNvPr>
+          <p:cNvSpPr>
+            <a:spLocks noGrp="1"/>
+          </p:cNvSpPr>
+          <p:nvPr>
+            <p:ph type="title"/>
+          </p:nvPr>
+        </p:nvSpPr>
+        <p:spPr/>
+        <p:txBody>
+          <a:bodyPr/>
+          <a:lstStyle/>
+          <a:p>
+            <a:r>
+              <a:rPr lang="en-US" dirty="0"/>
+              <a:t>Syllabus (week 1)</a:t>
+            </a:r>
+          </a:p>
+        </p:txBody>
+      </p:sp>
+      <p:sp>
+        <p:nvSpPr>
+          <p:cNvPr id="3" name="Content Placeholder 2">
+            <a:extLst>
+              <a:ext uri="{FF2B5EF4-FFF2-40B4-BE49-F238E27FC236}">
+                <a16:creationId xmlns:a16="http://schemas.microsoft.com/office/drawing/2014/main" id="{F5DB8611-2EDA-8CDF-8AA2-9AC795A3FB33}"/>
+              </a:ext>
+            </a:extLst>
+          </p:cNvPr>
+          <p:cNvSpPr>
+            <a:spLocks noGrp="1"/>
+          </p:cNvSpPr>
+          <p:nvPr>
+            <p:ph idx="1"/>
+          </p:nvPr>
+        </p:nvSpPr>
+        <p:spPr/>
+        <p:txBody>
+          <a:bodyPr/>
+          <a:lstStyle/>
+          <a:p>
+            <a:r>
+              <a:rPr lang="en-US" dirty="0"/>
+              <a:t>Linear regression and neural networks</a:t>
+            </a:r>
+          </a:p>
+          <a:p>
+            <a:r>
+              <a:rPr lang="en-US" dirty="0"/>
+              <a:t>NNs and back-propagation</a:t>
+            </a:r>
+          </a:p>
+          <a:p>
+            <a:r>
+              <a:rPr lang="en-US" dirty="0"/>
+              <a:t>Deep learning</a:t>
+            </a:r>
+          </a:p>
+          <a:p>
+            <a:r>
+              <a:rPr lang="en-US" dirty="0"/>
+              <a:t>Convolutional NNs</a:t>
+            </a:r>
+          </a:p>
+          <a:p>
+            <a:r>
+              <a:rPr lang="en-US" dirty="0"/>
+              <a:t>Recurrent NNs</a:t>
+            </a:r>
+          </a:p>
+          <a:p>
+            <a:r>
+              <a:rPr lang="en-US" dirty="0"/>
+              <a:t>Transformers</a:t>
+            </a:r>
+          </a:p>
+          <a:p>
+            <a:r>
+              <a:rPr lang="en-US" dirty="0"/>
+              <a:t>Graph NNs</a:t>
+            </a:r>
+          </a:p>
+          <a:p>
+            <a:r>
+              <a:rPr lang="en-US" dirty="0"/>
+              <a:t>Probabilistic forecasting with NNs</a:t>
+            </a:r>
+          </a:p>
+        </p:txBody>
+      </p:sp>
+      <p:sp>
+        <p:nvSpPr>
+          <p:cNvPr id="4" name="Slide Number Placeholder 3">
+            <a:extLst>
+              <a:ext uri="{FF2B5EF4-FFF2-40B4-BE49-F238E27FC236}">
+                <a16:creationId xmlns:a16="http://schemas.microsoft.com/office/drawing/2014/main" id="{B6B5E9C3-1976-DACA-3AE2-28F5B2DD6781}"/>
+              </a:ext>
+            </a:extLst>
+          </p:cNvPr>
+          <p:cNvSpPr>
+            <a:spLocks noGrp="1"/>
+          </p:cNvSpPr>
+          <p:nvPr>
+            <p:ph type="sldNum" sz="quarter" idx="12"/>
+          </p:nvPr>
+        </p:nvSpPr>
+        <p:spPr/>
+        <p:txBody>
+          <a:bodyPr/>
+          <a:lstStyle/>
+          <a:p>
+            <a:fld id="{8E65201D-48DB-3B45-ABC2-018B1E66F34C}" type="slidenum">
+              <a:rPr lang="en-US" smtClean="0"/>
+              <a:t>10</a:t>
+            </a:fld>
+            <a:endParaRPr lang="en-US"/>
+          </a:p>
+        </p:txBody>
+      </p:sp>
+    </p:spTree>
+    <p:extLst>
+      <p:ext uri="{BB962C8B-B14F-4D97-AF65-F5344CB8AC3E}">
+        <p14:creationId xmlns:p14="http://schemas.microsoft.com/office/powerpoint/2010/main" val="4278662269"/>
+      </p:ext>
+    </p:extLst>
+  </p:cSld>
+  <p:clrMapOvr>
+    <a:masterClrMapping/>
+  </p:clrMapOvr>
+</p:sld>
+</file>
+
+<file path=ppt/slides/slide11.xml><?xml version="1.0" encoding="utf-8"?>
+<p:sld xmlns:a="http://schemas.openxmlformats.org/drawingml/2006/main" xmlns:r="http://schemas.openxmlformats.org/officeDocument/2006/relationships" xmlns:p="http://schemas.openxmlformats.org/presentationml/2006/main">
+  <p:cSld>
+    <p:spTree>
+      <p:nvGrpSpPr>
+        <p:cNvPr id="1" name="">
+          <a:extLst>
+            <a:ext uri="{FF2B5EF4-FFF2-40B4-BE49-F238E27FC236}">
+              <a16:creationId xmlns:a16="http://schemas.microsoft.com/office/drawing/2014/main" id="{53911DA0-E8E2-7F7E-C1FA-DA29DD79B2E7}"/>
+            </a:ext>
+          </a:extLst>
+        </p:cNvPr>
+        <p:cNvGrpSpPr/>
+        <p:nvPr/>
+      </p:nvGrpSpPr>
+      <p:grpSpPr>
+        <a:xfrm>
+          <a:off x="0" y="0"/>
+          <a:ext cx="0" cy="0"/>
+          <a:chOff x="0" y="0"/>
+          <a:chExt cx="0" cy="0"/>
+        </a:xfrm>
+      </p:grpSpPr>
+      <p:sp>
+        <p:nvSpPr>
+          <p:cNvPr id="2" name="Title 1">
+            <a:extLst>
+              <a:ext uri="{FF2B5EF4-FFF2-40B4-BE49-F238E27FC236}">
+                <a16:creationId xmlns:a16="http://schemas.microsoft.com/office/drawing/2014/main" id="{D5EB629C-5A78-79DC-8BF5-FA033BE05BFA}"/>
+              </a:ext>
+            </a:extLst>
+          </p:cNvPr>
+          <p:cNvSpPr>
+            <a:spLocks noGrp="1"/>
+          </p:cNvSpPr>
+          <p:nvPr>
+            <p:ph type="title"/>
+          </p:nvPr>
+        </p:nvSpPr>
+        <p:spPr/>
+        <p:txBody>
+          <a:bodyPr/>
+          <a:lstStyle/>
+          <a:p>
+            <a:r>
+              <a:rPr lang="en-US" dirty="0"/>
+              <a:t>Syllabus (week 2)</a:t>
+            </a:r>
+          </a:p>
+        </p:txBody>
+      </p:sp>
+      <p:sp>
+        <p:nvSpPr>
+          <p:cNvPr id="3" name="Content Placeholder 2">
+            <a:extLst>
+              <a:ext uri="{FF2B5EF4-FFF2-40B4-BE49-F238E27FC236}">
+                <a16:creationId xmlns:a16="http://schemas.microsoft.com/office/drawing/2014/main" id="{B771B038-32D6-BA06-2580-C5C6C714DB2F}"/>
+              </a:ext>
+            </a:extLst>
+          </p:cNvPr>
+          <p:cNvSpPr>
+            <a:spLocks noGrp="1"/>
+          </p:cNvSpPr>
+          <p:nvPr>
+            <p:ph idx="1"/>
+          </p:nvPr>
+        </p:nvSpPr>
+        <p:spPr/>
+        <p:txBody>
+          <a:bodyPr/>
+          <a:lstStyle/>
+          <a:p>
+            <a:r>
+              <a:rPr lang="en-US" dirty="0"/>
+              <a:t>Graph Convolutional Neural Networks</a:t>
+            </a:r>
+          </a:p>
+          <a:p>
+            <a:r>
+              <a:rPr lang="en-US" dirty="0"/>
+              <a:t>SERT</a:t>
+            </a:r>
+          </a:p>
+          <a:p>
+            <a:r>
+              <a:rPr lang="en-US" dirty="0"/>
+              <a:t>Overview – data-driven weather forecasting</a:t>
+            </a:r>
+          </a:p>
+          <a:p>
+            <a:r>
+              <a:rPr lang="en-US" dirty="0"/>
+              <a:t>AIFS / Anemoi</a:t>
+            </a:r>
+          </a:p>
+          <a:p>
+            <a:r>
+              <a:rPr lang="en-US" dirty="0"/>
+              <a:t>Other topics (if time):</a:t>
+            </a:r>
+          </a:p>
+          <a:p>
+            <a:pPr lvl="1"/>
+            <a:r>
+              <a:rPr lang="en-US" dirty="0"/>
+              <a:t>Bayesian inference</a:t>
+            </a:r>
+          </a:p>
+          <a:p>
+            <a:pPr lvl="1"/>
+            <a:r>
+              <a:rPr lang="en-US" dirty="0" err="1"/>
+              <a:t>Github</a:t>
+            </a:r>
+            <a:endParaRPr lang="en-US" dirty="0"/>
+          </a:p>
+          <a:p>
+            <a:pPr lvl="1"/>
+            <a:r>
+              <a:rPr lang="en-US" dirty="0"/>
+              <a:t>Overleaf</a:t>
+            </a:r>
+          </a:p>
+          <a:p>
+            <a:endParaRPr lang="en-US" dirty="0"/>
+          </a:p>
+        </p:txBody>
+      </p:sp>
+      <p:sp>
+        <p:nvSpPr>
+          <p:cNvPr id="4" name="Slide Number Placeholder 3">
+            <a:extLst>
+              <a:ext uri="{FF2B5EF4-FFF2-40B4-BE49-F238E27FC236}">
+                <a16:creationId xmlns:a16="http://schemas.microsoft.com/office/drawing/2014/main" id="{F989814A-DE5D-C67D-CB2E-AC4F29717528}"/>
+              </a:ext>
+            </a:extLst>
+          </p:cNvPr>
+          <p:cNvSpPr>
+            <a:spLocks noGrp="1"/>
+          </p:cNvSpPr>
+          <p:nvPr>
+            <p:ph type="sldNum" sz="quarter" idx="12"/>
+          </p:nvPr>
+        </p:nvSpPr>
+        <p:spPr/>
+        <p:txBody>
+          <a:bodyPr/>
+          <a:lstStyle/>
+          <a:p>
+            <a:fld id="{8E65201D-48DB-3B45-ABC2-018B1E66F34C}" type="slidenum">
+              <a:rPr lang="en-US" smtClean="0"/>
+              <a:t>11</a:t>
+            </a:fld>
+            <a:endParaRPr lang="en-US"/>
+          </a:p>
+        </p:txBody>
+      </p:sp>
+    </p:spTree>
+    <p:extLst>
+      <p:ext uri="{BB962C8B-B14F-4D97-AF65-F5344CB8AC3E}">
+        <p14:creationId xmlns:p14="http://schemas.microsoft.com/office/powerpoint/2010/main" val="345519520"/>
+      </p:ext>
+    </p:extLst>
+  </p:cSld>
+  <p:clrMapOvr>
+    <a:masterClrMapping/>
+  </p:clrMapOvr>
+</p:sld>
+</file>
+
+<file path=ppt/slides/slide12.xml><?xml version="1.0" encoding="utf-8"?>
+<p:sld xmlns:a="http://schemas.openxmlformats.org/drawingml/2006/main" xmlns:r="http://schemas.openxmlformats.org/officeDocument/2006/relationships" xmlns:p="http://schemas.openxmlformats.org/presentationml/2006/main">
+  <p:cSld>
+    <p:spTree>
+      <p:nvGrpSpPr>
+        <p:cNvPr id="1" name=""/>
+        <p:cNvGrpSpPr/>
+        <p:nvPr/>
+      </p:nvGrpSpPr>
+      <p:grpSpPr>
+        <a:xfrm>
+          <a:off x="0" y="0"/>
+          <a:ext cx="0" cy="0"/>
+          <a:chOff x="0" y="0"/>
+          <a:chExt cx="0" cy="0"/>
+        </a:xfrm>
+      </p:grpSpPr>
+      <p:sp>
+        <p:nvSpPr>
+          <p:cNvPr id="2" name="Title 1">
+            <a:extLst>
+              <a:ext uri="{FF2B5EF4-FFF2-40B4-BE49-F238E27FC236}">
                 <a16:creationId xmlns:a16="http://schemas.microsoft.com/office/drawing/2014/main" id="{A05A94C2-B4AA-9A48-F920-5D2A76C25058}"/>
               </a:ext>
             </a:extLst>
@@ -8892,7 +9855,7 @@
 </p:sld>
 </file>
 
-<file path=ppt/slides/slide11.xml><?xml version="1.0" encoding="utf-8"?>
+<file path=ppt/slides/slide13.xml><?xml version="1.0" encoding="utf-8"?>
 <p:sld xmlns:a="http://schemas.openxmlformats.org/drawingml/2006/main" xmlns:r="http://schemas.openxmlformats.org/officeDocument/2006/relationships" xmlns:p="http://schemas.openxmlformats.org/presentationml/2006/main">
   <p:cSld>
     <p:spTree>
@@ -9008,7 +9971,7 @@
           <a:p>
             <a:fld id="{8E65201D-48DB-3B45-ABC2-018B1E66F34C}" type="slidenum">
               <a:rPr lang="en-US" smtClean="0"/>
-              <a:t>11</a:t>
+              <a:t>13</a:t>
             </a:fld>
             <a:endParaRPr lang="en-US"/>
           </a:p>
@@ -9027,7 +9990,7 @@
 </p:sld>
 </file>
 
-<file path=ppt/slides/slide12.xml><?xml version="1.0" encoding="utf-8"?>
+<file path=ppt/slides/slide14.xml><?xml version="1.0" encoding="utf-8"?>
 <p:sld xmlns:a="http://schemas.openxmlformats.org/drawingml/2006/main" xmlns:r="http://schemas.openxmlformats.org/officeDocument/2006/relationships" xmlns:p="http://schemas.openxmlformats.org/presentationml/2006/main">
   <p:cSld>
     <p:spTree>
@@ -9050,36 +10013,6 @@
           <a:chExt cx="0" cy="0"/>
         </a:xfrm>
       </p:grpSpPr>
-      <p:pic>
-        <p:nvPicPr>
-          <p:cNvPr id="7" name="Picture 6" descr="A graph with blue dots&#10;&#10;AI-generated content may be incorrect.">
-            <a:extLst>
-              <a:ext uri="{FF2B5EF4-FFF2-40B4-BE49-F238E27FC236}">
-                <a16:creationId xmlns:a16="http://schemas.microsoft.com/office/drawing/2014/main" id="{B703DE0C-9F1D-A591-D2F7-BA1A594FCC87}"/>
-              </a:ext>
-            </a:extLst>
-          </p:cNvPr>
-          <p:cNvPicPr>
-            <a:picLocks noChangeAspect="1"/>
-          </p:cNvPicPr>
-          <p:nvPr/>
-        </p:nvPicPr>
-        <p:blipFill>
-          <a:blip r:embed="rId2"/>
-          <a:stretch>
-            <a:fillRect/>
-          </a:stretch>
-        </p:blipFill>
-        <p:spPr>
-          <a:xfrm>
-            <a:off x="5499313" y="1025912"/>
-            <a:ext cx="6840192" cy="5130144"/>
-          </a:xfrm>
-          <a:prstGeom prst="rect">
-            <a:avLst/>
-          </a:prstGeom>
-        </p:spPr>
-      </p:pic>
       <p:sp>
         <p:nvSpPr>
           <p:cNvPr id="2" name="Title 1">
@@ -9115,8 +10048,8 @@
           </a:p>
         </p:txBody>
       </p:sp>
-      <mc:AlternateContent xmlns:mc="http://schemas.openxmlformats.org/markup-compatibility/2006" xmlns:a14="http://schemas.microsoft.com/office/drawing/2010/main">
-        <mc:Choice Requires="a14">
+      <mc:AlternateContent xmlns:mc="http://schemas.openxmlformats.org/markup-compatibility/2006">
+        <mc:Choice xmlns:a14="http://schemas.microsoft.com/office/drawing/2010/main" Requires="a14">
           <p:sp>
             <p:nvSpPr>
               <p:cNvPr id="3" name="Content Placeholder 2">
@@ -9166,7 +10099,7 @@
                 </a14:m>
                 <a:r>
                   <a:rPr lang="en-US" sz="2200" dirty="0"/>
-                  <a:t> = [16.09, 15.56, 15.85, 15.69, 15.01]</a:t>
+                  <a:t> = [15.54 15.28 15.42 15.84 15.00]</a:t>
                 </a:r>
               </a:p>
               <a:p>
@@ -9185,14 +10118,8 @@
                 </a14:m>
                 <a:r>
                   <a:rPr lang="en-US" sz="2200" dirty="0"/>
-                  <a:t> = [17.62, 14.88, 16.32, 16.28, 14.96]</a:t>
+                  <a:t> = [15.58 15.48 15.67 15.89 15.18]</a:t>
                 </a:r>
-              </a:p>
-              <a:p>
-                <a:pPr marL="0" indent="0">
-                  <a:buNone/>
-                </a:pPr>
-                <a:endParaRPr lang="en-US" sz="2200" dirty="0"/>
               </a:p>
               <a:p>
                 <a14:m>
@@ -9207,7 +10134,7 @@
                 </a14:m>
                 <a:r>
                   <a:rPr lang="en-US" sz="2200" dirty="0"/>
-                  <a:t> = temperature yesterday</a:t>
+                  <a:t> = temperature now</a:t>
                 </a:r>
               </a:p>
               <a:p>
@@ -9223,7 +10150,7 @@
                 </a14:m>
                 <a:r>
                   <a:rPr lang="en-US" sz="2200" dirty="0"/>
-                  <a:t> = temperature today</a:t>
+                  <a:t> = temperature in 6h</a:t>
                 </a:r>
               </a:p>
               <a:p>
@@ -9260,7 +10187,7 @@
             </p:txBody>
           </p:sp>
         </mc:Choice>
-        <mc:Fallback xmlns="">
+        <mc:Fallback>
           <p:sp>
             <p:nvSpPr>
               <p:cNvPr id="3" name="Content Placeholder 2">
@@ -9283,7 +10210,7 @@
                 <a:ext cx="5127702" cy="4149290"/>
               </a:xfrm>
               <a:blipFill>
-                <a:blip r:embed="rId3"/>
+                <a:blip r:embed="rId2"/>
                 <a:stretch>
                   <a:fillRect l="-1485" t="-2141"/>
                 </a:stretch>
@@ -9339,12 +10266,42 @@
                   <a:spcPts val="600"/>
                 </a:spcAft>
               </a:pPr>
-              <a:t>12</a:t>
+              <a:t>14</a:t>
             </a:fld>
             <a:endParaRPr lang="en-US"/>
           </a:p>
         </p:txBody>
       </p:sp>
+      <p:pic>
+        <p:nvPicPr>
+          <p:cNvPr id="6" name="Picture 5">
+            <a:extLst>
+              <a:ext uri="{FF2B5EF4-FFF2-40B4-BE49-F238E27FC236}">
+                <a16:creationId xmlns:a16="http://schemas.microsoft.com/office/drawing/2014/main" id="{5C1C5587-D56C-AF4C-FAB8-82EC2D273C91}"/>
+              </a:ext>
+            </a:extLst>
+          </p:cNvPr>
+          <p:cNvPicPr>
+            <a:picLocks noChangeAspect="1"/>
+          </p:cNvPicPr>
+          <p:nvPr/>
+        </p:nvPicPr>
+        <p:blipFill>
+          <a:blip r:embed="rId3"/>
+          <a:stretch>
+            <a:fillRect/>
+          </a:stretch>
+        </p:blipFill>
+        <p:spPr>
+          <a:xfrm>
+            <a:off x="5448300" y="1134682"/>
+            <a:ext cx="6184900" cy="4874904"/>
+          </a:xfrm>
+          <a:prstGeom prst="rect">
+            <a:avLst/>
+          </a:prstGeom>
+        </p:spPr>
+      </p:pic>
     </p:spTree>
     <p:extLst>
       <p:ext uri="{BB962C8B-B14F-4D97-AF65-F5344CB8AC3E}">
@@ -9358,7 +10315,7 @@
 </p:sld>
 </file>
 
-<file path=ppt/slides/slide13.xml><?xml version="1.0" encoding="utf-8"?>
+<file path=ppt/slides/slide15.xml><?xml version="1.0" encoding="utf-8"?>
 <p:sld xmlns:a="http://schemas.openxmlformats.org/drawingml/2006/main" xmlns:r="http://schemas.openxmlformats.org/officeDocument/2006/relationships" xmlns:p="http://schemas.openxmlformats.org/presentationml/2006/main">
   <p:cSld>
     <p:spTree>
@@ -9424,7 +10381,7 @@
             <p:spPr/>
             <p:txBody>
               <a:bodyPr>
-                <a:normAutofit lnSpcReduction="10000"/>
+                <a:normAutofit fontScale="92500"/>
               </a:bodyPr>
               <a:lstStyle/>
               <a:p>
@@ -9525,21 +10482,39 @@
                 </a14:m>
                 <a:r>
                   <a:rPr lang="en-US" dirty="0"/>
-                  <a:t> are our inputs and </a:t>
+                  <a:t> is our inputs and </a:t>
                 </a:r>
                 <a14:m>
                   <m:oMath xmlns:m="http://schemas.openxmlformats.org/officeDocument/2006/math">
+                    <m:acc>
+                      <m:accPr>
+                        <m:chr m:val="̂"/>
+                        <m:ctrlPr>
+                          <a:rPr lang="en-IE" i="1">
+                            <a:latin typeface="Cambria Math" panose="02040503050406030204" pitchFamily="18" charset="0"/>
+                          </a:rPr>
+                        </m:ctrlPr>
+                      </m:accPr>
+                      <m:e>
+                        <m:r>
+                          <a:rPr lang="en-IE" i="1" smtClean="0">
+                            <a:latin typeface="Cambria Math" panose="02040503050406030204" pitchFamily="18" charset="0"/>
+                          </a:rPr>
+                          <m:t>𝑦</m:t>
+                        </m:r>
+                      </m:e>
+                    </m:acc>
                     <m:r>
-                      <a:rPr lang="en-US" i="1" dirty="0" smtClean="0">
+                      <a:rPr lang="en-IE" b="0" i="1" smtClean="0">
                         <a:latin typeface="Cambria Math" panose="02040503050406030204" pitchFamily="18" charset="0"/>
                       </a:rPr>
-                      <m:t>𝑦</m:t>
+                      <m:t> </m:t>
                     </m:r>
                   </m:oMath>
                 </a14:m>
                 <a:r>
                   <a:rPr lang="en-US" dirty="0"/>
-                  <a:t> are our outputs.</a:t>
+                  <a:t>is our (predicted) outputs.</a:t>
                 </a:r>
               </a:p>
               <a:p>
@@ -9897,7 +10872,7 @@
               <a:blipFill>
                 <a:blip r:embed="rId2"/>
                 <a:stretch>
-                  <a:fillRect l="-1315" t="-3231" r="-219"/>
+                  <a:fillRect l="-1216" t="-2134" b="-13415"/>
                 </a:stretch>
               </a:blipFill>
             </p:spPr>
@@ -9906,7 +10881,7 @@
               <a:lstStyle/>
               <a:p>
                 <a:r>
-                  <a:rPr lang="en-IE">
+                  <a:rPr lang="en-US">
                     <a:noFill/>
                   </a:rPr>
                   <a:t> </a:t>
@@ -9939,7 +10914,7 @@
           <a:p>
             <a:fld id="{8E65201D-48DB-3B45-ABC2-018B1E66F34C}" type="slidenum">
               <a:rPr lang="en-US" smtClean="0"/>
-              <a:t>13</a:t>
+              <a:t>15</a:t>
             </a:fld>
             <a:endParaRPr lang="en-US"/>
           </a:p>
@@ -9958,7 +10933,7 @@
 </p:sld>
 </file>
 
-<file path=ppt/slides/slide14.xml><?xml version="1.0" encoding="utf-8"?>
+<file path=ppt/slides/slide16.xml><?xml version="1.0" encoding="utf-8"?>
 <p:sld xmlns:a="http://schemas.openxmlformats.org/drawingml/2006/main" xmlns:r="http://schemas.openxmlformats.org/officeDocument/2006/relationships" xmlns:p="http://schemas.openxmlformats.org/presentationml/2006/main">
   <p:cSld>
     <p:spTree>
@@ -10025,10 +11000,15 @@
             <p:ph idx="1"/>
           </p:nvPr>
         </p:nvSpPr>
-        <p:spPr/>
+        <p:spPr>
+          <a:xfrm>
+            <a:off x="838200" y="1825625"/>
+            <a:ext cx="10287000" cy="4149290"/>
+          </a:xfrm>
+        </p:spPr>
         <p:txBody>
           <a:bodyPr>
-            <a:normAutofit fontScale="77500" lnSpcReduction="20000"/>
+            <a:normAutofit/>
           </a:bodyPr>
           <a:lstStyle/>
           <a:p>
@@ -10036,11 +11016,11 @@
               <a:buNone/>
             </a:pPr>
             <a:r>
-              <a:rPr lang="en-US" dirty="0">
+              <a:rPr lang="en-US" sz="2400" dirty="0">
                 <a:latin typeface="Courier New" panose="02070309020205020404" pitchFamily="49" charset="0"/>
                 <a:cs typeface="Courier New" panose="02070309020205020404" pitchFamily="49" charset="0"/>
               </a:rPr>
-              <a:t>b = 0</a:t>
+              <a:t>b = 1</a:t>
             </a:r>
           </a:p>
           <a:p>
@@ -10048,11 +11028,11 @@
               <a:buNone/>
             </a:pPr>
             <a:r>
-              <a:rPr lang="en-US" dirty="0">
+              <a:rPr lang="en-US" sz="2400" dirty="0">
                 <a:latin typeface="Courier New" panose="02070309020205020404" pitchFamily="49" charset="0"/>
                 <a:cs typeface="Courier New" panose="02070309020205020404" pitchFamily="49" charset="0"/>
               </a:rPr>
-              <a:t>w = 0.5</a:t>
+              <a:t>w = 1</a:t>
             </a:r>
           </a:p>
           <a:p>
@@ -10060,28 +11040,28 @@
               <a:buNone/>
             </a:pPr>
             <a:r>
-              <a:rPr lang="en-US" dirty="0" err="1">
+              <a:rPr lang="en-US" sz="2400" dirty="0" err="1">
                 <a:latin typeface="Courier New" panose="02070309020205020404" pitchFamily="49" charset="0"/>
                 <a:cs typeface="Courier New" panose="02070309020205020404" pitchFamily="49" charset="0"/>
               </a:rPr>
               <a:t>sum_of_squares</a:t>
             </a:r>
             <a:r>
-              <a:rPr lang="en-US" dirty="0">
+              <a:rPr lang="en-US" sz="2400" dirty="0">
                 <a:latin typeface="Courier New" panose="02070309020205020404" pitchFamily="49" charset="0"/>
                 <a:cs typeface="Courier New" panose="02070309020205020404" pitchFamily="49" charset="0"/>
               </a:rPr>
               <a:t> = </a:t>
             </a:r>
             <a:r>
-              <a:rPr lang="en-US" dirty="0" err="1">
+              <a:rPr lang="en-US" sz="2400" dirty="0" err="1">
                 <a:latin typeface="Courier New" panose="02070309020205020404" pitchFamily="49" charset="0"/>
                 <a:cs typeface="Courier New" panose="02070309020205020404" pitchFamily="49" charset="0"/>
               </a:rPr>
               <a:t>np.sum</a:t>
             </a:r>
             <a:r>
-              <a:rPr lang="en-US" dirty="0">
+              <a:rPr lang="en-US" sz="2400" dirty="0">
                 <a:latin typeface="Courier New" panose="02070309020205020404" pitchFamily="49" charset="0"/>
                 <a:cs typeface="Courier New" panose="02070309020205020404" pitchFamily="49" charset="0"/>
               </a:rPr>
@@ -10093,58 +11073,44 @@
               <a:buNone/>
             </a:pPr>
             <a:r>
-              <a:rPr lang="en-US" dirty="0">
+              <a:rPr lang="en-US" sz="2400" b="1" dirty="0">
                 <a:latin typeface="Courier New" panose="02070309020205020404" pitchFamily="49" charset="0"/>
                 <a:cs typeface="Courier New" panose="02070309020205020404" pitchFamily="49" charset="0"/>
               </a:rPr>
-              <a:t>print(</a:t>
-            </a:r>
-            <a:r>
-              <a:rPr lang="en-US" dirty="0" err="1">
-                <a:latin typeface="Courier New" panose="02070309020205020404" pitchFamily="49" charset="0"/>
-                <a:cs typeface="Courier New" panose="02070309020205020404" pitchFamily="49" charset="0"/>
-              </a:rPr>
-              <a:t>sum_of_squares</a:t>
-            </a:r>
-            <a:r>
-              <a:rPr lang="en-US" dirty="0">
-                <a:latin typeface="Courier New" panose="02070309020205020404" pitchFamily="49" charset="0"/>
-                <a:cs typeface="Courier New" panose="02070309020205020404" pitchFamily="49" charset="0"/>
-              </a:rPr>
-              <a:t>)</a:t>
+              <a:t># Residual sum of squares for b=1, w=1: 3.74</a:t>
             </a:r>
           </a:p>
           <a:p>
             <a:pPr marL="0" indent="0">
               <a:buNone/>
             </a:pPr>
-            <a:r>
-              <a:rPr lang="en-US" b="1" dirty="0">
-                <a:latin typeface="Courier New" panose="02070309020205020404" pitchFamily="49" charset="0"/>
-                <a:cs typeface="Courier New" panose="02070309020205020404" pitchFamily="49" charset="0"/>
-              </a:rPr>
-              <a:t># Residual sum of squares for b=0, w=0.5: 339.3</a:t>
-            </a:r>
+            <a:endParaRPr lang="en-US" sz="2400" dirty="0">
+              <a:latin typeface="Courier New" panose="02070309020205020404" pitchFamily="49" charset="0"/>
+              <a:cs typeface="Courier New" panose="02070309020205020404" pitchFamily="49" charset="0"/>
+            </a:endParaRPr>
           </a:p>
           <a:p>
             <a:pPr marL="0" indent="0">
               <a:buNone/>
             </a:pPr>
-            <a:endParaRPr lang="en-US" dirty="0">
-              <a:latin typeface="Courier New" panose="02070309020205020404" pitchFamily="49" charset="0"/>
-              <a:cs typeface="Courier New" panose="02070309020205020404" pitchFamily="49" charset="0"/>
-            </a:endParaRPr>
+            <a:r>
+              <a:rPr lang="en-US" sz="2400" dirty="0">
+                <a:latin typeface="Courier New" panose="02070309020205020404" pitchFamily="49" charset="0"/>
+                <a:cs typeface="Courier New" panose="02070309020205020404" pitchFamily="49" charset="0"/>
+              </a:rPr>
+              <a:t>b = 5</a:t>
+            </a:r>
           </a:p>
           <a:p>
             <a:pPr marL="0" indent="0">
               <a:buNone/>
             </a:pPr>
             <a:r>
-              <a:rPr lang="en-US" dirty="0">
+              <a:rPr lang="en-US" sz="2400" dirty="0">
                 <a:latin typeface="Courier New" panose="02070309020205020404" pitchFamily="49" charset="0"/>
                 <a:cs typeface="Courier New" panose="02070309020205020404" pitchFamily="49" charset="0"/>
               </a:rPr>
-              <a:t>b = 1</a:t>
+              <a:t>w = 0.5</a:t>
             </a:r>
           </a:p>
           <a:p>
@@ -10152,11 +11118,32 @@
               <a:buNone/>
             </a:pPr>
             <a:r>
-              <a:rPr lang="en-US" dirty="0">
+              <a:rPr lang="en-US" sz="2400" dirty="0" err="1">
                 <a:latin typeface="Courier New" panose="02070309020205020404" pitchFamily="49" charset="0"/>
                 <a:cs typeface="Courier New" panose="02070309020205020404" pitchFamily="49" charset="0"/>
               </a:rPr>
-              <a:t>w = 1</a:t>
+              <a:t>sum_of_squares</a:t>
+            </a:r>
+            <a:r>
+              <a:rPr lang="en-US" sz="2400" dirty="0">
+                <a:latin typeface="Courier New" panose="02070309020205020404" pitchFamily="49" charset="0"/>
+                <a:cs typeface="Courier New" panose="02070309020205020404" pitchFamily="49" charset="0"/>
+              </a:rPr>
+              <a:t> = </a:t>
+            </a:r>
+            <a:r>
+              <a:rPr lang="en-US" sz="2400" dirty="0" err="1">
+                <a:latin typeface="Courier New" panose="02070309020205020404" pitchFamily="49" charset="0"/>
+                <a:cs typeface="Courier New" panose="02070309020205020404" pitchFamily="49" charset="0"/>
+              </a:rPr>
+              <a:t>np.sum</a:t>
+            </a:r>
+            <a:r>
+              <a:rPr lang="en-US" sz="2400" dirty="0">
+                <a:latin typeface="Courier New" panose="02070309020205020404" pitchFamily="49" charset="0"/>
+                <a:cs typeface="Courier New" panose="02070309020205020404" pitchFamily="49" charset="0"/>
+              </a:rPr>
+              <a:t>((y - (b + w * X)) ** 2)</a:t>
             </a:r>
           </a:p>
           <a:p>
@@ -10164,70 +11151,11 @@
               <a:buNone/>
             </a:pPr>
             <a:r>
-              <a:rPr lang="en-US" dirty="0" err="1">
+              <a:rPr lang="en-US" sz="2400" b="1" dirty="0">
                 <a:latin typeface="Courier New" panose="02070309020205020404" pitchFamily="49" charset="0"/>
                 <a:cs typeface="Courier New" panose="02070309020205020404" pitchFamily="49" charset="0"/>
               </a:rPr>
-              <a:t>sum_of_squares</a:t>
-            </a:r>
-            <a:r>
-              <a:rPr lang="en-US" dirty="0">
-                <a:latin typeface="Courier New" panose="02070309020205020404" pitchFamily="49" charset="0"/>
-                <a:cs typeface="Courier New" panose="02070309020205020404" pitchFamily="49" charset="0"/>
-              </a:rPr>
-              <a:t> = </a:t>
-            </a:r>
-            <a:r>
-              <a:rPr lang="en-US" dirty="0" err="1">
-                <a:latin typeface="Courier New" panose="02070309020205020404" pitchFamily="49" charset="0"/>
-                <a:cs typeface="Courier New" panose="02070309020205020404" pitchFamily="49" charset="0"/>
-              </a:rPr>
-              <a:t>np.sum</a:t>
-            </a:r>
-            <a:r>
-              <a:rPr lang="en-US" dirty="0">
-                <a:latin typeface="Courier New" panose="02070309020205020404" pitchFamily="49" charset="0"/>
-                <a:cs typeface="Courier New" panose="02070309020205020404" pitchFamily="49" charset="0"/>
-              </a:rPr>
-              <a:t>((y - (b + w * X)) ** 2)</a:t>
-            </a:r>
-          </a:p>
-          <a:p>
-            <a:pPr marL="0" indent="0">
-              <a:buNone/>
-            </a:pPr>
-            <a:r>
-              <a:rPr lang="en-US" dirty="0">
-                <a:latin typeface="Courier New" panose="02070309020205020404" pitchFamily="49" charset="0"/>
-                <a:cs typeface="Courier New" panose="02070309020205020404" pitchFamily="49" charset="0"/>
-              </a:rPr>
-              <a:t>print(</a:t>
-            </a:r>
-            <a:r>
-              <a:rPr lang="en-US" dirty="0" err="1">
-                <a:latin typeface="Courier New" panose="02070309020205020404" pitchFamily="49" charset="0"/>
-                <a:cs typeface="Courier New" panose="02070309020205020404" pitchFamily="49" charset="0"/>
-              </a:rPr>
-              <a:t>sum_of_squares</a:t>
-            </a:r>
-            <a:r>
-              <a:rPr lang="en-US" dirty="0">
-                <a:latin typeface="Courier New" panose="02070309020205020404" pitchFamily="49" charset="0"/>
-                <a:cs typeface="Courier New" panose="02070309020205020404" pitchFamily="49" charset="0"/>
-              </a:rPr>
-              <a:t>)</a:t>
-            </a:r>
-          </a:p>
-          <a:p>
-            <a:pPr marL="0" indent="0">
-              <a:buNone/>
-            </a:pPr>
-            <a:r>
-              <a:rPr lang="en-US" b="1" dirty="0">
-                <a:latin typeface="Courier New" panose="02070309020205020404" pitchFamily="49" charset="0"/>
-                <a:cs typeface="Courier New" panose="02070309020205020404" pitchFamily="49" charset="0"/>
-              </a:rPr>
-              <a:t># Residual sum of squares for b=1, w=1: 4.6</a:t>
+              <a:t>Residual sum of squares for b=5, w=0.5: 40.65</a:t>
             </a:r>
           </a:p>
         </p:txBody>
@@ -10255,7 +11183,7 @@
           <a:p>
             <a:fld id="{8E65201D-48DB-3B45-ABC2-018B1E66F34C}" type="slidenum">
               <a:rPr lang="en-US" smtClean="0"/>
-              <a:t>14</a:t>
+              <a:t>16</a:t>
             </a:fld>
             <a:endParaRPr lang="en-US"/>
           </a:p>
@@ -10274,7 +11202,7 @@
 </p:sld>
 </file>
 
-<file path=ppt/slides/slide15.xml><?xml version="1.0" encoding="utf-8"?>
+<file path=ppt/slides/slide17.xml><?xml version="1.0" encoding="utf-8"?>
 <p:sld xmlns:a="http://schemas.openxmlformats.org/drawingml/2006/main" xmlns:r="http://schemas.openxmlformats.org/officeDocument/2006/relationships" xmlns:p="http://schemas.openxmlformats.org/presentationml/2006/main">
   <p:cSld>
     <p:spTree>
@@ -10325,8 +11253,8 @@
           </a:p>
         </p:txBody>
       </p:sp>
-      <mc:AlternateContent xmlns:mc="http://schemas.openxmlformats.org/markup-compatibility/2006">
-        <mc:Choice xmlns:a14="http://schemas.microsoft.com/office/drawing/2010/main" Requires="a14">
+      <mc:AlternateContent xmlns:mc="http://schemas.openxmlformats.org/markup-compatibility/2006" xmlns:a14="http://schemas.microsoft.com/office/drawing/2010/main">
+        <mc:Choice Requires="a14">
           <p:sp>
             <p:nvSpPr>
               <p:cNvPr id="5" name="Content Placeholder 4">
@@ -10408,7 +11336,7 @@
             </p:txBody>
           </p:sp>
         </mc:Choice>
-        <mc:Fallback>
+        <mc:Fallback xmlns="">
           <p:sp>
             <p:nvSpPr>
               <p:cNvPr id="5" name="Content Placeholder 4">
@@ -10471,7 +11399,7 @@
           <a:p>
             <a:fld id="{8E65201D-48DB-3B45-ABC2-018B1E66F34C}" type="slidenum">
               <a:rPr lang="en-US" smtClean="0"/>
-              <a:t>15</a:t>
+              <a:t>17</a:t>
             </a:fld>
             <a:endParaRPr lang="en-US"/>
           </a:p>
@@ -10490,7 +11418,7 @@
 </p:sld>
 </file>
 
-<file path=ppt/slides/slide16.xml><?xml version="1.0" encoding="utf-8"?>
+<file path=ppt/slides/slide18.xml><?xml version="1.0" encoding="utf-8"?>
 <p:sld xmlns:a="http://schemas.openxmlformats.org/drawingml/2006/main" xmlns:r="http://schemas.openxmlformats.org/officeDocument/2006/relationships" xmlns:p="http://schemas.openxmlformats.org/presentationml/2006/main">
   <p:cSld>
     <p:spTree>
@@ -10541,8 +11469,8 @@
           </a:p>
         </p:txBody>
       </p:sp>
-      <mc:AlternateContent xmlns:mc="http://schemas.openxmlformats.org/markup-compatibility/2006">
-        <mc:Choice xmlns:a14="http://schemas.microsoft.com/office/drawing/2010/main" Requires="a14">
+      <mc:AlternateContent xmlns:mc="http://schemas.openxmlformats.org/markup-compatibility/2006" xmlns:a14="http://schemas.microsoft.com/office/drawing/2010/main">
+        <mc:Choice Requires="a14">
           <p:sp>
             <p:nvSpPr>
               <p:cNvPr id="5" name="Content Placeholder 4">
@@ -10568,7 +11496,35 @@
               <a:p>
                 <a:r>
                   <a:rPr lang="en-US" dirty="0"/>
-                  <a:t>The ‘best’ values of b and w will be found when we minimize the residual sum of squares</a:t>
+                  <a:t>The ‘best’ values of </a:t>
+                </a:r>
+                <a14:m>
+                  <m:oMath xmlns:m="http://schemas.openxmlformats.org/officeDocument/2006/math">
+                    <m:r>
+                      <a:rPr lang="en-US" i="1" dirty="0" smtClean="0">
+                        <a:latin typeface="Cambria Math" panose="02040503050406030204" pitchFamily="18" charset="0"/>
+                      </a:rPr>
+                      <m:t>𝑏</m:t>
+                    </m:r>
+                  </m:oMath>
+                </a14:m>
+                <a:r>
+                  <a:rPr lang="en-US" dirty="0"/>
+                  <a:t> and </a:t>
+                </a:r>
+                <a14:m>
+                  <m:oMath xmlns:m="http://schemas.openxmlformats.org/officeDocument/2006/math">
+                    <m:r>
+                      <a:rPr lang="en-US" i="1" dirty="0" smtClean="0">
+                        <a:latin typeface="Cambria Math" panose="02040503050406030204" pitchFamily="18" charset="0"/>
+                      </a:rPr>
+                      <m:t>𝑤</m:t>
+                    </m:r>
+                  </m:oMath>
+                </a14:m>
+                <a:r>
+                  <a:rPr lang="en-US" dirty="0"/>
+                  <a:t> will be found when we minimize the residual sum of squares</a:t>
                 </a:r>
               </a:p>
               <a:p>
@@ -10942,7 +11898,7 @@
             </p:txBody>
           </p:sp>
         </mc:Choice>
-        <mc:Fallback>
+        <mc:Fallback xmlns="">
           <p:sp>
             <p:nvSpPr>
               <p:cNvPr id="5" name="Content Placeholder 4">
@@ -11005,7 +11961,7 @@
           <a:p>
             <a:fld id="{8E65201D-48DB-3B45-ABC2-018B1E66F34C}" type="slidenum">
               <a:rPr lang="en-US" smtClean="0"/>
-              <a:t>16</a:t>
+              <a:t>18</a:t>
             </a:fld>
             <a:endParaRPr lang="en-US"/>
           </a:p>
@@ -11024,7 +11980,7 @@
 </p:sld>
 </file>
 
-<file path=ppt/slides/slide17.xml><?xml version="1.0" encoding="utf-8"?>
+<file path=ppt/slides/slide19.xml><?xml version="1.0" encoding="utf-8"?>
 <p:sld xmlns:a="http://schemas.openxmlformats.org/drawingml/2006/main" xmlns:r="http://schemas.openxmlformats.org/officeDocument/2006/relationships" xmlns:p="http://schemas.openxmlformats.org/presentationml/2006/main">
   <p:cSld>
     <p:spTree>
@@ -11515,7 +12471,7 @@
           <a:p>
             <a:fld id="{8E65201D-48DB-3B45-ABC2-018B1E66F34C}" type="slidenum">
               <a:rPr lang="en-US" smtClean="0"/>
-              <a:t>17</a:t>
+              <a:t>19</a:t>
             </a:fld>
             <a:endParaRPr lang="en-US"/>
           </a:p>
@@ -11534,7 +12490,213 @@
 </p:sld>
 </file>
 
-<file path=ppt/slides/slide18.xml><?xml version="1.0" encoding="utf-8"?>
+<file path=ppt/slides/slide2.xml><?xml version="1.0" encoding="utf-8"?>
+<p:sld xmlns:a="http://schemas.openxmlformats.org/drawingml/2006/main" xmlns:r="http://schemas.openxmlformats.org/officeDocument/2006/relationships" xmlns:p="http://schemas.openxmlformats.org/presentationml/2006/main">
+  <p:cSld>
+    <p:spTree>
+      <p:nvGrpSpPr>
+        <p:cNvPr id="1" name=""/>
+        <p:cNvGrpSpPr/>
+        <p:nvPr/>
+      </p:nvGrpSpPr>
+      <p:grpSpPr>
+        <a:xfrm>
+          <a:off x="0" y="0"/>
+          <a:ext cx="0" cy="0"/>
+          <a:chOff x="0" y="0"/>
+          <a:chExt cx="0" cy="0"/>
+        </a:xfrm>
+      </p:grpSpPr>
+      <p:sp>
+        <p:nvSpPr>
+          <p:cNvPr id="2" name="Title 1">
+            <a:extLst>
+              <a:ext uri="{FF2B5EF4-FFF2-40B4-BE49-F238E27FC236}">
+                <a16:creationId xmlns:a16="http://schemas.microsoft.com/office/drawing/2014/main" id="{CC4BCD2E-CCE6-5C58-BD47-638FA2E4525B}"/>
+              </a:ext>
+            </a:extLst>
+          </p:cNvPr>
+          <p:cNvSpPr>
+            <a:spLocks noGrp="1"/>
+          </p:cNvSpPr>
+          <p:nvPr>
+            <p:ph type="title"/>
+          </p:nvPr>
+        </p:nvSpPr>
+        <p:spPr/>
+        <p:txBody>
+          <a:bodyPr/>
+          <a:lstStyle/>
+          <a:p>
+            <a:r>
+              <a:rPr lang="en-US" dirty="0"/>
+              <a:t>Course Introduction</a:t>
+            </a:r>
+          </a:p>
+        </p:txBody>
+      </p:sp>
+      <p:sp>
+        <p:nvSpPr>
+          <p:cNvPr id="3" name="Content Placeholder 2">
+            <a:extLst>
+              <a:ext uri="{FF2B5EF4-FFF2-40B4-BE49-F238E27FC236}">
+                <a16:creationId xmlns:a16="http://schemas.microsoft.com/office/drawing/2014/main" id="{44CA97C9-B9DB-169D-4540-562B92298F3C}"/>
+              </a:ext>
+            </a:extLst>
+          </p:cNvPr>
+          <p:cNvSpPr>
+            <a:spLocks noGrp="1"/>
+          </p:cNvSpPr>
+          <p:nvPr>
+            <p:ph idx="1"/>
+          </p:nvPr>
+        </p:nvSpPr>
+        <p:spPr>
+          <a:xfrm>
+            <a:off x="838199" y="1825625"/>
+            <a:ext cx="8605603" cy="4149290"/>
+          </a:xfrm>
+        </p:spPr>
+        <p:txBody>
+          <a:bodyPr>
+            <a:normAutofit fontScale="92500" lnSpcReduction="10000"/>
+          </a:bodyPr>
+          <a:lstStyle/>
+          <a:p>
+            <a:r>
+              <a:rPr lang="en-US" dirty="0"/>
+              <a:t>Quick round table (who are you, and what would you like to get out of this course?)</a:t>
+            </a:r>
+          </a:p>
+          <a:p>
+            <a:r>
+              <a:rPr lang="en-US" dirty="0"/>
+              <a:t>Inspiration for this course:</a:t>
+            </a:r>
+          </a:p>
+          <a:p>
+            <a:pPr lvl="1"/>
+            <a:r>
+              <a:rPr lang="en-US" dirty="0"/>
+              <a:t>AI by Hand by Tom Yeh: </a:t>
+            </a:r>
+            <a:r>
+              <a:rPr lang="en-US" dirty="0">
+                <a:hlinkClick r:id="rId2"/>
+              </a:rPr>
+              <a:t>www.byhand.ai</a:t>
+            </a:r>
+            <a:endParaRPr lang="en-US" dirty="0"/>
+          </a:p>
+          <a:p>
+            <a:pPr lvl="1"/>
+            <a:r>
+              <a:rPr lang="en-US" dirty="0" err="1"/>
+              <a:t>StatQuest</a:t>
+            </a:r>
+            <a:r>
+              <a:rPr lang="en-US" dirty="0"/>
+              <a:t> ‘Clearly Explained’ Videos</a:t>
+            </a:r>
+          </a:p>
+          <a:p>
+            <a:pPr lvl="1"/>
+            <a:r>
+              <a:rPr lang="en-US" dirty="0"/>
+              <a:t>Artificial Intelligence Forecasting System (AIFS), </a:t>
+            </a:r>
+          </a:p>
+          <a:p>
+            <a:pPr lvl="1"/>
+            <a:r>
+              <a:rPr lang="en-US" dirty="0"/>
+              <a:t>Anemoi: https://</a:t>
+            </a:r>
+            <a:r>
+              <a:rPr lang="en-US" dirty="0" err="1"/>
+              <a:t>github.com</a:t>
+            </a:r>
+            <a:r>
+              <a:rPr lang="en-US" dirty="0"/>
+              <a:t>/</a:t>
+            </a:r>
+            <a:r>
+              <a:rPr lang="en-US" dirty="0" err="1"/>
+              <a:t>ecmwf</a:t>
+            </a:r>
+            <a:r>
+              <a:rPr lang="en-US" dirty="0"/>
+              <a:t>/</a:t>
+            </a:r>
+            <a:r>
+              <a:rPr lang="en-US" dirty="0" err="1"/>
+              <a:t>anemoi</a:t>
+            </a:r>
+            <a:r>
+              <a:rPr lang="en-US" dirty="0"/>
+              <a:t>-core</a:t>
+            </a:r>
+          </a:p>
+          <a:p>
+            <a:r>
+              <a:rPr lang="en-US" dirty="0"/>
+              <a:t>This is a hands-on course, mixing manual calculation and coding</a:t>
+            </a:r>
+          </a:p>
+          <a:p>
+            <a:r>
+              <a:rPr lang="en-US" dirty="0"/>
+              <a:t>Weather and climate is a motivating application, but the ideas can be applied more widely</a:t>
+            </a:r>
+          </a:p>
+          <a:p>
+            <a:endParaRPr lang="en-US" dirty="0"/>
+          </a:p>
+        </p:txBody>
+      </p:sp>
+      <p:sp>
+        <p:nvSpPr>
+          <p:cNvPr id="4" name="Slide Number Placeholder 3">
+            <a:extLst>
+              <a:ext uri="{FF2B5EF4-FFF2-40B4-BE49-F238E27FC236}">
+                <a16:creationId xmlns:a16="http://schemas.microsoft.com/office/drawing/2014/main" id="{D8DED1C5-3E0F-6088-5498-20F37CAADF97}"/>
+              </a:ext>
+            </a:extLst>
+          </p:cNvPr>
+          <p:cNvSpPr>
+            <a:spLocks noGrp="1"/>
+          </p:cNvSpPr>
+          <p:nvPr>
+            <p:ph type="sldNum" sz="quarter" idx="12"/>
+          </p:nvPr>
+        </p:nvSpPr>
+        <p:spPr/>
+        <p:txBody>
+          <a:bodyPr/>
+          <a:lstStyle/>
+          <a:p>
+            <a:fld id="{8E65201D-48DB-3B45-ABC2-018B1E66F34C}" type="slidenum">
+              <a:rPr lang="en-US" smtClean="0"/>
+              <a:t>2</a:t>
+            </a:fld>
+            <a:endParaRPr lang="en-US"/>
+          </a:p>
+        </p:txBody>
+      </p:sp>
+    </p:spTree>
+    <p:extLst>
+      <p:ext uri="{BB962C8B-B14F-4D97-AF65-F5344CB8AC3E}">
+        <p14:creationId xmlns:p14="http://schemas.microsoft.com/office/powerpoint/2010/main" val="726790741"/>
+      </p:ext>
+    </p:extLst>
+  </p:cSld>
+  <p:clrMapOvr>
+    <a:masterClrMapping/>
+  </p:clrMapOvr>
+</p:sld>
+</file>
+
+<file path=ppt/slides/slide20.xml><?xml version="1.0" encoding="utf-8"?>
 <p:sld xmlns:a="http://schemas.openxmlformats.org/drawingml/2006/main" xmlns:r="http://schemas.openxmlformats.org/officeDocument/2006/relationships" xmlns:p="http://schemas.openxmlformats.org/presentationml/2006/main">
   <p:cSld>
     <p:spTree>
@@ -11876,7 +13038,7 @@
           <a:p>
             <a:fld id="{8E65201D-48DB-3B45-ABC2-018B1E66F34C}" type="slidenum">
               <a:rPr lang="en-US" smtClean="0"/>
-              <a:t>18</a:t>
+              <a:t>20</a:t>
             </a:fld>
             <a:endParaRPr lang="en-US"/>
           </a:p>
@@ -11895,7 +13057,7 @@
 </p:sld>
 </file>
 
-<file path=ppt/slides/slide19.xml><?xml version="1.0" encoding="utf-8"?>
+<file path=ppt/slides/slide21.xml><?xml version="1.0" encoding="utf-8"?>
 <p:sld xmlns:a="http://schemas.openxmlformats.org/drawingml/2006/main" xmlns:r="http://schemas.openxmlformats.org/officeDocument/2006/relationships" xmlns:p="http://schemas.openxmlformats.org/presentationml/2006/main">
   <p:cSld>
     <p:spTree>
@@ -12285,7 +13447,7 @@
           <a:p>
             <a:fld id="{8E65201D-48DB-3B45-ABC2-018B1E66F34C}" type="slidenum">
               <a:rPr lang="en-US" smtClean="0"/>
-              <a:t>19</a:t>
+              <a:t>21</a:t>
             </a:fld>
             <a:endParaRPr lang="en-US"/>
           </a:p>
@@ -12304,213 +13466,7 @@
 </p:sld>
 </file>
 
-<file path=ppt/slides/slide2.xml><?xml version="1.0" encoding="utf-8"?>
-<p:sld xmlns:a="http://schemas.openxmlformats.org/drawingml/2006/main" xmlns:r="http://schemas.openxmlformats.org/officeDocument/2006/relationships" xmlns:p="http://schemas.openxmlformats.org/presentationml/2006/main">
-  <p:cSld>
-    <p:spTree>
-      <p:nvGrpSpPr>
-        <p:cNvPr id="1" name=""/>
-        <p:cNvGrpSpPr/>
-        <p:nvPr/>
-      </p:nvGrpSpPr>
-      <p:grpSpPr>
-        <a:xfrm>
-          <a:off x="0" y="0"/>
-          <a:ext cx="0" cy="0"/>
-          <a:chOff x="0" y="0"/>
-          <a:chExt cx="0" cy="0"/>
-        </a:xfrm>
-      </p:grpSpPr>
-      <p:sp>
-        <p:nvSpPr>
-          <p:cNvPr id="2" name="Title 1">
-            <a:extLst>
-              <a:ext uri="{FF2B5EF4-FFF2-40B4-BE49-F238E27FC236}">
-                <a16:creationId xmlns:a16="http://schemas.microsoft.com/office/drawing/2014/main" id="{CC4BCD2E-CCE6-5C58-BD47-638FA2E4525B}"/>
-              </a:ext>
-            </a:extLst>
-          </p:cNvPr>
-          <p:cNvSpPr>
-            <a:spLocks noGrp="1"/>
-          </p:cNvSpPr>
-          <p:nvPr>
-            <p:ph type="title"/>
-          </p:nvPr>
-        </p:nvSpPr>
-        <p:spPr/>
-        <p:txBody>
-          <a:bodyPr/>
-          <a:lstStyle/>
-          <a:p>
-            <a:r>
-              <a:rPr lang="en-US" dirty="0"/>
-              <a:t>Course Introduction</a:t>
-            </a:r>
-          </a:p>
-        </p:txBody>
-      </p:sp>
-      <p:sp>
-        <p:nvSpPr>
-          <p:cNvPr id="3" name="Content Placeholder 2">
-            <a:extLst>
-              <a:ext uri="{FF2B5EF4-FFF2-40B4-BE49-F238E27FC236}">
-                <a16:creationId xmlns:a16="http://schemas.microsoft.com/office/drawing/2014/main" id="{44CA97C9-B9DB-169D-4540-562B92298F3C}"/>
-              </a:ext>
-            </a:extLst>
-          </p:cNvPr>
-          <p:cNvSpPr>
-            <a:spLocks noGrp="1"/>
-          </p:cNvSpPr>
-          <p:nvPr>
-            <p:ph idx="1"/>
-          </p:nvPr>
-        </p:nvSpPr>
-        <p:spPr>
-          <a:xfrm>
-            <a:off x="838199" y="1825625"/>
-            <a:ext cx="8605603" cy="4149290"/>
-          </a:xfrm>
-        </p:spPr>
-        <p:txBody>
-          <a:bodyPr>
-            <a:normAutofit lnSpcReduction="10000"/>
-          </a:bodyPr>
-          <a:lstStyle/>
-          <a:p>
-            <a:r>
-              <a:rPr lang="en-US" dirty="0"/>
-              <a:t>Quick round table (who are you and why are you here?)</a:t>
-            </a:r>
-          </a:p>
-          <a:p>
-            <a:r>
-              <a:rPr lang="en-US" dirty="0"/>
-              <a:t>Inspiration for this course:</a:t>
-            </a:r>
-          </a:p>
-          <a:p>
-            <a:pPr lvl="1"/>
-            <a:r>
-              <a:rPr lang="en-US" dirty="0"/>
-              <a:t>AI by Hand by Tom Yeh: </a:t>
-            </a:r>
-            <a:r>
-              <a:rPr lang="en-US" dirty="0">
-                <a:hlinkClick r:id="rId2"/>
-              </a:rPr>
-              <a:t>www.byhand.ai</a:t>
-            </a:r>
-            <a:endParaRPr lang="en-US" dirty="0"/>
-          </a:p>
-          <a:p>
-            <a:pPr lvl="1"/>
-            <a:r>
-              <a:rPr lang="en-US" dirty="0" err="1"/>
-              <a:t>StatQuest</a:t>
-            </a:r>
-            <a:r>
-              <a:rPr lang="en-US" dirty="0"/>
-              <a:t> ‘Clearly Explained’ Videos</a:t>
-            </a:r>
-          </a:p>
-          <a:p>
-            <a:pPr lvl="1"/>
-            <a:r>
-              <a:rPr lang="en-US" dirty="0"/>
-              <a:t>Artificial Intelligence Forecasting System (AIFS), </a:t>
-            </a:r>
-          </a:p>
-          <a:p>
-            <a:pPr lvl="1"/>
-            <a:r>
-              <a:rPr lang="en-US" dirty="0"/>
-              <a:t>Anemoi: https://</a:t>
-            </a:r>
-            <a:r>
-              <a:rPr lang="en-US" dirty="0" err="1"/>
-              <a:t>github.com</a:t>
-            </a:r>
-            <a:r>
-              <a:rPr lang="en-US" dirty="0"/>
-              <a:t>/</a:t>
-            </a:r>
-            <a:r>
-              <a:rPr lang="en-US" dirty="0" err="1"/>
-              <a:t>ecmwf</a:t>
-            </a:r>
-            <a:r>
-              <a:rPr lang="en-US" dirty="0"/>
-              <a:t>/</a:t>
-            </a:r>
-            <a:r>
-              <a:rPr lang="en-US" dirty="0" err="1"/>
-              <a:t>anemoi</a:t>
-            </a:r>
-            <a:r>
-              <a:rPr lang="en-US" dirty="0"/>
-              <a:t>-core</a:t>
-            </a:r>
-          </a:p>
-          <a:p>
-            <a:r>
-              <a:rPr lang="en-US" dirty="0"/>
-              <a:t>This is a hands-on course, mixing manual calculation and coding</a:t>
-            </a:r>
-          </a:p>
-          <a:p>
-            <a:r>
-              <a:rPr lang="en-US" dirty="0"/>
-              <a:t>Weather and climate is a motivating application, but the ideas can be applied more widely</a:t>
-            </a:r>
-          </a:p>
-          <a:p>
-            <a:endParaRPr lang="en-US" dirty="0"/>
-          </a:p>
-        </p:txBody>
-      </p:sp>
-      <p:sp>
-        <p:nvSpPr>
-          <p:cNvPr id="4" name="Slide Number Placeholder 3">
-            <a:extLst>
-              <a:ext uri="{FF2B5EF4-FFF2-40B4-BE49-F238E27FC236}">
-                <a16:creationId xmlns:a16="http://schemas.microsoft.com/office/drawing/2014/main" id="{D8DED1C5-3E0F-6088-5498-20F37CAADF97}"/>
-              </a:ext>
-            </a:extLst>
-          </p:cNvPr>
-          <p:cNvSpPr>
-            <a:spLocks noGrp="1"/>
-          </p:cNvSpPr>
-          <p:nvPr>
-            <p:ph type="sldNum" sz="quarter" idx="12"/>
-          </p:nvPr>
-        </p:nvSpPr>
-        <p:spPr/>
-        <p:txBody>
-          <a:bodyPr/>
-          <a:lstStyle/>
-          <a:p>
-            <a:fld id="{8E65201D-48DB-3B45-ABC2-018B1E66F34C}" type="slidenum">
-              <a:rPr lang="en-US" smtClean="0"/>
-              <a:t>2</a:t>
-            </a:fld>
-            <a:endParaRPr lang="en-US"/>
-          </a:p>
-        </p:txBody>
-      </p:sp>
-    </p:spTree>
-    <p:extLst>
-      <p:ext uri="{BB962C8B-B14F-4D97-AF65-F5344CB8AC3E}">
-        <p14:creationId xmlns:p14="http://schemas.microsoft.com/office/powerpoint/2010/main" val="726790741"/>
-      </p:ext>
-    </p:extLst>
-  </p:cSld>
-  <p:clrMapOvr>
-    <a:masterClrMapping/>
-  </p:clrMapOvr>
-</p:sld>
-</file>
-
-<file path=ppt/slides/slide20.xml><?xml version="1.0" encoding="utf-8"?>
+<file path=ppt/slides/slide22.xml><?xml version="1.0" encoding="utf-8"?>
 <p:sld xmlns:a="http://schemas.openxmlformats.org/drawingml/2006/main" xmlns:r="http://schemas.openxmlformats.org/officeDocument/2006/relationships" xmlns:p="http://schemas.openxmlformats.org/presentationml/2006/main">
   <p:cSld>
     <p:spTree>
@@ -12580,7 +13536,7 @@
         <p:spPr/>
         <p:txBody>
           <a:bodyPr>
-            <a:normAutofit fontScale="62500" lnSpcReduction="20000"/>
+            <a:normAutofit fontScale="85000" lnSpcReduction="20000"/>
           </a:bodyPr>
           <a:lstStyle/>
           <a:p>
@@ -12592,7 +13548,7 @@
                 <a:latin typeface="Courier New" panose="02070309020205020404" pitchFamily="49" charset="0"/>
                 <a:cs typeface="Courier New" panose="02070309020205020404" pitchFamily="49" charset="0"/>
               </a:rPr>
-              <a:t>Epoch    0 | RMSE: 0.945800 | w: 0.998072 | b: 0.999874</a:t>
+              <a:t>Epoch 0, Loss: 9.0256, w: 1.4669, b: 1.9654</a:t>
             </a:r>
           </a:p>
           <a:p>
@@ -12604,7 +13560,7 @@
                 <a:latin typeface="Courier New" panose="02070309020205020404" pitchFamily="49" charset="0"/>
                 <a:cs typeface="Courier New" panose="02070309020205020404" pitchFamily="49" charset="0"/>
               </a:rPr>
-              <a:t>Epoch   12 | RMSE: 0.808423 | w: 0.981143 | b: 0.998764</a:t>
+              <a:t>Epoch 1, Loss: 4.7143, w: 1.1885, b: 1.9474</a:t>
             </a:r>
           </a:p>
           <a:p>
@@ -12616,7 +13572,7 @@
                 <a:latin typeface="Courier New" panose="02070309020205020404" pitchFamily="49" charset="0"/>
                 <a:cs typeface="Courier New" panose="02070309020205020404" pitchFamily="49" charset="0"/>
               </a:rPr>
-              <a:t>Epoch   24 | RMSE: 0.762661 | w: 0.971897 | b: 0.998145</a:t>
+              <a:t>Epoch 2, Loss: 2.4623, w: 1.0431, b: 1.9380</a:t>
             </a:r>
           </a:p>
           <a:p>
@@ -12628,7 +13584,7 @@
                 <a:latin typeface="Courier New" panose="02070309020205020404" pitchFamily="49" charset="0"/>
                 <a:cs typeface="Courier New" panose="02070309020205020404" pitchFamily="49" charset="0"/>
               </a:rPr>
-              <a:t>Epoch   36 | RMSE: 0.748466 | w: 0.966848 | b: 0.997794</a:t>
+              <a:t>Epoch 3, Loss: 1.2860, w: 0.9671, b: 1.9330</a:t>
             </a:r>
           </a:p>
           <a:p>
@@ -12640,7 +13596,7 @@
                 <a:latin typeface="Courier New" panose="02070309020205020404" pitchFamily="49" charset="0"/>
                 <a:cs typeface="Courier New" panose="02070309020205020404" pitchFamily="49" charset="0"/>
               </a:rPr>
-              <a:t>Epoch   48 | RMSE: 0.744178 | w: 0.964091 | b: 0.997589</a:t>
+              <a:t>Epoch 4, Loss: 0.6715, w: 0.9274, b: 1.9305</a:t>
             </a:r>
           </a:p>
           <a:p>
@@ -12652,7 +13608,7 @@
                 <a:latin typeface="Courier New" panose="02070309020205020404" pitchFamily="49" charset="0"/>
                 <a:cs typeface="Courier New" panose="02070309020205020404" pitchFamily="49" charset="0"/>
               </a:rPr>
-              <a:t>Epoch   60 | RMSE: 0.742894 | w: 0.962586 | b: 0.997464</a:t>
+              <a:t>Epoch 5, Loss: 0.3506, w: 0.9067, b: 1.9291</a:t>
             </a:r>
           </a:p>
           <a:p>
@@ -12664,7 +13620,7 @@
                 <a:latin typeface="Courier New" panose="02070309020205020404" pitchFamily="49" charset="0"/>
                 <a:cs typeface="Courier New" panose="02070309020205020404" pitchFamily="49" charset="0"/>
               </a:rPr>
-              <a:t>Epoch   72 | RMSE: 0.742510 | w: 0.961764 | b: 0.997383</a:t>
+              <a:t>Epoch 6, Loss: 0.1829, w: 0.8959, b: 1.9284</a:t>
             </a:r>
           </a:p>
           <a:p>
@@ -12676,7 +13632,7 @@
                 <a:latin typeface="Courier New" panose="02070309020205020404" pitchFamily="49" charset="0"/>
                 <a:cs typeface="Courier New" panose="02070309020205020404" pitchFamily="49" charset="0"/>
               </a:rPr>
-              <a:t>Epoch   84 | RMSE: 0.742395 | w: 0.961317 | b: 0.997326</a:t>
+              <a:t>Epoch 7, Loss: 0.1006, w: 0.8902, b: 1.9281</a:t>
             </a:r>
           </a:p>
           <a:p>
@@ -12688,7 +13644,7 @@
                 <a:latin typeface="Courier New" panose="02070309020205020404" pitchFamily="49" charset="0"/>
                 <a:cs typeface="Courier New" panose="02070309020205020404" pitchFamily="49" charset="0"/>
               </a:rPr>
-              <a:t>Epoch   96 | RMSE: 0.742360 | w: 0.961073 | b: 0.997282</a:t>
+              <a:t>Epoch 8, Loss: 0.0732, w: 0.8873, b: 1.9279</a:t>
             </a:r>
           </a:p>
           <a:p>
@@ -12700,7 +13656,7 @@
                 <a:latin typeface="Courier New" panose="02070309020205020404" pitchFamily="49" charset="0"/>
                 <a:cs typeface="Courier New" panose="02070309020205020404" pitchFamily="49" charset="0"/>
               </a:rPr>
-              <a:t>Epoch  108 | RMSE: 0.742350 | w: 0.960941 | b: 0.997245</a:t>
+              <a:t>Epoch 9, Loss: 0.0667, w: 0.8857, b: 1.9278</a:t>
             </a:r>
           </a:p>
         </p:txBody>
@@ -12728,7 +13684,7 @@
           <a:p>
             <a:fld id="{8E65201D-48DB-3B45-ABC2-018B1E66F34C}" type="slidenum">
               <a:rPr lang="en-US" smtClean="0"/>
-              <a:t>20</a:t>
+              <a:t>22</a:t>
             </a:fld>
             <a:endParaRPr lang="en-US"/>
           </a:p>
@@ -12747,7 +13703,7 @@
 </p:sld>
 </file>
 
-<file path=ppt/slides/slide21.xml><?xml version="1.0" encoding="utf-8"?>
+<file path=ppt/slides/slide23.xml><?xml version="1.0" encoding="utf-8"?>
 <p:sld xmlns:a="http://schemas.openxmlformats.org/drawingml/2006/main" xmlns:r="http://schemas.openxmlformats.org/officeDocument/2006/relationships" xmlns:p="http://schemas.openxmlformats.org/presentationml/2006/main">
   <p:cSld>
     <p:spTree>
@@ -12805,39 +13761,6 @@
           </a:p>
         </p:txBody>
       </p:sp>
-      <p:pic>
-        <p:nvPicPr>
-          <p:cNvPr id="9" name="Content Placeholder 8">
-            <a:extLst>
-              <a:ext uri="{FF2B5EF4-FFF2-40B4-BE49-F238E27FC236}">
-                <a16:creationId xmlns:a16="http://schemas.microsoft.com/office/drawing/2014/main" id="{A6C9CFE7-C67E-A0B2-6A7B-77BB70E123B3}"/>
-              </a:ext>
-            </a:extLst>
-          </p:cNvPr>
-          <p:cNvPicPr>
-            <a:picLocks noGrp="1" noChangeAspect="1"/>
-          </p:cNvPicPr>
-          <p:nvPr>
-            <p:ph idx="1"/>
-          </p:nvPr>
-        </p:nvPicPr>
-        <p:blipFill>
-          <a:blip r:embed="rId2"/>
-          <a:stretch>
-            <a:fillRect/>
-          </a:stretch>
-        </p:blipFill>
-        <p:spPr>
-          <a:xfrm>
-            <a:off x="838200" y="1363979"/>
-            <a:ext cx="6353372" cy="5019163"/>
-          </a:xfrm>
-          <a:prstGeom prst="rect">
-            <a:avLst/>
-          </a:prstGeom>
-          <a:noFill/>
-        </p:spPr>
-      </p:pic>
       <p:sp>
         <p:nvSpPr>
           <p:cNvPr id="4" name="Slide Number Placeholder 3" hidden="1">
@@ -12879,7 +13802,7 @@
                   <a:spcPts val="600"/>
                 </a:spcAft>
               </a:pPr>
-              <a:t>21</a:t>
+              <a:t>23</a:t>
             </a:fld>
             <a:endParaRPr lang="en-US">
               <a:solidFill>
@@ -12891,6 +13814,38 @@
           </a:p>
         </p:txBody>
       </p:sp>
+      <p:pic>
+        <p:nvPicPr>
+          <p:cNvPr id="7" name="Content Placeholder 6">
+            <a:extLst>
+              <a:ext uri="{FF2B5EF4-FFF2-40B4-BE49-F238E27FC236}">
+                <a16:creationId xmlns:a16="http://schemas.microsoft.com/office/drawing/2014/main" id="{311A9BD6-D00F-742B-6324-D05E741DBDAC}"/>
+              </a:ext>
+            </a:extLst>
+          </p:cNvPr>
+          <p:cNvPicPr>
+            <a:picLocks noGrp="1" noChangeAspect="1"/>
+          </p:cNvPicPr>
+          <p:nvPr>
+            <p:ph idx="1"/>
+          </p:nvPr>
+        </p:nvPicPr>
+        <p:blipFill>
+          <a:blip r:embed="rId2"/>
+          <a:stretch>
+            <a:fillRect/>
+          </a:stretch>
+        </p:blipFill>
+        <p:spPr>
+          <a:xfrm>
+            <a:off x="838200" y="1481136"/>
+            <a:ext cx="6108700" cy="4814843"/>
+          </a:xfrm>
+          <a:prstGeom prst="rect">
+            <a:avLst/>
+          </a:prstGeom>
+        </p:spPr>
+      </p:pic>
     </p:spTree>
     <p:extLst>
       <p:ext uri="{BB962C8B-B14F-4D97-AF65-F5344CB8AC3E}">
@@ -12904,7 +13859,7 @@
 </p:sld>
 </file>
 
-<file path=ppt/slides/slide22.xml><?xml version="1.0" encoding="utf-8"?>
+<file path=ppt/slides/slide24.xml><?xml version="1.0" encoding="utf-8"?>
 <p:sld xmlns:a="http://schemas.openxmlformats.org/drawingml/2006/main" xmlns:r="http://schemas.openxmlformats.org/officeDocument/2006/relationships" xmlns:p="http://schemas.openxmlformats.org/presentationml/2006/main">
   <p:cSld>
     <p:spTree>
@@ -12981,7 +13936,7 @@
                     <m:r>
                       <a:rPr lang="en-US" sz="2800" i="1" dirty="0" smtClean="0">
                         <a:solidFill>
-                          <a:srgbClr val="030A18"/>
+                          <a:srgbClr val="00427A"/>
                         </a:solidFill>
                         <a:latin typeface="Cambria Math" panose="02040503050406030204" pitchFamily="18" charset="0"/>
                       </a:rPr>
@@ -12992,12 +13947,11 @@
                 <a:r>
                   <a:rPr lang="en-US" sz="2800" dirty="0">
                     <a:solidFill>
-                      <a:srgbClr val="030A18"/>
+                      <a:srgbClr val="00427A"/>
                     </a:solidFill>
                   </a:rPr>
-                  <a:t> controls the step size in gradient descent.</a:t>
+                  <a:t> controls the step size in gradient descent</a:t>
                 </a:r>
-                <a:endParaRPr lang="en-US" sz="2800" dirty="0"/>
               </a:p>
               <a:p>
                 <a:pPr marL="190500" indent="-190500">
@@ -13007,12 +13961,11 @@
                 <a:r>
                   <a:rPr lang="en-US" sz="2800" dirty="0">
                     <a:solidFill>
-                      <a:srgbClr val="030A18"/>
+                      <a:srgbClr val="00427A"/>
                     </a:solidFill>
                   </a:rPr>
-                  <a:t>Too small: slow convergence; too large: divergence.</a:t>
+                  <a:t>Too small: slow convergence; too large: divergence</a:t>
                 </a:r>
-                <a:endParaRPr lang="en-US" sz="2800" dirty="0"/>
               </a:p>
               <a:p>
                 <a:pPr marL="190500" indent="-190500">
@@ -13022,12 +13975,11 @@
                 <a:r>
                   <a:rPr lang="en-US" sz="2800" dirty="0">
                     <a:solidFill>
-                      <a:srgbClr val="030A18"/>
+                      <a:srgbClr val="00427A"/>
                     </a:solidFill>
                   </a:rPr>
-                  <a:t>Often chosen empirically or via learning rate schedules.</a:t>
+                  <a:t>Often chosen empirically or via learning rate schedules</a:t>
                 </a:r>
-                <a:endParaRPr lang="en-US" sz="2800" dirty="0"/>
               </a:p>
               <a:p>
                 <a:pPr marL="190500" indent="-190500">
@@ -13037,7 +13989,7 @@
                 <a:r>
                   <a:rPr lang="en-US" sz="2800" dirty="0">
                     <a:solidFill>
-                      <a:srgbClr val="030A18"/>
+                      <a:srgbClr val="00427A"/>
                     </a:solidFill>
                   </a:rPr>
                   <a:t>Adaptive optimizers (e.g. Adam, </a:t>
@@ -13045,7 +13997,7 @@
                 <a:r>
                   <a:rPr lang="en-US" sz="2800" dirty="0" err="1">
                     <a:solidFill>
-                      <a:srgbClr val="030A18"/>
+                      <a:srgbClr val="00427A"/>
                     </a:solidFill>
                   </a:rPr>
                   <a:t>RMSProp</a:t>
@@ -13053,12 +14005,11 @@
                 <a:r>
                   <a:rPr lang="en-US" sz="2800" dirty="0">
                     <a:solidFill>
-                      <a:srgbClr val="030A18"/>
+                      <a:srgbClr val="00427A"/>
                     </a:solidFill>
                   </a:rPr>
-                  <a:t>) adjust the rate automatically.</a:t>
+                  <a:t>) adjust the rate automatically</a:t>
                 </a:r>
-                <a:endParaRPr lang="en-US" sz="2800" dirty="0"/>
               </a:p>
               <a:p>
                 <a:endParaRPr lang="en-US" dirty="0"/>
@@ -13087,7 +14038,7 @@
               <a:blipFill>
                 <a:blip r:embed="rId2"/>
                 <a:stretch>
-                  <a:fillRect l="-2118" t="-2241" r="-2941"/>
+                  <a:fillRect l="-2200" t="-2326" r="-2934"/>
                 </a:stretch>
               </a:blipFill>
             </p:spPr>
@@ -13096,7 +14047,7 @@
               <a:lstStyle/>
               <a:p>
                 <a:r>
-                  <a:rPr lang="en-IE">
+                  <a:rPr lang="en-US">
                     <a:noFill/>
                   </a:rPr>
                   <a:t> </a:t>
@@ -13129,7 +14080,7 @@
           <a:p>
             <a:fld id="{8E65201D-48DB-3B45-ABC2-018B1E66F34C}" type="slidenum">
               <a:rPr lang="en-US" smtClean="0"/>
-              <a:t>22</a:t>
+              <a:t>24</a:t>
             </a:fld>
             <a:endParaRPr lang="en-US"/>
           </a:p>
@@ -13174,7 +14125,7 @@
 </p:sld>
 </file>
 
-<file path=ppt/slides/slide23.xml><?xml version="1.0" encoding="utf-8"?>
+<file path=ppt/slides/slide25.xml><?xml version="1.0" encoding="utf-8"?>
 <p:sld xmlns:a="http://schemas.openxmlformats.org/drawingml/2006/main" xmlns:r="http://schemas.openxmlformats.org/officeDocument/2006/relationships" xmlns:p="http://schemas.openxmlformats.org/presentationml/2006/main">
   <p:cSld>
     <p:spTree>
@@ -13226,66 +14177,6 @@
           </a:p>
         </p:txBody>
       </p:sp>
-      <p:pic>
-        <p:nvPicPr>
-          <p:cNvPr id="11" name="Picture 10">
-            <a:extLst>
-              <a:ext uri="{FF2B5EF4-FFF2-40B4-BE49-F238E27FC236}">
-                <a16:creationId xmlns:a16="http://schemas.microsoft.com/office/drawing/2014/main" id="{F7D51CE3-1CC8-7BA1-89BF-91C7FFEE6C12}"/>
-              </a:ext>
-            </a:extLst>
-          </p:cNvPr>
-          <p:cNvPicPr>
-            <a:picLocks noChangeAspect="1"/>
-          </p:cNvPicPr>
-          <p:nvPr/>
-        </p:nvPicPr>
-        <p:blipFill>
-          <a:blip r:embed="rId2"/>
-          <a:stretch>
-            <a:fillRect/>
-          </a:stretch>
-        </p:blipFill>
-        <p:spPr>
-          <a:xfrm>
-            <a:off x="1101305" y="2421924"/>
-            <a:ext cx="4640971" cy="3711146"/>
-          </a:xfrm>
-          <a:prstGeom prst="rect">
-            <a:avLst/>
-          </a:prstGeom>
-        </p:spPr>
-      </p:pic>
-      <p:pic>
-        <p:nvPicPr>
-          <p:cNvPr id="8" name="Picture 7">
-            <a:extLst>
-              <a:ext uri="{FF2B5EF4-FFF2-40B4-BE49-F238E27FC236}">
-                <a16:creationId xmlns:a16="http://schemas.microsoft.com/office/drawing/2014/main" id="{A0DDA876-962C-55D3-CCE3-A990A25E42B1}"/>
-              </a:ext>
-            </a:extLst>
-          </p:cNvPr>
-          <p:cNvPicPr>
-            <a:picLocks noChangeAspect="1"/>
-          </p:cNvPicPr>
-          <p:nvPr/>
-        </p:nvPicPr>
-        <p:blipFill>
-          <a:blip r:embed="rId3"/>
-          <a:stretch>
-            <a:fillRect/>
-          </a:stretch>
-        </p:blipFill>
-        <p:spPr>
-          <a:xfrm>
-            <a:off x="6403047" y="2421924"/>
-            <a:ext cx="4757879" cy="3711146"/>
-          </a:xfrm>
-          <a:prstGeom prst="rect">
-            <a:avLst/>
-          </a:prstGeom>
-        </p:spPr>
-      </p:pic>
       <p:sp>
         <p:nvSpPr>
           <p:cNvPr id="5" name="Slide Number Placeholder 4">
@@ -13332,7 +14223,7 @@
                   <a:spcPts val="600"/>
                 </a:spcAft>
               </a:pPr>
-              <a:t>23</a:t>
+              <a:t>25</a:t>
             </a:fld>
             <a:endParaRPr lang="en-US">
               <a:solidFill>
@@ -13344,6 +14235,66 @@
           </a:p>
         </p:txBody>
       </p:sp>
+      <p:pic>
+        <p:nvPicPr>
+          <p:cNvPr id="9" name="Picture 8">
+            <a:extLst>
+              <a:ext uri="{FF2B5EF4-FFF2-40B4-BE49-F238E27FC236}">
+                <a16:creationId xmlns:a16="http://schemas.microsoft.com/office/drawing/2014/main" id="{59412C57-0140-DC49-6555-3CC6A8F020CD}"/>
+              </a:ext>
+            </a:extLst>
+          </p:cNvPr>
+          <p:cNvPicPr>
+            <a:picLocks noChangeAspect="1"/>
+          </p:cNvPicPr>
+          <p:nvPr/>
+        </p:nvPicPr>
+        <p:blipFill>
+          <a:blip r:embed="rId3"/>
+          <a:stretch>
+            <a:fillRect/>
+          </a:stretch>
+        </p:blipFill>
+        <p:spPr>
+          <a:xfrm>
+            <a:off x="476249" y="1746767"/>
+            <a:ext cx="5167185" cy="4234480"/>
+          </a:xfrm>
+          <a:prstGeom prst="rect">
+            <a:avLst/>
+          </a:prstGeom>
+        </p:spPr>
+      </p:pic>
+      <p:pic>
+        <p:nvPicPr>
+          <p:cNvPr id="12" name="Picture 11">
+            <a:extLst>
+              <a:ext uri="{FF2B5EF4-FFF2-40B4-BE49-F238E27FC236}">
+                <a16:creationId xmlns:a16="http://schemas.microsoft.com/office/drawing/2014/main" id="{181392AA-DE41-8855-0DE8-29DDE33C2E2E}"/>
+              </a:ext>
+            </a:extLst>
+          </p:cNvPr>
+          <p:cNvPicPr>
+            <a:picLocks noChangeAspect="1"/>
+          </p:cNvPicPr>
+          <p:nvPr/>
+        </p:nvPicPr>
+        <p:blipFill>
+          <a:blip r:embed="rId4"/>
+          <a:stretch>
+            <a:fillRect/>
+          </a:stretch>
+        </p:blipFill>
+        <p:spPr>
+          <a:xfrm>
+            <a:off x="6005383" y="1426174"/>
+            <a:ext cx="5181600" cy="4445000"/>
+          </a:xfrm>
+          <a:prstGeom prst="rect">
+            <a:avLst/>
+          </a:prstGeom>
+        </p:spPr>
+      </p:pic>
     </p:spTree>
     <p:extLst>
       <p:ext uri="{BB962C8B-B14F-4D97-AF65-F5344CB8AC3E}">
@@ -13357,7 +14308,287 @@
 </p:sld>
 </file>
 
-<file path=ppt/slides/slide24.xml><?xml version="1.0" encoding="utf-8"?>
+<file path=ppt/slides/slide26.xml><?xml version="1.0" encoding="utf-8"?>
+<p:sld xmlns:a="http://schemas.openxmlformats.org/drawingml/2006/main" xmlns:r="http://schemas.openxmlformats.org/officeDocument/2006/relationships" xmlns:p="http://schemas.openxmlformats.org/presentationml/2006/main">
+  <p:cSld>
+    <p:spTree>
+      <p:nvGrpSpPr>
+        <p:cNvPr id="1" name=""/>
+        <p:cNvGrpSpPr/>
+        <p:nvPr/>
+      </p:nvGrpSpPr>
+      <p:grpSpPr>
+        <a:xfrm>
+          <a:off x="0" y="0"/>
+          <a:ext cx="0" cy="0"/>
+          <a:chOff x="0" y="0"/>
+          <a:chExt cx="0" cy="0"/>
+        </a:xfrm>
+      </p:grpSpPr>
+      <p:sp>
+        <p:nvSpPr>
+          <p:cNvPr id="2" name="Title 1">
+            <a:extLst>
+              <a:ext uri="{FF2B5EF4-FFF2-40B4-BE49-F238E27FC236}">
+                <a16:creationId xmlns:a16="http://schemas.microsoft.com/office/drawing/2014/main" id="{E469E39C-D5F6-C77D-18D4-38402697D38E}"/>
+              </a:ext>
+            </a:extLst>
+          </p:cNvPr>
+          <p:cNvSpPr>
+            <a:spLocks noGrp="1"/>
+          </p:cNvSpPr>
+          <p:nvPr>
+            <p:ph type="ctrTitle"/>
+          </p:nvPr>
+        </p:nvSpPr>
+        <p:spPr/>
+        <p:txBody>
+          <a:bodyPr/>
+          <a:lstStyle/>
+          <a:p>
+            <a:endParaRPr lang="en-US"/>
+          </a:p>
+        </p:txBody>
+      </p:sp>
+      <p:sp>
+        <p:nvSpPr>
+          <p:cNvPr id="3" name="Subtitle 2">
+            <a:extLst>
+              <a:ext uri="{FF2B5EF4-FFF2-40B4-BE49-F238E27FC236}">
+                <a16:creationId xmlns:a16="http://schemas.microsoft.com/office/drawing/2014/main" id="{E8EA4A61-CE6D-44D8-27E8-4536E4268A11}"/>
+              </a:ext>
+            </a:extLst>
+          </p:cNvPr>
+          <p:cNvSpPr>
+            <a:spLocks noGrp="1"/>
+          </p:cNvSpPr>
+          <p:nvPr>
+            <p:ph type="subTitle" idx="1"/>
+          </p:nvPr>
+        </p:nvSpPr>
+        <p:spPr/>
+        <p:txBody>
+          <a:bodyPr/>
+          <a:lstStyle/>
+          <a:p>
+            <a:endParaRPr lang="en-US"/>
+          </a:p>
+        </p:txBody>
+      </p:sp>
+      <p:sp>
+        <p:nvSpPr>
+          <p:cNvPr id="4" name="Date Placeholder 3">
+            <a:extLst>
+              <a:ext uri="{FF2B5EF4-FFF2-40B4-BE49-F238E27FC236}">
+                <a16:creationId xmlns:a16="http://schemas.microsoft.com/office/drawing/2014/main" id="{3FE6E257-E59D-F782-9848-DE19C5472F4E}"/>
+              </a:ext>
+            </a:extLst>
+          </p:cNvPr>
+          <p:cNvSpPr>
+            <a:spLocks noGrp="1"/>
+          </p:cNvSpPr>
+          <p:nvPr>
+            <p:ph type="dt" sz="half" idx="10"/>
+          </p:nvPr>
+        </p:nvSpPr>
+        <p:spPr/>
+        <p:txBody>
+          <a:bodyPr/>
+          <a:lstStyle/>
+          <a:p>
+            <a:fld id="{16F2FB5F-D553-C945-B874-A642CC0C851F}" type="datetime3">
+              <a:rPr lang="en-IE" smtClean="0"/>
+              <a:pPr/>
+              <a:t>15 February 2026</a:t>
+            </a:fld>
+            <a:endParaRPr lang="en-US" dirty="0"/>
+          </a:p>
+        </p:txBody>
+      </p:sp>
+      <p:pic>
+        <p:nvPicPr>
+          <p:cNvPr id="6" name="slide.url=https://www.polleverywhere.com/multiple_choice_polls/Nl64SB8F6W7j9Limp1MDf?state=opened&amp;flow=Default&amp;onscreen=persist">
+            <a:extLst>
+              <a:ext uri="{FF2B5EF4-FFF2-40B4-BE49-F238E27FC236}">
+                <a16:creationId xmlns:a16="http://schemas.microsoft.com/office/drawing/2014/main" id="{B4F5BFCF-BB8A-978B-0020-717E2E775D84}"/>
+              </a:ext>
+            </a:extLst>
+          </p:cNvPr>
+          <p:cNvPicPr>
+            <a:picLocks/>
+          </p:cNvPicPr>
+          <p:nvPr/>
+        </p:nvPicPr>
+        <p:blipFill>
+          <a:blip r:embed="rId3"/>
+          <a:stretch>
+            <a:fillRect/>
+          </a:stretch>
+        </p:blipFill>
+        <p:spPr>
+          <a:xfrm>
+            <a:off x="63500" y="63500"/>
+            <a:ext cx="12065000" cy="6731000"/>
+          </a:xfrm>
+          <a:prstGeom prst="rect">
+            <a:avLst/>
+          </a:prstGeom>
+        </p:spPr>
+      </p:pic>
+    </p:spTree>
+    <p:extLst>
+      <p:ext uri="{BB962C8B-B14F-4D97-AF65-F5344CB8AC3E}">
+        <p14:creationId xmlns:p14="http://schemas.microsoft.com/office/powerpoint/2010/main" val="2670540137"/>
+      </p:ext>
+    </p:extLst>
+  </p:cSld>
+  <p:clrMapOvr>
+    <a:masterClrMapping/>
+  </p:clrMapOvr>
+</p:sld>
+</file>
+
+<file path=ppt/slides/slide27.xml><?xml version="1.0" encoding="utf-8"?>
+<p:sld xmlns:a="http://schemas.openxmlformats.org/drawingml/2006/main" xmlns:r="http://schemas.openxmlformats.org/officeDocument/2006/relationships" xmlns:p="http://schemas.openxmlformats.org/presentationml/2006/main">
+  <p:cSld>
+    <p:spTree>
+      <p:nvGrpSpPr>
+        <p:cNvPr id="1" name=""/>
+        <p:cNvGrpSpPr/>
+        <p:nvPr/>
+      </p:nvGrpSpPr>
+      <p:grpSpPr>
+        <a:xfrm>
+          <a:off x="0" y="0"/>
+          <a:ext cx="0" cy="0"/>
+          <a:chOff x="0" y="0"/>
+          <a:chExt cx="0" cy="0"/>
+        </a:xfrm>
+      </p:grpSpPr>
+      <p:sp>
+        <p:nvSpPr>
+          <p:cNvPr id="2" name="Title 1">
+            <a:extLst>
+              <a:ext uri="{FF2B5EF4-FFF2-40B4-BE49-F238E27FC236}">
+                <a16:creationId xmlns:a16="http://schemas.microsoft.com/office/drawing/2014/main" id="{8945B126-7CFA-3A88-2EE6-CEA5619E0500}"/>
+              </a:ext>
+            </a:extLst>
+          </p:cNvPr>
+          <p:cNvSpPr>
+            <a:spLocks noGrp="1"/>
+          </p:cNvSpPr>
+          <p:nvPr>
+            <p:ph type="ctrTitle"/>
+          </p:nvPr>
+        </p:nvSpPr>
+        <p:spPr/>
+        <p:txBody>
+          <a:bodyPr/>
+          <a:lstStyle/>
+          <a:p>
+            <a:endParaRPr lang="en-US"/>
+          </a:p>
+        </p:txBody>
+      </p:sp>
+      <p:sp>
+        <p:nvSpPr>
+          <p:cNvPr id="3" name="Subtitle 2">
+            <a:extLst>
+              <a:ext uri="{FF2B5EF4-FFF2-40B4-BE49-F238E27FC236}">
+                <a16:creationId xmlns:a16="http://schemas.microsoft.com/office/drawing/2014/main" id="{F07A2352-2040-A403-BE1A-19C828EEAEF3}"/>
+              </a:ext>
+            </a:extLst>
+          </p:cNvPr>
+          <p:cNvSpPr>
+            <a:spLocks noGrp="1"/>
+          </p:cNvSpPr>
+          <p:nvPr>
+            <p:ph type="subTitle" idx="1"/>
+          </p:nvPr>
+        </p:nvSpPr>
+        <p:spPr/>
+        <p:txBody>
+          <a:bodyPr/>
+          <a:lstStyle/>
+          <a:p>
+            <a:endParaRPr lang="en-US"/>
+          </a:p>
+        </p:txBody>
+      </p:sp>
+      <p:sp>
+        <p:nvSpPr>
+          <p:cNvPr id="4" name="Date Placeholder 3">
+            <a:extLst>
+              <a:ext uri="{FF2B5EF4-FFF2-40B4-BE49-F238E27FC236}">
+                <a16:creationId xmlns:a16="http://schemas.microsoft.com/office/drawing/2014/main" id="{23EF3ACE-AADC-CBE1-4FEF-E50BDF36DED7}"/>
+              </a:ext>
+            </a:extLst>
+          </p:cNvPr>
+          <p:cNvSpPr>
+            <a:spLocks noGrp="1"/>
+          </p:cNvSpPr>
+          <p:nvPr>
+            <p:ph type="dt" sz="half" idx="10"/>
+          </p:nvPr>
+        </p:nvSpPr>
+        <p:spPr/>
+        <p:txBody>
+          <a:bodyPr/>
+          <a:lstStyle/>
+          <a:p>
+            <a:fld id="{16F2FB5F-D553-C945-B874-A642CC0C851F}" type="datetime3">
+              <a:rPr lang="en-IE" smtClean="0"/>
+              <a:pPr/>
+              <a:t>15 February 2026</a:t>
+            </a:fld>
+            <a:endParaRPr lang="en-US" dirty="0"/>
+          </a:p>
+        </p:txBody>
+      </p:sp>
+      <p:pic>
+        <p:nvPicPr>
+          <p:cNvPr id="6" name="slide.url=https://www.polleverywhere.com/multiple_choice_polls/OrixocTkLIB9GXI5DFJxH?state=opened&amp;flow=Default&amp;onscreen=persist">
+            <a:extLst>
+              <a:ext uri="{FF2B5EF4-FFF2-40B4-BE49-F238E27FC236}">
+                <a16:creationId xmlns:a16="http://schemas.microsoft.com/office/drawing/2014/main" id="{F1EF27CE-E014-4EA8-22E6-3B76572C87BE}"/>
+              </a:ext>
+            </a:extLst>
+          </p:cNvPr>
+          <p:cNvPicPr>
+            <a:picLocks/>
+          </p:cNvPicPr>
+          <p:nvPr/>
+        </p:nvPicPr>
+        <p:blipFill>
+          <a:blip r:embed="rId3"/>
+          <a:stretch>
+            <a:fillRect/>
+          </a:stretch>
+        </p:blipFill>
+        <p:spPr>
+          <a:xfrm>
+            <a:off x="63500" y="63500"/>
+            <a:ext cx="12065000" cy="6731000"/>
+          </a:xfrm>
+          <a:prstGeom prst="rect">
+            <a:avLst/>
+          </a:prstGeom>
+        </p:spPr>
+      </p:pic>
+    </p:spTree>
+    <p:extLst>
+      <p:ext uri="{BB962C8B-B14F-4D97-AF65-F5344CB8AC3E}">
+        <p14:creationId xmlns:p14="http://schemas.microsoft.com/office/powerpoint/2010/main" val="342750567"/>
+      </p:ext>
+    </p:extLst>
+  </p:cSld>
+  <p:clrMapOvr>
+    <a:masterClrMapping/>
+  </p:clrMapOvr>
+</p:sld>
+</file>
+
+<file path=ppt/slides/slide28.xml><?xml version="1.0" encoding="utf-8"?>
 <p:sld xmlns:a="http://schemas.openxmlformats.org/drawingml/2006/main" xmlns:r="http://schemas.openxmlformats.org/officeDocument/2006/relationships" xmlns:p="http://schemas.openxmlformats.org/presentationml/2006/main">
   <p:cSld>
     <p:spTree>
@@ -13477,7 +14708,7 @@
           <a:p>
             <a:fld id="{8E65201D-48DB-3B45-ABC2-018B1E66F34C}" type="slidenum">
               <a:rPr lang="en-US" smtClean="0"/>
-              <a:t>24</a:t>
+              <a:t>28</a:t>
             </a:fld>
             <a:endParaRPr lang="en-US"/>
           </a:p>
@@ -13496,7 +14727,7 @@
 </p:sld>
 </file>
 
-<file path=ppt/slides/slide25.xml><?xml version="1.0" encoding="utf-8"?>
+<file path=ppt/slides/slide29.xml><?xml version="1.0" encoding="utf-8"?>
 <p:sld xmlns:a="http://schemas.openxmlformats.org/drawingml/2006/main" xmlns:r="http://schemas.openxmlformats.org/officeDocument/2006/relationships" xmlns:p="http://schemas.openxmlformats.org/presentationml/2006/main">
   <p:cSld>
     <p:spTree>
@@ -13617,7 +14848,147 @@
 </p:sld>
 </file>
 
-<file path=ppt/slides/slide26.xml><?xml version="1.0" encoding="utf-8"?>
+<file path=ppt/slides/slide3.xml><?xml version="1.0" encoding="utf-8"?>
+<p:sld xmlns:a="http://schemas.openxmlformats.org/drawingml/2006/main" xmlns:r="http://schemas.openxmlformats.org/officeDocument/2006/relationships" xmlns:p="http://schemas.openxmlformats.org/presentationml/2006/main">
+  <p:cSld>
+    <p:spTree>
+      <p:nvGrpSpPr>
+        <p:cNvPr id="1" name=""/>
+        <p:cNvGrpSpPr/>
+        <p:nvPr/>
+      </p:nvGrpSpPr>
+      <p:grpSpPr>
+        <a:xfrm>
+          <a:off x="0" y="0"/>
+          <a:ext cx="0" cy="0"/>
+          <a:chOff x="0" y="0"/>
+          <a:chExt cx="0" cy="0"/>
+        </a:xfrm>
+      </p:grpSpPr>
+      <p:sp>
+        <p:nvSpPr>
+          <p:cNvPr id="2" name="Title 1">
+            <a:extLst>
+              <a:ext uri="{FF2B5EF4-FFF2-40B4-BE49-F238E27FC236}">
+                <a16:creationId xmlns:a16="http://schemas.microsoft.com/office/drawing/2014/main" id="{8FEA0143-3578-2EB8-D2D7-84DB83A5F318}"/>
+              </a:ext>
+            </a:extLst>
+          </p:cNvPr>
+          <p:cNvSpPr>
+            <a:spLocks noGrp="1"/>
+          </p:cNvSpPr>
+          <p:nvPr>
+            <p:ph type="ctrTitle"/>
+          </p:nvPr>
+        </p:nvSpPr>
+        <p:spPr/>
+        <p:txBody>
+          <a:bodyPr/>
+          <a:lstStyle/>
+          <a:p>
+            <a:endParaRPr lang="en-US"/>
+          </a:p>
+        </p:txBody>
+      </p:sp>
+      <p:sp>
+        <p:nvSpPr>
+          <p:cNvPr id="3" name="Subtitle 2">
+            <a:extLst>
+              <a:ext uri="{FF2B5EF4-FFF2-40B4-BE49-F238E27FC236}">
+                <a16:creationId xmlns:a16="http://schemas.microsoft.com/office/drawing/2014/main" id="{1F2D60D2-C3AC-DB5C-5600-9EE7E4D8D285}"/>
+              </a:ext>
+            </a:extLst>
+          </p:cNvPr>
+          <p:cNvSpPr>
+            <a:spLocks noGrp="1"/>
+          </p:cNvSpPr>
+          <p:nvPr>
+            <p:ph type="subTitle" idx="1"/>
+          </p:nvPr>
+        </p:nvSpPr>
+        <p:spPr/>
+        <p:txBody>
+          <a:bodyPr/>
+          <a:lstStyle/>
+          <a:p>
+            <a:endParaRPr lang="en-US"/>
+          </a:p>
+        </p:txBody>
+      </p:sp>
+      <p:sp>
+        <p:nvSpPr>
+          <p:cNvPr id="4" name="Date Placeholder 3">
+            <a:extLst>
+              <a:ext uri="{FF2B5EF4-FFF2-40B4-BE49-F238E27FC236}">
+                <a16:creationId xmlns:a16="http://schemas.microsoft.com/office/drawing/2014/main" id="{20EA06DC-5B5D-44EA-8DFF-0749F91B7533}"/>
+              </a:ext>
+            </a:extLst>
+          </p:cNvPr>
+          <p:cNvSpPr>
+            <a:spLocks noGrp="1"/>
+          </p:cNvSpPr>
+          <p:nvPr>
+            <p:ph type="dt" sz="half" idx="10"/>
+          </p:nvPr>
+        </p:nvSpPr>
+        <p:spPr/>
+        <p:txBody>
+          <a:bodyPr/>
+          <a:lstStyle/>
+          <a:p>
+            <a:fld id="{16F2FB5F-D553-C945-B874-A642CC0C851F}" type="datetime3">
+              <a:rPr lang="en-IE" smtClean="0"/>
+              <a:pPr/>
+              <a:t>15 February 2026</a:t>
+            </a:fld>
+            <a:endParaRPr lang="en-US" dirty="0"/>
+          </a:p>
+        </p:txBody>
+      </p:sp>
+      <p:pic>
+        <p:nvPicPr>
+          <p:cNvPr id="6" name="slide.url=https://www.polleverywhere.com/multiple_choice_polls/ke0F7V1qXKkGTR3kaJFc2?state=opened&amp;flow=Default&amp;onscreen=persist">
+            <a:extLst>
+              <a:ext uri="{FF2B5EF4-FFF2-40B4-BE49-F238E27FC236}">
+                <a16:creationId xmlns:a16="http://schemas.microsoft.com/office/drawing/2014/main" id="{0BCC93E8-3DE3-87A1-CECE-4DE59FC7AA16}"/>
+              </a:ext>
+            </a:extLst>
+          </p:cNvPr>
+          <p:cNvPicPr>
+            <a:picLocks/>
+          </p:cNvPicPr>
+          <p:nvPr/>
+        </p:nvPicPr>
+        <p:blipFill>
+          <a:blip r:embed="rId3"/>
+          <a:stretch>
+            <a:fillRect/>
+          </a:stretch>
+        </p:blipFill>
+        <p:spPr>
+          <a:xfrm>
+            <a:off x="63500" y="63500"/>
+            <a:ext cx="12065000" cy="6731000"/>
+          </a:xfrm>
+          <a:prstGeom prst="rect">
+            <a:avLst/>
+          </a:prstGeom>
+        </p:spPr>
+      </p:pic>
+    </p:spTree>
+    <p:extLst>
+      <p:ext uri="{BB962C8B-B14F-4D97-AF65-F5344CB8AC3E}">
+        <p14:creationId xmlns:p14="http://schemas.microsoft.com/office/powerpoint/2010/main" val="257407931"/>
+      </p:ext>
+    </p:extLst>
+  </p:cSld>
+  <p:clrMapOvr>
+    <a:masterClrMapping/>
+  </p:clrMapOvr>
+</p:sld>
+</file>
+
+<file path=ppt/slides/slide30.xml><?xml version="1.0" encoding="utf-8"?>
 <p:sld xmlns:a="http://schemas.openxmlformats.org/drawingml/2006/main" xmlns:r="http://schemas.openxmlformats.org/officeDocument/2006/relationships" xmlns:p="http://schemas.openxmlformats.org/presentationml/2006/main">
   <p:cSld>
     <p:spTree>
@@ -13749,8 +15120,19 @@
             </a:pPr>
             <a:r>
               <a:rPr lang="en-US" sz="2800" dirty="0"/>
-              <a:t>Either improves numerical stability and convergence</a:t>
-            </a:r>
+              <a:t>Either technique usually improves numerical stability and convergence</a:t>
+            </a:r>
+          </a:p>
+          <a:p>
+            <a:pPr marL="190500" indent="-190500">
+              <a:buSzPct val="100000"/>
+              <a:buChar char="•"/>
+            </a:pPr>
+            <a:r>
+              <a:rPr lang="en-US" dirty="0"/>
+              <a:t>Remember to re-scale back to original units when producing predictions</a:t>
+            </a:r>
+            <a:endParaRPr lang="en-US" sz="2800" dirty="0"/>
           </a:p>
           <a:p>
             <a:endParaRPr lang="en-US" dirty="0"/>
@@ -13780,7 +15162,7 @@
           <a:p>
             <a:fld id="{8E65201D-48DB-3B45-ABC2-018B1E66F34C}" type="slidenum">
               <a:rPr lang="en-US" smtClean="0"/>
-              <a:t>26</a:t>
+              <a:t>30</a:t>
             </a:fld>
             <a:endParaRPr lang="en-US"/>
           </a:p>
@@ -13799,7 +15181,7 @@
 </p:sld>
 </file>
 
-<file path=ppt/slides/slide27.xml><?xml version="1.0" encoding="utf-8"?>
+<file path=ppt/slides/slide31.xml><?xml version="1.0" encoding="utf-8"?>
 <p:sld xmlns:a="http://schemas.openxmlformats.org/drawingml/2006/main" xmlns:r="http://schemas.openxmlformats.org/officeDocument/2006/relationships" xmlns:p="http://schemas.openxmlformats.org/presentationml/2006/main">
   <p:cSld>
     <p:spTree>
@@ -13929,7 +15311,7 @@
           <a:p>
             <a:fld id="{8E65201D-48DB-3B45-ABC2-018B1E66F34C}" type="slidenum">
               <a:rPr lang="en-US" smtClean="0"/>
-              <a:t>27</a:t>
+              <a:t>31</a:t>
             </a:fld>
             <a:endParaRPr lang="en-US"/>
           </a:p>
@@ -13948,7 +15330,7 @@
 </p:sld>
 </file>
 
-<file path=ppt/slides/slide28.xml><?xml version="1.0" encoding="utf-8"?>
+<file path=ppt/slides/slide32.xml><?xml version="1.0" encoding="utf-8"?>
 <p:sld xmlns:a="http://schemas.openxmlformats.org/drawingml/2006/main" xmlns:r="http://schemas.openxmlformats.org/officeDocument/2006/relationships" xmlns:p="http://schemas.openxmlformats.org/presentationml/2006/main">
   <p:cSld>
     <p:spTree>
@@ -14135,7 +15517,7 @@
           <a:p>
             <a:fld id="{8E65201D-48DB-3B45-ABC2-018B1E66F34C}" type="slidenum">
               <a:rPr lang="en-US" smtClean="0"/>
-              <a:t>28</a:t>
+              <a:t>32</a:t>
             </a:fld>
             <a:endParaRPr lang="en-US"/>
           </a:p>
@@ -14154,7 +15536,7 @@
 </p:sld>
 </file>
 
-<file path=ppt/slides/slide29.xml><?xml version="1.0" encoding="utf-8"?>
+<file path=ppt/slides/slide33.xml><?xml version="1.0" encoding="utf-8"?>
 <p:sld xmlns:a="http://schemas.openxmlformats.org/drawingml/2006/main" xmlns:r="http://schemas.openxmlformats.org/officeDocument/2006/relationships" xmlns:p="http://schemas.openxmlformats.org/presentationml/2006/main">
   <p:cSld>
     <p:spTree>
@@ -14212,8 +15594,8 @@
           </a:p>
         </p:txBody>
       </p:sp>
-      <mc:AlternateContent xmlns:mc="http://schemas.openxmlformats.org/markup-compatibility/2006" xmlns:a14="http://schemas.microsoft.com/office/drawing/2010/main">
-        <mc:Choice Requires="a14">
+      <mc:AlternateContent xmlns:mc="http://schemas.openxmlformats.org/markup-compatibility/2006">
+        <mc:Choice xmlns:a14="http://schemas.microsoft.com/office/drawing/2010/main" Requires="a14">
           <p:sp>
             <p:nvSpPr>
               <p:cNvPr id="3" name="Content Placeholder 2">
@@ -14277,7 +15659,7 @@
                 </a14:m>
                 <a:r>
                   <a:rPr lang="en-US" sz="2000" dirty="0"/>
-                  <a:t> is temperature yesterday, </a:t>
+                  <a:t> is temperature, </a:t>
                 </a:r>
                 <a14:m>
                   <m:oMath xmlns:m="http://schemas.openxmlformats.org/officeDocument/2006/math">
@@ -14310,7 +15692,7 @@
                 </a14:m>
                 <a:r>
                   <a:rPr lang="en-US" sz="2000" dirty="0"/>
-                  <a:t> is rainfall yesterday</a:t>
+                  <a:t> is rainfall</a:t>
                 </a:r>
               </a:p>
               <a:p>
@@ -14375,7 +15757,7 @@
             </p:txBody>
           </p:sp>
         </mc:Choice>
-        <mc:Fallback xmlns="">
+        <mc:Fallback>
           <p:sp>
             <p:nvSpPr>
               <p:cNvPr id="3" name="Content Placeholder 2">
@@ -14400,7 +15782,7 @@
               <a:blipFill>
                 <a:blip r:embed="rId2"/>
                 <a:stretch>
-                  <a:fillRect l="-1311" t="-1713" r="-119"/>
+                  <a:fillRect l="-1238" t="-1942"/>
                 </a:stretch>
               </a:blipFill>
             </p:spPr>
@@ -14409,7 +15791,7 @@
               <a:lstStyle/>
               <a:p>
                 <a:r>
-                  <a:rPr lang="en-IE">
+                  <a:rPr lang="en-US">
                     <a:noFill/>
                   </a:rPr>
                   <a:t> </a:t>
@@ -14489,7 +15871,7 @@
                   <a:spcPts val="600"/>
                 </a:spcAft>
               </a:pPr>
-              <a:t>29</a:t>
+              <a:t>33</a:t>
             </a:fld>
             <a:endParaRPr lang="en-US" sz="1000"/>
           </a:p>
@@ -14508,233 +15890,7 @@
 </p:sld>
 </file>
 
-<file path=ppt/slides/slide3.xml><?xml version="1.0" encoding="utf-8"?>
-<p:sld xmlns:a="http://schemas.openxmlformats.org/drawingml/2006/main" xmlns:r="http://schemas.openxmlformats.org/officeDocument/2006/relationships" xmlns:p="http://schemas.openxmlformats.org/presentationml/2006/main">
-  <p:cSld>
-    <p:spTree>
-      <p:nvGrpSpPr>
-        <p:cNvPr id="1" name="">
-          <a:extLst>
-            <a:ext uri="{FF2B5EF4-FFF2-40B4-BE49-F238E27FC236}">
-              <a16:creationId xmlns:a16="http://schemas.microsoft.com/office/drawing/2014/main" id="{2E369361-7BB8-50C7-0B85-81FAACF39E4A}"/>
-            </a:ext>
-          </a:extLst>
-        </p:cNvPr>
-        <p:cNvGrpSpPr/>
-        <p:nvPr/>
-      </p:nvGrpSpPr>
-      <p:grpSpPr>
-        <a:xfrm>
-          <a:off x="0" y="0"/>
-          <a:ext cx="0" cy="0"/>
-          <a:chOff x="0" y="0"/>
-          <a:chExt cx="0" cy="0"/>
-        </a:xfrm>
-      </p:grpSpPr>
-      <p:sp>
-        <p:nvSpPr>
-          <p:cNvPr id="2" name="Title 1">
-            <a:extLst>
-              <a:ext uri="{FF2B5EF4-FFF2-40B4-BE49-F238E27FC236}">
-                <a16:creationId xmlns:a16="http://schemas.microsoft.com/office/drawing/2014/main" id="{C65AD364-1EC0-916C-8601-9F056E761DED}"/>
-              </a:ext>
-            </a:extLst>
-          </p:cNvPr>
-          <p:cNvSpPr>
-            <a:spLocks noGrp="1"/>
-          </p:cNvSpPr>
-          <p:nvPr>
-            <p:ph type="title"/>
-          </p:nvPr>
-        </p:nvSpPr>
-        <p:spPr/>
-        <p:txBody>
-          <a:bodyPr/>
-          <a:lstStyle/>
-          <a:p>
-            <a:r>
-              <a:rPr lang="en-US" dirty="0" err="1"/>
-              <a:t>Github</a:t>
-            </a:r>
-            <a:r>
-              <a:rPr lang="en-US" dirty="0"/>
-              <a:t> repo</a:t>
-            </a:r>
-          </a:p>
-        </p:txBody>
-      </p:sp>
-      <p:sp>
-        <p:nvSpPr>
-          <p:cNvPr id="3" name="Content Placeholder 2">
-            <a:extLst>
-              <a:ext uri="{FF2B5EF4-FFF2-40B4-BE49-F238E27FC236}">
-                <a16:creationId xmlns:a16="http://schemas.microsoft.com/office/drawing/2014/main" id="{72EB3572-F3A9-A8CD-B1B7-6558F6EAAEAD}"/>
-              </a:ext>
-            </a:extLst>
-          </p:cNvPr>
-          <p:cNvSpPr>
-            <a:spLocks noGrp="1"/>
-          </p:cNvSpPr>
-          <p:nvPr>
-            <p:ph idx="1"/>
-          </p:nvPr>
-        </p:nvSpPr>
-        <p:spPr/>
-        <p:txBody>
-          <a:bodyPr>
-            <a:normAutofit fontScale="85000" lnSpcReduction="10000"/>
-          </a:bodyPr>
-          <a:lstStyle/>
-          <a:p>
-            <a:r>
-              <a:rPr lang="en-US" dirty="0"/>
-              <a:t>All information at: </a:t>
-            </a:r>
-            <a:r>
-              <a:rPr lang="en-US" dirty="0">
-                <a:latin typeface="Courier New" panose="02070309020205020404" pitchFamily="49" charset="0"/>
-                <a:cs typeface="Courier New" panose="02070309020205020404" pitchFamily="49" charset="0"/>
-              </a:rPr>
-              <a:t>https://</a:t>
-            </a:r>
-            <a:r>
-              <a:rPr lang="en-US" dirty="0" err="1">
-                <a:latin typeface="Courier New" panose="02070309020205020404" pitchFamily="49" charset="0"/>
-                <a:cs typeface="Courier New" panose="02070309020205020404" pitchFamily="49" charset="0"/>
-              </a:rPr>
-              <a:t>github.com</a:t>
-            </a:r>
-            <a:r>
-              <a:rPr lang="en-US" dirty="0">
-                <a:latin typeface="Courier New" panose="02070309020205020404" pitchFamily="49" charset="0"/>
-                <a:cs typeface="Courier New" panose="02070309020205020404" pitchFamily="49" charset="0"/>
-              </a:rPr>
-              <a:t>/</a:t>
-            </a:r>
-            <a:r>
-              <a:rPr lang="en-US" dirty="0" err="1">
-                <a:latin typeface="Courier New" panose="02070309020205020404" pitchFamily="49" charset="0"/>
-                <a:cs typeface="Courier New" panose="02070309020205020404" pitchFamily="49" charset="0"/>
-              </a:rPr>
-              <a:t>andrewcparnell</a:t>
-            </a:r>
-            <a:r>
-              <a:rPr lang="en-US" dirty="0">
-                <a:latin typeface="Courier New" panose="02070309020205020404" pitchFamily="49" charset="0"/>
-                <a:cs typeface="Courier New" panose="02070309020205020404" pitchFamily="49" charset="0"/>
-              </a:rPr>
-              <a:t>/STAT41130</a:t>
-            </a:r>
-          </a:p>
-          <a:p>
-            <a:r>
-              <a:rPr lang="en-US" dirty="0"/>
-              <a:t>Contains slides (PPT files), code (Python script files), and worksheets (PDFs).</a:t>
-            </a:r>
-          </a:p>
-          <a:p>
-            <a:r>
-              <a:rPr lang="en-US" dirty="0"/>
-              <a:t>To access the material either:</a:t>
-            </a:r>
-          </a:p>
-          <a:p>
-            <a:pPr lvl="1"/>
-            <a:r>
-              <a:rPr lang="en-US" dirty="0"/>
-              <a:t>Use </a:t>
-            </a:r>
-            <a:r>
-              <a:rPr lang="en-US" dirty="0">
-                <a:latin typeface="Courier New" panose="02070309020205020404" pitchFamily="49" charset="0"/>
-                <a:cs typeface="Courier New" panose="02070309020205020404" pitchFamily="49" charset="0"/>
-              </a:rPr>
-              <a:t>git</a:t>
-            </a:r>
-            <a:r>
-              <a:rPr lang="en-US" dirty="0"/>
-              <a:t> directly to download the materials</a:t>
-            </a:r>
-          </a:p>
-          <a:p>
-            <a:pPr lvl="1"/>
-            <a:r>
-              <a:rPr lang="en-US" dirty="0"/>
-              <a:t>Go to the website and click: Code -&gt; Download Zip</a:t>
-            </a:r>
-          </a:p>
-          <a:p>
-            <a:r>
-              <a:rPr lang="en-US" dirty="0"/>
-              <a:t>If you find typos/bugs either:</a:t>
-            </a:r>
-          </a:p>
-          <a:p>
-            <a:pPr lvl="1"/>
-            <a:r>
-              <a:rPr lang="en-US" dirty="0"/>
-              <a:t>Let me know (basic)</a:t>
-            </a:r>
-          </a:p>
-          <a:p>
-            <a:pPr lvl="1"/>
-            <a:r>
-              <a:rPr lang="en-US" dirty="0"/>
-              <a:t>File an issue on the GitHub page (intermediate)</a:t>
-            </a:r>
-          </a:p>
-          <a:p>
-            <a:pPr lvl="1"/>
-            <a:r>
-              <a:rPr lang="en-US" dirty="0"/>
-              <a:t>Create a Pull Request and fix it yourself (advanced, and most helpful)</a:t>
-            </a:r>
-          </a:p>
-        </p:txBody>
-      </p:sp>
-      <p:sp>
-        <p:nvSpPr>
-          <p:cNvPr id="4" name="Slide Number Placeholder 3">
-            <a:extLst>
-              <a:ext uri="{FF2B5EF4-FFF2-40B4-BE49-F238E27FC236}">
-                <a16:creationId xmlns:a16="http://schemas.microsoft.com/office/drawing/2014/main" id="{09AC871B-19E6-0C6F-EDB7-E160D1101A44}"/>
-              </a:ext>
-            </a:extLst>
-          </p:cNvPr>
-          <p:cNvSpPr>
-            <a:spLocks noGrp="1"/>
-          </p:cNvSpPr>
-          <p:nvPr>
-            <p:ph type="sldNum" sz="quarter" idx="12"/>
-          </p:nvPr>
-        </p:nvSpPr>
-        <p:spPr/>
-        <p:txBody>
-          <a:bodyPr/>
-          <a:lstStyle/>
-          <a:p>
-            <a:fld id="{8E65201D-48DB-3B45-ABC2-018B1E66F34C}" type="slidenum">
-              <a:rPr lang="en-US" smtClean="0"/>
-              <a:t>3</a:t>
-            </a:fld>
-            <a:endParaRPr lang="en-US"/>
-          </a:p>
-        </p:txBody>
-      </p:sp>
-    </p:spTree>
-    <p:extLst>
-      <p:ext uri="{BB962C8B-B14F-4D97-AF65-F5344CB8AC3E}">
-        <p14:creationId xmlns:p14="http://schemas.microsoft.com/office/powerpoint/2010/main" val="994236747"/>
-      </p:ext>
-    </p:extLst>
-  </p:cSld>
-  <p:clrMapOvr>
-    <a:masterClrMapping/>
-  </p:clrMapOvr>
-</p:sld>
-</file>
-
-<file path=ppt/slides/slide30.xml><?xml version="1.0" encoding="utf-8"?>
+<file path=ppt/slides/slide34.xml><?xml version="1.0" encoding="utf-8"?>
 <p:sld xmlns:a="http://schemas.openxmlformats.org/drawingml/2006/main" xmlns:r="http://schemas.openxmlformats.org/officeDocument/2006/relationships" xmlns:p="http://schemas.openxmlformats.org/presentationml/2006/main">
   <p:cSld>
     <p:spTree>
@@ -15042,7 +16198,7 @@
           <a:p>
             <a:fld id="{8E65201D-48DB-3B45-ABC2-018B1E66F34C}" type="slidenum">
               <a:rPr lang="en-US" smtClean="0"/>
-              <a:t>30</a:t>
+              <a:t>34</a:t>
             </a:fld>
             <a:endParaRPr lang="en-US"/>
           </a:p>
@@ -15061,7 +16217,7 @@
 </p:sld>
 </file>
 
-<file path=ppt/slides/slide31.xml><?xml version="1.0" encoding="utf-8"?>
+<file path=ppt/slides/slide35.xml><?xml version="1.0" encoding="utf-8"?>
 <p:sld xmlns:a="http://schemas.openxmlformats.org/drawingml/2006/main" xmlns:r="http://schemas.openxmlformats.org/officeDocument/2006/relationships" xmlns:p="http://schemas.openxmlformats.org/presentationml/2006/main">
   <p:cSld>
     <p:spTree>
@@ -15442,7 +16598,7 @@
           <a:p>
             <a:fld id="{8E65201D-48DB-3B45-ABC2-018B1E66F34C}" type="slidenum">
               <a:rPr lang="en-US" smtClean="0"/>
-              <a:t>31</a:t>
+              <a:t>35</a:t>
             </a:fld>
             <a:endParaRPr lang="en-US"/>
           </a:p>
@@ -15461,7 +16617,7 @@
 </p:sld>
 </file>
 
-<file path=ppt/slides/slide32.xml><?xml version="1.0" encoding="utf-8"?>
+<file path=ppt/slides/slide36.xml><?xml version="1.0" encoding="utf-8"?>
 <p:sld xmlns:a="http://schemas.openxmlformats.org/drawingml/2006/main" xmlns:r="http://schemas.openxmlformats.org/officeDocument/2006/relationships" xmlns:p="http://schemas.openxmlformats.org/presentationml/2006/main">
   <p:cSld>
     <p:spTree>
@@ -15747,7 +16903,7 @@
                   <a:spcPts val="600"/>
                 </a:spcAft>
               </a:pPr>
-              <a:t>32</a:t>
+              <a:t>36</a:t>
             </a:fld>
             <a:endParaRPr lang="en-US" sz="1000">
               <a:solidFill>
@@ -15772,7 +16928,7 @@
 </p:sld>
 </file>
 
-<file path=ppt/slides/slide33.xml><?xml version="1.0" encoding="utf-8"?>
+<file path=ppt/slides/slide37.xml><?xml version="1.0" encoding="utf-8"?>
 <p:sld xmlns:a="http://schemas.openxmlformats.org/drawingml/2006/main" xmlns:r="http://schemas.openxmlformats.org/officeDocument/2006/relationships" xmlns:p="http://schemas.openxmlformats.org/presentationml/2006/main">
   <p:cSld>
     <p:spTree>
@@ -15846,7 +17002,7 @@
             </a:pPr>
             <a:r>
               <a:rPr lang="en-US" dirty="0"/>
-              <a:t>Key ingredients: loss function, prediction function, gradients.</a:t>
+              <a:t>Key ingredients: loss function, prediction function, gradients</a:t>
             </a:r>
           </a:p>
           <a:p>
@@ -15864,7 +17020,7 @@
             </a:r>
             <a:r>
               <a:rPr lang="en-US" dirty="0"/>
-              <a:t> the weights and the biases.</a:t>
+              <a:t> the weights and the biases</a:t>
             </a:r>
           </a:p>
           <a:p>
@@ -15874,7 +17030,7 @@
             </a:pPr>
             <a:r>
               <a:rPr lang="en-US" dirty="0"/>
-              <a:t>Run over epochs until the parameters converge.</a:t>
+              <a:t>Run over epochs until the parameters converge</a:t>
             </a:r>
           </a:p>
           <a:p>
@@ -15884,7 +17040,7 @@
             </a:pPr>
             <a:r>
               <a:rPr lang="en-US" dirty="0"/>
-              <a:t>Use the final values as your final model to predict.</a:t>
+              <a:t>Use the final values as your final model to predict</a:t>
             </a:r>
           </a:p>
           <a:p>
@@ -15902,7 +17058,7 @@
             </a:r>
             <a:r>
               <a:rPr lang="en-US" dirty="0"/>
-              <a:t> repository.</a:t>
+              <a:t> repository</a:t>
             </a:r>
           </a:p>
         </p:txBody>
@@ -15921,6 +17077,372 @@
 </file>
 
 <file path=ppt/slides/slide4.xml><?xml version="1.0" encoding="utf-8"?>
+<p:sld xmlns:a="http://schemas.openxmlformats.org/drawingml/2006/main" xmlns:r="http://schemas.openxmlformats.org/officeDocument/2006/relationships" xmlns:p="http://schemas.openxmlformats.org/presentationml/2006/main">
+  <p:cSld>
+    <p:spTree>
+      <p:nvGrpSpPr>
+        <p:cNvPr id="1" name=""/>
+        <p:cNvGrpSpPr/>
+        <p:nvPr/>
+      </p:nvGrpSpPr>
+      <p:grpSpPr>
+        <a:xfrm>
+          <a:off x="0" y="0"/>
+          <a:ext cx="0" cy="0"/>
+          <a:chOff x="0" y="0"/>
+          <a:chExt cx="0" cy="0"/>
+        </a:xfrm>
+      </p:grpSpPr>
+      <p:sp>
+        <p:nvSpPr>
+          <p:cNvPr id="2" name="Title 1">
+            <a:extLst>
+              <a:ext uri="{FF2B5EF4-FFF2-40B4-BE49-F238E27FC236}">
+                <a16:creationId xmlns:a16="http://schemas.microsoft.com/office/drawing/2014/main" id="{63CD1B87-1966-8E89-2962-DC3204622DBD}"/>
+              </a:ext>
+            </a:extLst>
+          </p:cNvPr>
+          <p:cNvSpPr>
+            <a:spLocks noGrp="1"/>
+          </p:cNvSpPr>
+          <p:nvPr>
+            <p:ph type="ctrTitle"/>
+          </p:nvPr>
+        </p:nvSpPr>
+        <p:spPr/>
+        <p:txBody>
+          <a:bodyPr/>
+          <a:lstStyle/>
+          <a:p>
+            <a:endParaRPr lang="en-US"/>
+          </a:p>
+        </p:txBody>
+      </p:sp>
+      <p:sp>
+        <p:nvSpPr>
+          <p:cNvPr id="3" name="Subtitle 2">
+            <a:extLst>
+              <a:ext uri="{FF2B5EF4-FFF2-40B4-BE49-F238E27FC236}">
+                <a16:creationId xmlns:a16="http://schemas.microsoft.com/office/drawing/2014/main" id="{F0A3567E-FC36-7941-7351-E09189A2FDBD}"/>
+              </a:ext>
+            </a:extLst>
+          </p:cNvPr>
+          <p:cNvSpPr>
+            <a:spLocks noGrp="1"/>
+          </p:cNvSpPr>
+          <p:nvPr>
+            <p:ph type="subTitle" idx="1"/>
+          </p:nvPr>
+        </p:nvSpPr>
+        <p:spPr/>
+        <p:txBody>
+          <a:bodyPr/>
+          <a:lstStyle/>
+          <a:p>
+            <a:endParaRPr lang="en-US"/>
+          </a:p>
+        </p:txBody>
+      </p:sp>
+      <p:sp>
+        <p:nvSpPr>
+          <p:cNvPr id="4" name="Date Placeholder 3">
+            <a:extLst>
+              <a:ext uri="{FF2B5EF4-FFF2-40B4-BE49-F238E27FC236}">
+                <a16:creationId xmlns:a16="http://schemas.microsoft.com/office/drawing/2014/main" id="{5AFC2028-5178-52BF-4586-FB92315110E7}"/>
+              </a:ext>
+            </a:extLst>
+          </p:cNvPr>
+          <p:cNvSpPr>
+            <a:spLocks noGrp="1"/>
+          </p:cNvSpPr>
+          <p:nvPr>
+            <p:ph type="dt" sz="half" idx="10"/>
+          </p:nvPr>
+        </p:nvSpPr>
+        <p:spPr/>
+        <p:txBody>
+          <a:bodyPr/>
+          <a:lstStyle/>
+          <a:p>
+            <a:fld id="{16F2FB5F-D553-C945-B874-A642CC0C851F}" type="datetime3">
+              <a:rPr lang="en-IE" smtClean="0"/>
+              <a:pPr/>
+              <a:t>15 February 2026</a:t>
+            </a:fld>
+            <a:endParaRPr lang="en-US" dirty="0"/>
+          </a:p>
+        </p:txBody>
+      </p:sp>
+      <p:pic>
+        <p:nvPicPr>
+          <p:cNvPr id="6" name="slide.url=https://www.polleverywhere.com/multiple_choice_polls/hWsbco8TWVs02D6zeGQK2?state=opened&amp;flow=Default&amp;onscreen=persist">
+            <a:extLst>
+              <a:ext uri="{FF2B5EF4-FFF2-40B4-BE49-F238E27FC236}">
+                <a16:creationId xmlns:a16="http://schemas.microsoft.com/office/drawing/2014/main" id="{7D73A2DC-225C-661F-920B-2DF4EFA4A389}"/>
+              </a:ext>
+            </a:extLst>
+          </p:cNvPr>
+          <p:cNvPicPr>
+            <a:picLocks/>
+          </p:cNvPicPr>
+          <p:nvPr/>
+        </p:nvPicPr>
+        <p:blipFill>
+          <a:blip r:embed="rId3"/>
+          <a:stretch>
+            <a:fillRect/>
+          </a:stretch>
+        </p:blipFill>
+        <p:spPr>
+          <a:xfrm>
+            <a:off x="63500" y="63500"/>
+            <a:ext cx="12065000" cy="6731000"/>
+          </a:xfrm>
+          <a:prstGeom prst="rect">
+            <a:avLst/>
+          </a:prstGeom>
+        </p:spPr>
+      </p:pic>
+    </p:spTree>
+    <p:extLst>
+      <p:ext uri="{BB962C8B-B14F-4D97-AF65-F5344CB8AC3E}">
+        <p14:creationId xmlns:p14="http://schemas.microsoft.com/office/powerpoint/2010/main" val="497456797"/>
+      </p:ext>
+    </p:extLst>
+  </p:cSld>
+  <p:clrMapOvr>
+    <a:masterClrMapping/>
+  </p:clrMapOvr>
+</p:sld>
+</file>
+
+<file path=ppt/slides/slide5.xml><?xml version="1.0" encoding="utf-8"?>
+<p:sld xmlns:a="http://schemas.openxmlformats.org/drawingml/2006/main" xmlns:r="http://schemas.openxmlformats.org/officeDocument/2006/relationships" xmlns:p="http://schemas.openxmlformats.org/presentationml/2006/main">
+  <p:cSld>
+    <p:spTree>
+      <p:nvGrpSpPr>
+        <p:cNvPr id="1" name="">
+          <a:extLst>
+            <a:ext uri="{FF2B5EF4-FFF2-40B4-BE49-F238E27FC236}">
+              <a16:creationId xmlns:a16="http://schemas.microsoft.com/office/drawing/2014/main" id="{2E369361-7BB8-50C7-0B85-81FAACF39E4A}"/>
+            </a:ext>
+          </a:extLst>
+        </p:cNvPr>
+        <p:cNvGrpSpPr/>
+        <p:nvPr/>
+      </p:nvGrpSpPr>
+      <p:grpSpPr>
+        <a:xfrm>
+          <a:off x="0" y="0"/>
+          <a:ext cx="0" cy="0"/>
+          <a:chOff x="0" y="0"/>
+          <a:chExt cx="0" cy="0"/>
+        </a:xfrm>
+      </p:grpSpPr>
+      <p:sp>
+        <p:nvSpPr>
+          <p:cNvPr id="2" name="Title 1">
+            <a:extLst>
+              <a:ext uri="{FF2B5EF4-FFF2-40B4-BE49-F238E27FC236}">
+                <a16:creationId xmlns:a16="http://schemas.microsoft.com/office/drawing/2014/main" id="{C65AD364-1EC0-916C-8601-9F056E761DED}"/>
+              </a:ext>
+            </a:extLst>
+          </p:cNvPr>
+          <p:cNvSpPr>
+            <a:spLocks noGrp="1"/>
+          </p:cNvSpPr>
+          <p:nvPr>
+            <p:ph type="title"/>
+          </p:nvPr>
+        </p:nvSpPr>
+        <p:spPr/>
+        <p:txBody>
+          <a:bodyPr/>
+          <a:lstStyle/>
+          <a:p>
+            <a:r>
+              <a:rPr lang="en-US" dirty="0" err="1"/>
+              <a:t>Github</a:t>
+            </a:r>
+            <a:r>
+              <a:rPr lang="en-US" dirty="0"/>
+              <a:t> repo</a:t>
+            </a:r>
+          </a:p>
+        </p:txBody>
+      </p:sp>
+      <p:sp>
+        <p:nvSpPr>
+          <p:cNvPr id="3" name="Content Placeholder 2">
+            <a:extLst>
+              <a:ext uri="{FF2B5EF4-FFF2-40B4-BE49-F238E27FC236}">
+                <a16:creationId xmlns:a16="http://schemas.microsoft.com/office/drawing/2014/main" id="{72EB3572-F3A9-A8CD-B1B7-6558F6EAAEAD}"/>
+              </a:ext>
+            </a:extLst>
+          </p:cNvPr>
+          <p:cNvSpPr>
+            <a:spLocks noGrp="1"/>
+          </p:cNvSpPr>
+          <p:nvPr>
+            <p:ph idx="1"/>
+          </p:nvPr>
+        </p:nvSpPr>
+        <p:spPr/>
+        <p:txBody>
+          <a:bodyPr>
+            <a:normAutofit fontScale="85000" lnSpcReduction="10000"/>
+          </a:bodyPr>
+          <a:lstStyle/>
+          <a:p>
+            <a:r>
+              <a:rPr lang="en-US" dirty="0"/>
+              <a:t>All information at: </a:t>
+            </a:r>
+            <a:r>
+              <a:rPr lang="en-US" dirty="0">
+                <a:latin typeface="Courier New" panose="02070309020205020404" pitchFamily="49" charset="0"/>
+                <a:cs typeface="Courier New" panose="02070309020205020404" pitchFamily="49" charset="0"/>
+              </a:rPr>
+              <a:t>https://</a:t>
+            </a:r>
+            <a:r>
+              <a:rPr lang="en-US" dirty="0" err="1">
+                <a:latin typeface="Courier New" panose="02070309020205020404" pitchFamily="49" charset="0"/>
+                <a:cs typeface="Courier New" panose="02070309020205020404" pitchFamily="49" charset="0"/>
+              </a:rPr>
+              <a:t>github.com</a:t>
+            </a:r>
+            <a:r>
+              <a:rPr lang="en-US" dirty="0">
+                <a:latin typeface="Courier New" panose="02070309020205020404" pitchFamily="49" charset="0"/>
+                <a:cs typeface="Courier New" panose="02070309020205020404" pitchFamily="49" charset="0"/>
+              </a:rPr>
+              <a:t>/</a:t>
+            </a:r>
+            <a:r>
+              <a:rPr lang="en-US" dirty="0" err="1">
+                <a:latin typeface="Courier New" panose="02070309020205020404" pitchFamily="49" charset="0"/>
+                <a:cs typeface="Courier New" panose="02070309020205020404" pitchFamily="49" charset="0"/>
+              </a:rPr>
+              <a:t>andrewcparnell</a:t>
+            </a:r>
+            <a:r>
+              <a:rPr lang="en-US" dirty="0">
+                <a:latin typeface="Courier New" panose="02070309020205020404" pitchFamily="49" charset="0"/>
+                <a:cs typeface="Courier New" panose="02070309020205020404" pitchFamily="49" charset="0"/>
+              </a:rPr>
+              <a:t>/STAT41130</a:t>
+            </a:r>
+          </a:p>
+          <a:p>
+            <a:r>
+              <a:rPr lang="en-US" dirty="0"/>
+              <a:t>Contains slides (PPT files), code (Python script files), and worksheets (PDFs).</a:t>
+            </a:r>
+          </a:p>
+          <a:p>
+            <a:r>
+              <a:rPr lang="en-US" dirty="0"/>
+              <a:t>To access the material either:</a:t>
+            </a:r>
+          </a:p>
+          <a:p>
+            <a:pPr lvl="1"/>
+            <a:r>
+              <a:rPr lang="en-US" dirty="0"/>
+              <a:t>Use </a:t>
+            </a:r>
+            <a:r>
+              <a:rPr lang="en-US" dirty="0">
+                <a:latin typeface="Courier New" panose="02070309020205020404" pitchFamily="49" charset="0"/>
+                <a:cs typeface="Courier New" panose="02070309020205020404" pitchFamily="49" charset="0"/>
+              </a:rPr>
+              <a:t>git</a:t>
+            </a:r>
+            <a:r>
+              <a:rPr lang="en-US" dirty="0"/>
+              <a:t> directly to download the materials</a:t>
+            </a:r>
+          </a:p>
+          <a:p>
+            <a:pPr lvl="1"/>
+            <a:r>
+              <a:rPr lang="en-US" dirty="0"/>
+              <a:t>Go to the website and click: Code -&gt; Download Zip</a:t>
+            </a:r>
+          </a:p>
+          <a:p>
+            <a:r>
+              <a:rPr lang="en-US" dirty="0"/>
+              <a:t>If you find typos/bugs either:</a:t>
+            </a:r>
+          </a:p>
+          <a:p>
+            <a:pPr lvl="1"/>
+            <a:r>
+              <a:rPr lang="en-US" dirty="0"/>
+              <a:t>Let me know (basic)</a:t>
+            </a:r>
+          </a:p>
+          <a:p>
+            <a:pPr lvl="1"/>
+            <a:r>
+              <a:rPr lang="en-US" dirty="0"/>
+              <a:t>File an issue on the GitHub page (intermediate)</a:t>
+            </a:r>
+          </a:p>
+          <a:p>
+            <a:pPr lvl="1"/>
+            <a:r>
+              <a:rPr lang="en-US" dirty="0"/>
+              <a:t>Create a Pull Request and fix it yourself (advanced, and most helpful)</a:t>
+            </a:r>
+          </a:p>
+        </p:txBody>
+      </p:sp>
+      <p:sp>
+        <p:nvSpPr>
+          <p:cNvPr id="4" name="Slide Number Placeholder 3">
+            <a:extLst>
+              <a:ext uri="{FF2B5EF4-FFF2-40B4-BE49-F238E27FC236}">
+                <a16:creationId xmlns:a16="http://schemas.microsoft.com/office/drawing/2014/main" id="{09AC871B-19E6-0C6F-EDB7-E160D1101A44}"/>
+              </a:ext>
+            </a:extLst>
+          </p:cNvPr>
+          <p:cNvSpPr>
+            <a:spLocks noGrp="1"/>
+          </p:cNvSpPr>
+          <p:nvPr>
+            <p:ph type="sldNum" sz="quarter" idx="12"/>
+          </p:nvPr>
+        </p:nvSpPr>
+        <p:spPr/>
+        <p:txBody>
+          <a:bodyPr/>
+          <a:lstStyle/>
+          <a:p>
+            <a:fld id="{8E65201D-48DB-3B45-ABC2-018B1E66F34C}" type="slidenum">
+              <a:rPr lang="en-US" smtClean="0"/>
+              <a:t>5</a:t>
+            </a:fld>
+            <a:endParaRPr lang="en-US"/>
+          </a:p>
+        </p:txBody>
+      </p:sp>
+    </p:spTree>
+    <p:extLst>
+      <p:ext uri="{BB962C8B-B14F-4D97-AF65-F5344CB8AC3E}">
+        <p14:creationId xmlns:p14="http://schemas.microsoft.com/office/powerpoint/2010/main" val="994236747"/>
+      </p:ext>
+    </p:extLst>
+  </p:cSld>
+  <p:clrMapOvr>
+    <a:masterClrMapping/>
+  </p:clrMapOvr>
+</p:sld>
+</file>
+
+<file path=ppt/slides/slide6.xml><?xml version="1.0" encoding="utf-8"?>
 <p:sld xmlns:a="http://schemas.openxmlformats.org/drawingml/2006/main" xmlns:r="http://schemas.openxmlformats.org/officeDocument/2006/relationships" xmlns:p="http://schemas.openxmlformats.org/presentationml/2006/main">
   <p:cSld>
     <p:spTree>
@@ -16039,29 +17561,18 @@
           <a:p>
             <a:r>
               <a:rPr lang="en-US" dirty="0"/>
-              <a:t>Install the requirements in the </a:t>
+              <a:t>Install the requirements in one (or more) of the </a:t>
             </a:r>
             <a:r>
               <a:rPr lang="en-US" dirty="0">
                 <a:latin typeface="Courier New" panose="02070309020205020404" pitchFamily="49" charset="0"/>
                 <a:cs typeface="Courier New" panose="02070309020205020404" pitchFamily="49" charset="0"/>
               </a:rPr>
-              <a:t>requirements_ECMWF.txt </a:t>
+              <a:t>requirements_*.txt</a:t>
             </a:r>
             <a:r>
               <a:rPr lang="en-US" dirty="0"/>
-              <a:t>file (Mac/Linux) or </a:t>
-            </a:r>
-            <a:r>
-              <a:rPr lang="en-US" dirty="0">
-                <a:latin typeface="Courier New" panose="02070309020205020404" pitchFamily="49" charset="0"/>
-                <a:cs typeface="Courier New" panose="02070309020205020404" pitchFamily="49" charset="0"/>
-              </a:rPr>
-              <a:t>requirements_ECMWF_win.txt</a:t>
-            </a:r>
-            <a:r>
-              <a:rPr lang="en-US" dirty="0"/>
-              <a:t> (windows)</a:t>
+              <a:t> files</a:t>
             </a:r>
           </a:p>
         </p:txBody>
@@ -16089,7 +17600,7 @@
           <a:p>
             <a:fld id="{8E65201D-48DB-3B45-ABC2-018B1E66F34C}" type="slidenum">
               <a:rPr lang="en-US" smtClean="0"/>
-              <a:t>4</a:t>
+              <a:t>6</a:t>
             </a:fld>
             <a:endParaRPr lang="en-US"/>
           </a:p>
@@ -16108,7 +17619,7 @@
 </p:sld>
 </file>
 
-<file path=ppt/slides/slide5.xml><?xml version="1.0" encoding="utf-8"?>
+<file path=ppt/slides/slide7.xml><?xml version="1.0" encoding="utf-8"?>
 <p:sld xmlns:a="http://schemas.openxmlformats.org/drawingml/2006/main" xmlns:r="http://schemas.openxmlformats.org/officeDocument/2006/relationships" xmlns:p="http://schemas.openxmlformats.org/presentationml/2006/main">
   <p:cSld>
     <p:spTree>
@@ -16190,7 +17701,7 @@
           <a:p>
             <a:fld id="{8E65201D-48DB-3B45-ABC2-018B1E66F34C}" type="slidenum">
               <a:rPr lang="en-US" smtClean="0"/>
-              <a:t>5</a:t>
+              <a:t>7</a:t>
             </a:fld>
             <a:endParaRPr lang="en-US"/>
           </a:p>
@@ -16240,7 +17751,7 @@
 </p:sld>
 </file>
 
-<file path=ppt/slides/slide6.xml><?xml version="1.0" encoding="utf-8"?>
+<file path=ppt/slides/slide8.xml><?xml version="1.0" encoding="utf-8"?>
 <p:sld xmlns:a="http://schemas.openxmlformats.org/drawingml/2006/main" xmlns:r="http://schemas.openxmlformats.org/officeDocument/2006/relationships" xmlns:p="http://schemas.openxmlformats.org/presentationml/2006/main">
   <p:cSld>
     <p:spTree>
@@ -16315,7 +17826,15 @@
           <a:p>
             <a:r>
               <a:rPr lang="en-US" dirty="0"/>
-              <a:t>Designed for students with either AI or weather/climate background</a:t>
+              <a:t>Designed for students with </a:t>
+            </a:r>
+            <a:r>
+              <a:rPr lang="en-US" i="1" dirty="0"/>
+              <a:t>either</a:t>
+            </a:r>
+            <a:r>
+              <a:rPr lang="en-US" dirty="0"/>
+              <a:t> AI or weather/climate background</a:t>
             </a:r>
           </a:p>
           <a:p>
@@ -16506,7 +18025,7 @@
           <a:p>
             <a:fld id="{8E65201D-48DB-3B45-ABC2-018B1E66F34C}" type="slidenum">
               <a:rPr lang="en-US" smtClean="0"/>
-              <a:t>6</a:t>
+              <a:t>8</a:t>
             </a:fld>
             <a:endParaRPr lang="en-US"/>
           </a:p>
@@ -16611,7 +18130,7 @@
 </p:sld>
 </file>
 
-<file path=ppt/slides/slide7.xml><?xml version="1.0" encoding="utf-8"?>
+<file path=ppt/slides/slide9.xml><?xml version="1.0" encoding="utf-8"?>
 <p:sld xmlns:a="http://schemas.openxmlformats.org/drawingml/2006/main" xmlns:r="http://schemas.openxmlformats.org/officeDocument/2006/relationships" xmlns:p="http://schemas.openxmlformats.org/presentationml/2006/main">
   <p:cSld>
     <p:spTree>
@@ -16675,7 +18194,7 @@
         <p:spPr/>
         <p:txBody>
           <a:bodyPr>
-            <a:normAutofit/>
+            <a:normAutofit lnSpcReduction="10000"/>
           </a:bodyPr>
           <a:lstStyle/>
           <a:p>
@@ -16695,7 +18214,7 @@
             <a:pPr lvl="1"/>
             <a:r>
               <a:rPr lang="en-US" dirty="0"/>
-              <a:t>1 ~1-hour guided coding class</a:t>
+              <a:t>Short introduction to coding challenges</a:t>
             </a:r>
           </a:p>
           <a:p>
@@ -16739,6 +18258,20 @@
             <a:r>
               <a:rPr lang="en-US" dirty="0"/>
               <a:t>Expect to create short presentations, coding tasks, and pen-and-paper exercises</a:t>
+            </a:r>
+          </a:p>
+          <a:p>
+            <a:r>
+              <a:rPr lang="en-US" dirty="0">
+                <a:solidFill>
+                  <a:srgbClr val="009749"/>
+                </a:solidFill>
+              </a:rPr>
+              <a:t>Green text</a:t>
+            </a:r>
+            <a:r>
+              <a:rPr lang="en-US" dirty="0"/>
+              <a:t> means we go to the board</a:t>
             </a:r>
           </a:p>
         </p:txBody>
@@ -16766,7 +18299,7 @@
           <a:p>
             <a:fld id="{8E65201D-48DB-3B45-ABC2-018B1E66F34C}" type="slidenum">
               <a:rPr lang="en-US" smtClean="0"/>
-              <a:t>7</a:t>
+              <a:t>9</a:t>
             </a:fld>
             <a:endParaRPr lang="en-US"/>
           </a:p>
@@ -16776,334 +18309,6 @@
     <p:extLst>
       <p:ext uri="{BB962C8B-B14F-4D97-AF65-F5344CB8AC3E}">
         <p14:creationId xmlns:p14="http://schemas.microsoft.com/office/powerpoint/2010/main" val="3904630008"/>
-      </p:ext>
-    </p:extLst>
-  </p:cSld>
-  <p:clrMapOvr>
-    <a:masterClrMapping/>
-  </p:clrMapOvr>
-</p:sld>
-</file>
-
-<file path=ppt/slides/slide8.xml><?xml version="1.0" encoding="utf-8"?>
-<p:sld xmlns:a="http://schemas.openxmlformats.org/drawingml/2006/main" xmlns:r="http://schemas.openxmlformats.org/officeDocument/2006/relationships" xmlns:p="http://schemas.openxmlformats.org/presentationml/2006/main">
-  <p:cSld>
-    <p:spTree>
-      <p:nvGrpSpPr>
-        <p:cNvPr id="1" name=""/>
-        <p:cNvGrpSpPr/>
-        <p:nvPr/>
-      </p:nvGrpSpPr>
-      <p:grpSpPr>
-        <a:xfrm>
-          <a:off x="0" y="0"/>
-          <a:ext cx="0" cy="0"/>
-          <a:chOff x="0" y="0"/>
-          <a:chExt cx="0" cy="0"/>
-        </a:xfrm>
-      </p:grpSpPr>
-      <p:sp>
-        <p:nvSpPr>
-          <p:cNvPr id="2" name="Title 1">
-            <a:extLst>
-              <a:ext uri="{FF2B5EF4-FFF2-40B4-BE49-F238E27FC236}">
-                <a16:creationId xmlns:a16="http://schemas.microsoft.com/office/drawing/2014/main" id="{5F404B0A-99AF-1B23-9CEF-CC62D701AE52}"/>
-              </a:ext>
-            </a:extLst>
-          </p:cNvPr>
-          <p:cNvSpPr>
-            <a:spLocks noGrp="1"/>
-          </p:cNvSpPr>
-          <p:nvPr>
-            <p:ph type="title"/>
-          </p:nvPr>
-        </p:nvSpPr>
-        <p:spPr/>
-        <p:txBody>
-          <a:bodyPr/>
-          <a:lstStyle/>
-          <a:p>
-            <a:r>
-              <a:rPr lang="en-US" dirty="0"/>
-              <a:t>Syllabus (week 1)</a:t>
-            </a:r>
-          </a:p>
-        </p:txBody>
-      </p:sp>
-      <p:sp>
-        <p:nvSpPr>
-          <p:cNvPr id="3" name="Content Placeholder 2">
-            <a:extLst>
-              <a:ext uri="{FF2B5EF4-FFF2-40B4-BE49-F238E27FC236}">
-                <a16:creationId xmlns:a16="http://schemas.microsoft.com/office/drawing/2014/main" id="{F5DB8611-2EDA-8CDF-8AA2-9AC795A3FB33}"/>
-              </a:ext>
-            </a:extLst>
-          </p:cNvPr>
-          <p:cNvSpPr>
-            <a:spLocks noGrp="1"/>
-          </p:cNvSpPr>
-          <p:nvPr>
-            <p:ph idx="1"/>
-          </p:nvPr>
-        </p:nvSpPr>
-        <p:spPr/>
-        <p:txBody>
-          <a:bodyPr/>
-          <a:lstStyle/>
-          <a:p>
-            <a:r>
-              <a:rPr lang="en-US" dirty="0"/>
-              <a:t>Linear regression and neural networks</a:t>
-            </a:r>
-          </a:p>
-          <a:p>
-            <a:r>
-              <a:rPr lang="en-US" dirty="0"/>
-              <a:t>NNs and back-propagation</a:t>
-            </a:r>
-          </a:p>
-          <a:p>
-            <a:r>
-              <a:rPr lang="en-US" dirty="0"/>
-              <a:t>Deep learning</a:t>
-            </a:r>
-          </a:p>
-          <a:p>
-            <a:r>
-              <a:rPr lang="en-US" dirty="0"/>
-              <a:t>Convolutional NNs</a:t>
-            </a:r>
-          </a:p>
-          <a:p>
-            <a:r>
-              <a:rPr lang="en-US" dirty="0"/>
-              <a:t>Recurrent NNs</a:t>
-            </a:r>
-          </a:p>
-          <a:p>
-            <a:r>
-              <a:rPr lang="en-US" dirty="0"/>
-              <a:t>Transformers</a:t>
-            </a:r>
-          </a:p>
-          <a:p>
-            <a:r>
-              <a:rPr lang="en-US" dirty="0"/>
-              <a:t>Graph NNs</a:t>
-            </a:r>
-          </a:p>
-          <a:p>
-            <a:r>
-              <a:rPr lang="en-US" dirty="0"/>
-              <a:t>Probabilistic forecasting with NNs</a:t>
-            </a:r>
-          </a:p>
-        </p:txBody>
-      </p:sp>
-      <p:sp>
-        <p:nvSpPr>
-          <p:cNvPr id="4" name="Slide Number Placeholder 3">
-            <a:extLst>
-              <a:ext uri="{FF2B5EF4-FFF2-40B4-BE49-F238E27FC236}">
-                <a16:creationId xmlns:a16="http://schemas.microsoft.com/office/drawing/2014/main" id="{B6B5E9C3-1976-DACA-3AE2-28F5B2DD6781}"/>
-              </a:ext>
-            </a:extLst>
-          </p:cNvPr>
-          <p:cNvSpPr>
-            <a:spLocks noGrp="1"/>
-          </p:cNvSpPr>
-          <p:nvPr>
-            <p:ph type="sldNum" sz="quarter" idx="12"/>
-          </p:nvPr>
-        </p:nvSpPr>
-        <p:spPr/>
-        <p:txBody>
-          <a:bodyPr/>
-          <a:lstStyle/>
-          <a:p>
-            <a:fld id="{8E65201D-48DB-3B45-ABC2-018B1E66F34C}" type="slidenum">
-              <a:rPr lang="en-US" smtClean="0"/>
-              <a:t>8</a:t>
-            </a:fld>
-            <a:endParaRPr lang="en-US"/>
-          </a:p>
-        </p:txBody>
-      </p:sp>
-    </p:spTree>
-    <p:extLst>
-      <p:ext uri="{BB962C8B-B14F-4D97-AF65-F5344CB8AC3E}">
-        <p14:creationId xmlns:p14="http://schemas.microsoft.com/office/powerpoint/2010/main" val="4278662269"/>
-      </p:ext>
-    </p:extLst>
-  </p:cSld>
-  <p:clrMapOvr>
-    <a:masterClrMapping/>
-  </p:clrMapOvr>
-</p:sld>
-</file>
-
-<file path=ppt/slides/slide9.xml><?xml version="1.0" encoding="utf-8"?>
-<p:sld xmlns:a="http://schemas.openxmlformats.org/drawingml/2006/main" xmlns:r="http://schemas.openxmlformats.org/officeDocument/2006/relationships" xmlns:p="http://schemas.openxmlformats.org/presentationml/2006/main">
-  <p:cSld>
-    <p:spTree>
-      <p:nvGrpSpPr>
-        <p:cNvPr id="1" name="">
-          <a:extLst>
-            <a:ext uri="{FF2B5EF4-FFF2-40B4-BE49-F238E27FC236}">
-              <a16:creationId xmlns:a16="http://schemas.microsoft.com/office/drawing/2014/main" id="{53911DA0-E8E2-7F7E-C1FA-DA29DD79B2E7}"/>
-            </a:ext>
-          </a:extLst>
-        </p:cNvPr>
-        <p:cNvGrpSpPr/>
-        <p:nvPr/>
-      </p:nvGrpSpPr>
-      <p:grpSpPr>
-        <a:xfrm>
-          <a:off x="0" y="0"/>
-          <a:ext cx="0" cy="0"/>
-          <a:chOff x="0" y="0"/>
-          <a:chExt cx="0" cy="0"/>
-        </a:xfrm>
-      </p:grpSpPr>
-      <p:sp>
-        <p:nvSpPr>
-          <p:cNvPr id="2" name="Title 1">
-            <a:extLst>
-              <a:ext uri="{FF2B5EF4-FFF2-40B4-BE49-F238E27FC236}">
-                <a16:creationId xmlns:a16="http://schemas.microsoft.com/office/drawing/2014/main" id="{D5EB629C-5A78-79DC-8BF5-FA033BE05BFA}"/>
-              </a:ext>
-            </a:extLst>
-          </p:cNvPr>
-          <p:cNvSpPr>
-            <a:spLocks noGrp="1"/>
-          </p:cNvSpPr>
-          <p:nvPr>
-            <p:ph type="title"/>
-          </p:nvPr>
-        </p:nvSpPr>
-        <p:spPr/>
-        <p:txBody>
-          <a:bodyPr/>
-          <a:lstStyle/>
-          <a:p>
-            <a:r>
-              <a:rPr lang="en-US" dirty="0"/>
-              <a:t>Syllabus (week 2)</a:t>
-            </a:r>
-          </a:p>
-        </p:txBody>
-      </p:sp>
-      <p:sp>
-        <p:nvSpPr>
-          <p:cNvPr id="3" name="Content Placeholder 2">
-            <a:extLst>
-              <a:ext uri="{FF2B5EF4-FFF2-40B4-BE49-F238E27FC236}">
-                <a16:creationId xmlns:a16="http://schemas.microsoft.com/office/drawing/2014/main" id="{B771B038-32D6-BA06-2580-C5C6C714DB2F}"/>
-              </a:ext>
-            </a:extLst>
-          </p:cNvPr>
-          <p:cNvSpPr>
-            <a:spLocks noGrp="1"/>
-          </p:cNvSpPr>
-          <p:nvPr>
-            <p:ph idx="1"/>
-          </p:nvPr>
-        </p:nvSpPr>
-        <p:spPr/>
-        <p:txBody>
-          <a:bodyPr/>
-          <a:lstStyle/>
-          <a:p>
-            <a:r>
-              <a:rPr lang="en-US" dirty="0"/>
-              <a:t>Graph Convolutional Neural Networks</a:t>
-            </a:r>
-          </a:p>
-          <a:p>
-            <a:r>
-              <a:rPr lang="en-US" dirty="0"/>
-              <a:t>Overview – data-driven weather forecasting</a:t>
-            </a:r>
-          </a:p>
-          <a:p>
-            <a:r>
-              <a:rPr lang="en-US" dirty="0"/>
-              <a:t>AIFS / Anemoi</a:t>
-            </a:r>
-          </a:p>
-          <a:p>
-            <a:r>
-              <a:rPr lang="en-US" dirty="0"/>
-              <a:t>Other topics (if time):</a:t>
-            </a:r>
-          </a:p>
-          <a:p>
-            <a:pPr lvl="1"/>
-            <a:r>
-              <a:rPr lang="en-US" dirty="0"/>
-              <a:t>Bayesian inference</a:t>
-            </a:r>
-          </a:p>
-          <a:p>
-            <a:pPr lvl="1"/>
-            <a:r>
-              <a:rPr lang="en-US" dirty="0"/>
-              <a:t>SERT</a:t>
-            </a:r>
-          </a:p>
-          <a:p>
-            <a:pPr lvl="1"/>
-            <a:r>
-              <a:rPr lang="en-US" dirty="0" err="1"/>
-              <a:t>Github</a:t>
-            </a:r>
-            <a:endParaRPr lang="en-US" dirty="0"/>
-          </a:p>
-          <a:p>
-            <a:pPr lvl="1"/>
-            <a:r>
-              <a:rPr lang="en-US" dirty="0"/>
-              <a:t>Overleaf</a:t>
-            </a:r>
-          </a:p>
-          <a:p>
-            <a:endParaRPr lang="en-US" dirty="0"/>
-          </a:p>
-        </p:txBody>
-      </p:sp>
-      <p:sp>
-        <p:nvSpPr>
-          <p:cNvPr id="4" name="Slide Number Placeholder 3">
-            <a:extLst>
-              <a:ext uri="{FF2B5EF4-FFF2-40B4-BE49-F238E27FC236}">
-                <a16:creationId xmlns:a16="http://schemas.microsoft.com/office/drawing/2014/main" id="{F989814A-DE5D-C67D-CB2E-AC4F29717528}"/>
-              </a:ext>
-            </a:extLst>
-          </p:cNvPr>
-          <p:cNvSpPr>
-            <a:spLocks noGrp="1"/>
-          </p:cNvSpPr>
-          <p:nvPr>
-            <p:ph type="sldNum" sz="quarter" idx="12"/>
-          </p:nvPr>
-        </p:nvSpPr>
-        <p:spPr/>
-        <p:txBody>
-          <a:bodyPr/>
-          <a:lstStyle/>
-          <a:p>
-            <a:fld id="{8E65201D-48DB-3B45-ABC2-018B1E66F34C}" type="slidenum">
-              <a:rPr lang="en-US" smtClean="0"/>
-              <a:t>9</a:t>
-            </a:fld>
-            <a:endParaRPr lang="en-US"/>
-          </a:p>
-        </p:txBody>
-      </p:sp>
-    </p:spTree>
-    <p:extLst>
-      <p:ext uri="{BB962C8B-B14F-4D97-AF65-F5344CB8AC3E}">
-        <p14:creationId xmlns:p14="http://schemas.microsoft.com/office/powerpoint/2010/main" val="345519520"/>
       </p:ext>
     </p:extLst>
   </p:cSld>

</xml_diff>

<commit_message>
Fix typos in days 1 - 3
</commit_message>
<xml_diff>
--- a/slides/day 1/D1C1_LR_NNs.pptx
+++ b/slides/day 1/D1C1_LR_NNs.pptx
@@ -10549,8 +10549,8 @@
           </a:p>
         </p:txBody>
       </p:sp>
-      <mc:AlternateContent xmlns:mc="http://schemas.openxmlformats.org/markup-compatibility/2006" xmlns:a14="http://schemas.microsoft.com/office/drawing/2010/main">
-        <mc:Choice Requires="a14">
+      <mc:AlternateContent xmlns:mc="http://schemas.openxmlformats.org/markup-compatibility/2006">
+        <mc:Choice xmlns:a14="http://schemas.microsoft.com/office/drawing/2010/main" Requires="a14">
           <p:sp>
             <p:nvSpPr>
               <p:cNvPr id="3" name="Content Placeholder 2">
@@ -10761,7 +10761,15 @@
                 </a14:m>
                 <a:r>
                   <a:rPr lang="en-US" dirty="0"/>
-                  <a:t> be a residual (or error) leftover term </a:t>
+                  <a:t> be a residual (or error or </a:t>
+                </a:r>
+                <a:r>
+                  <a:rPr lang="en-US" i="1" dirty="0"/>
+                  <a:t>loss</a:t>
+                </a:r>
+                <a:r>
+                  <a:rPr lang="en-US" dirty="0"/>
+                  <a:t>) leftover term </a:t>
                 </a:r>
                 <a14:m>
                   <m:oMath xmlns:m="http://schemas.openxmlformats.org/officeDocument/2006/math">
@@ -10814,7 +10822,15 @@
               <a:p>
                 <a:r>
                   <a:rPr lang="en-US" dirty="0"/>
-                  <a:t>Idea: optimize the values of </a:t>
+                  <a:t>Idea: </a:t>
+                </a:r>
+                <a:r>
+                  <a:rPr lang="en-US" dirty="0" err="1"/>
+                  <a:t>optimise</a:t>
+                </a:r>
+                <a:r>
+                  <a:rPr lang="en-US" dirty="0"/>
+                  <a:t> the values of </a:t>
                 </a:r>
                 <a14:m>
                   <m:oMath xmlns:m="http://schemas.openxmlformats.org/officeDocument/2006/math">
@@ -11040,7 +11056,7 @@
             </p:txBody>
           </p:sp>
         </mc:Choice>
-        <mc:Fallback xmlns="">
+        <mc:Fallback>
           <p:sp>
             <p:nvSpPr>
               <p:cNvPr id="3" name="Content Placeholder 2">
@@ -11061,7 +11077,7 @@
               <a:blipFill>
                 <a:blip r:embed="rId2"/>
                 <a:stretch>
-                  <a:fillRect l="-1216" t="-2134" b="-13415"/>
+                  <a:fillRect l="-1216" t="-2134" b="-21951"/>
                 </a:stretch>
               </a:blipFill>
             </p:spPr>
@@ -11229,31 +11245,24 @@
               <a:buNone/>
             </a:pPr>
             <a:r>
+              <a:rPr lang="en-US" sz="2400" dirty="0">
+                <a:latin typeface="Courier New" panose="02070309020205020404" pitchFamily="49" charset="0"/>
+                <a:cs typeface="Courier New" panose="02070309020205020404" pitchFamily="49" charset="0"/>
+              </a:rPr>
+              <a:t>loss = </a:t>
+            </a:r>
+            <a:r>
               <a:rPr lang="en-US" sz="2400" dirty="0" err="1">
                 <a:latin typeface="Courier New" panose="02070309020205020404" pitchFamily="49" charset="0"/>
                 <a:cs typeface="Courier New" panose="02070309020205020404" pitchFamily="49" charset="0"/>
               </a:rPr>
-              <a:t>sum_of_squares</a:t>
+              <a:t>np.sum</a:t>
             </a:r>
             <a:r>
               <a:rPr lang="en-US" sz="2400" dirty="0">
                 <a:latin typeface="Courier New" panose="02070309020205020404" pitchFamily="49" charset="0"/>
                 <a:cs typeface="Courier New" panose="02070309020205020404" pitchFamily="49" charset="0"/>
               </a:rPr>
-              <a:t> = </a:t>
-            </a:r>
-            <a:r>
-              <a:rPr lang="en-US" sz="2400" dirty="0" err="1">
-                <a:latin typeface="Courier New" panose="02070309020205020404" pitchFamily="49" charset="0"/>
-                <a:cs typeface="Courier New" panose="02070309020205020404" pitchFamily="49" charset="0"/>
-              </a:rPr>
-              <a:t>np.sum</a:t>
-            </a:r>
-            <a:r>
-              <a:rPr lang="en-US" sz="2400" dirty="0">
-                <a:latin typeface="Courier New" panose="02070309020205020404" pitchFamily="49" charset="0"/>
-                <a:cs typeface="Courier New" panose="02070309020205020404" pitchFamily="49" charset="0"/>
-              </a:rPr>
               <a:t>((y - (b + w * X)) ** 2)</a:t>
             </a:r>
           </a:p>
@@ -11266,7 +11275,7 @@
                 <a:latin typeface="Courier New" panose="02070309020205020404" pitchFamily="49" charset="0"/>
                 <a:cs typeface="Courier New" panose="02070309020205020404" pitchFamily="49" charset="0"/>
               </a:rPr>
-              <a:t># Residual sum of squares for b=1, w=1: 3.74</a:t>
+              <a:t># Loss for b=1, w=1: 3.74</a:t>
             </a:r>
           </a:p>
           <a:p>
@@ -11307,31 +11316,24 @@
               <a:buNone/>
             </a:pPr>
             <a:r>
+              <a:rPr lang="en-US" sz="2400" dirty="0">
+                <a:latin typeface="Courier New" panose="02070309020205020404" pitchFamily="49" charset="0"/>
+                <a:cs typeface="Courier New" panose="02070309020205020404" pitchFamily="49" charset="0"/>
+              </a:rPr>
+              <a:t>loss = </a:t>
+            </a:r>
+            <a:r>
               <a:rPr lang="en-US" sz="2400" dirty="0" err="1">
                 <a:latin typeface="Courier New" panose="02070309020205020404" pitchFamily="49" charset="0"/>
                 <a:cs typeface="Courier New" panose="02070309020205020404" pitchFamily="49" charset="0"/>
               </a:rPr>
-              <a:t>sum_of_squares</a:t>
+              <a:t>np.sum</a:t>
             </a:r>
             <a:r>
               <a:rPr lang="en-US" sz="2400" dirty="0">
                 <a:latin typeface="Courier New" panose="02070309020205020404" pitchFamily="49" charset="0"/>
                 <a:cs typeface="Courier New" panose="02070309020205020404" pitchFamily="49" charset="0"/>
               </a:rPr>
-              <a:t> = </a:t>
-            </a:r>
-            <a:r>
-              <a:rPr lang="en-US" sz="2400" dirty="0" err="1">
-                <a:latin typeface="Courier New" panose="02070309020205020404" pitchFamily="49" charset="0"/>
-                <a:cs typeface="Courier New" panose="02070309020205020404" pitchFamily="49" charset="0"/>
-              </a:rPr>
-              <a:t>np.sum</a:t>
-            </a:r>
-            <a:r>
-              <a:rPr lang="en-US" sz="2400" dirty="0">
-                <a:latin typeface="Courier New" panose="02070309020205020404" pitchFamily="49" charset="0"/>
-                <a:cs typeface="Courier New" panose="02070309020205020404" pitchFamily="49" charset="0"/>
-              </a:rPr>
               <a:t>((y - (b + w * X)) ** 2)</a:t>
             </a:r>
           </a:p>
@@ -11344,7 +11346,7 @@
                 <a:latin typeface="Courier New" panose="02070309020205020404" pitchFamily="49" charset="0"/>
                 <a:cs typeface="Courier New" panose="02070309020205020404" pitchFamily="49" charset="0"/>
               </a:rPr>
-              <a:t>Residual sum of squares for b=5, w=0.5: 40.65</a:t>
+              <a:t>Loss for b=5, w=0.5: 40.65</a:t>
             </a:r>
           </a:p>
         </p:txBody>
@@ -11658,8 +11660,8 @@
           </a:p>
         </p:txBody>
       </p:sp>
-      <mc:AlternateContent xmlns:mc="http://schemas.openxmlformats.org/markup-compatibility/2006" xmlns:a14="http://schemas.microsoft.com/office/drawing/2010/main">
-        <mc:Choice Requires="a14">
+      <mc:AlternateContent xmlns:mc="http://schemas.openxmlformats.org/markup-compatibility/2006">
+        <mc:Choice xmlns:a14="http://schemas.microsoft.com/office/drawing/2010/main" Requires="a14">
           <p:sp>
             <p:nvSpPr>
               <p:cNvPr id="5" name="Content Placeholder 4">
@@ -11713,7 +11715,15 @@
                 </a14:m>
                 <a:r>
                   <a:rPr lang="en-US" dirty="0"/>
-                  <a:t> will be found when we minimize the residual sum of squares</a:t>
+                  <a:t> will be found when we </a:t>
+                </a:r>
+                <a:r>
+                  <a:rPr lang="en-US" dirty="0" err="1"/>
+                  <a:t>minimise</a:t>
+                </a:r>
+                <a:r>
+                  <a:rPr lang="en-US" dirty="0"/>
+                  <a:t> the residual sum of squares</a:t>
                 </a:r>
               </a:p>
               <a:p>
@@ -12081,13 +12091,21 @@
                 </a14:m>
                 <a:r>
                   <a:rPr lang="en-US" dirty="0"/>
-                  <a:t> that minimize the values of RMSE (they’ll be the same)</a:t>
+                  <a:t> that </a:t>
+                </a:r>
+                <a:r>
+                  <a:rPr lang="en-US" dirty="0" err="1"/>
+                  <a:t>minimise</a:t>
+                </a:r>
+                <a:r>
+                  <a:rPr lang="en-US" dirty="0"/>
+                  <a:t> the values of RMSE (they’ll be the same)</a:t>
                 </a:r>
               </a:p>
             </p:txBody>
           </p:sp>
         </mc:Choice>
-        <mc:Fallback xmlns="">
+        <mc:Fallback>
           <p:sp>
             <p:nvSpPr>
               <p:cNvPr id="5" name="Content Placeholder 4">
@@ -12420,8 +12438,8 @@
           </a:p>
         </p:txBody>
       </p:sp>
-      <mc:AlternateContent xmlns:mc="http://schemas.openxmlformats.org/markup-compatibility/2006" xmlns:a14="http://schemas.microsoft.com/office/drawing/2010/main">
-        <mc:Choice Requires="a14">
+      <mc:AlternateContent xmlns:mc="http://schemas.openxmlformats.org/markup-compatibility/2006">
+        <mc:Choice xmlns:a14="http://schemas.microsoft.com/office/drawing/2010/main" Requires="a14">
           <p:sp>
             <p:nvSpPr>
               <p:cNvPr id="3" name="Content Placeholder 2">
@@ -12455,7 +12473,23 @@
                       <a:srgbClr val="00427A"/>
                     </a:solidFill>
                   </a:rPr>
-                  <a:t>Iterative algorithm to minimize the loss function</a:t>
+                  <a:t>Iterative algorithm to </a:t>
+                </a:r>
+                <a:r>
+                  <a:rPr lang="en-US" sz="2800" dirty="0" err="1">
+                    <a:solidFill>
+                      <a:srgbClr val="00427A"/>
+                    </a:solidFill>
+                  </a:rPr>
+                  <a:t>minimise</a:t>
+                </a:r>
+                <a:r>
+                  <a:rPr lang="en-US" sz="2800" dirty="0">
+                    <a:solidFill>
+                      <a:srgbClr val="00427A"/>
+                    </a:solidFill>
+                  </a:rPr>
+                  <a:t> the loss function</a:t>
                 </a:r>
               </a:p>
               <a:p>
@@ -12803,7 +12837,7 @@
             </p:txBody>
           </p:sp>
         </mc:Choice>
-        <mc:Fallback xmlns="">
+        <mc:Fallback>
           <p:sp>
             <p:nvSpPr>
               <p:cNvPr id="3" name="Content Placeholder 2">

</xml_diff>